<commit_message>
Final Project instructions updated
</commit_message>
<xml_diff>
--- a/Z - Final Project/Small Project_intro.pptx
+++ b/Z - Final Project/Small Project_intro.pptx
@@ -1,30 +1,30 @@
 
 <file path=ppt/presentation.xml><?xml version="1.0" encoding="utf-8"?>
-<p:presentation xmlns:a="http://schemas.openxmlformats.org/drawingml/2006/main" xmlns:r="http://schemas.openxmlformats.org/officeDocument/2006/relationships" xmlns:mc="http://schemas.openxmlformats.org/markup-compatibility/2006" xmlns:mv="urn:schemas-microsoft-com:mac:vml" xmlns:p="http://schemas.openxmlformats.org/presentationml/2006/main" xmlns:c="http://schemas.openxmlformats.org/drawingml/2006/chart" xmlns:dgm="http://schemas.openxmlformats.org/drawingml/2006/diagram" xmlns:o="urn:schemas-microsoft-com:office:office" xmlns:v="urn:schemas-microsoft-com:vml" xmlns:pvml="urn:schemas-microsoft-com:office:powerpoint" xmlns:com="http://schemas.openxmlformats.org/drawingml/2006/compatibility" xmlns:p14="http://schemas.microsoft.com/office/powerpoint/2010/main" xmlns:p15="http://schemas.microsoft.com/office/powerpoint/2012/main" xmlns:ahyp="http://schemas.microsoft.com/office/drawing/2018/hyperlinkcolor" autoCompressPictures="0" embedTrueTypeFonts="1" strictFirstAndLastChars="0" saveSubsetFonts="1">
+<p:presentation xmlns:a="http://schemas.openxmlformats.org/drawingml/2006/main" xmlns:r="http://schemas.openxmlformats.org/officeDocument/2006/relationships" xmlns:p="http://schemas.openxmlformats.org/presentationml/2006/main" strictFirstAndLastChars="0" embedTrueTypeFonts="1" saveSubsetFonts="1" autoCompressPictures="0">
   <p:sldMasterIdLst>
-    <p:sldMasterId id="2147483659" r:id="rId4"/>
+    <p:sldMasterId id="2147483659" r:id="rId1"/>
   </p:sldMasterIdLst>
   <p:notesMasterIdLst>
     <p:notesMasterId r:id="rId5"/>
   </p:notesMasterIdLst>
   <p:sldIdLst>
-    <p:sldId id="256" r:id="rId6"/>
-    <p:sldId id="257" r:id="rId7"/>
-    <p:sldId id="258" r:id="rId8"/>
+    <p:sldId id="256" r:id="rId2"/>
+    <p:sldId id="257" r:id="rId3"/>
+    <p:sldId id="258" r:id="rId4"/>
   </p:sldIdLst>
-  <p:sldSz cy="5143500" cx="9144000"/>
+  <p:sldSz cx="9144000" cy="5143500" type="screen16x9"/>
   <p:notesSz cx="6858000" cy="9144000"/>
   <p:embeddedFontLst>
     <p:embeddedFont>
-      <p:font typeface="Proxima Nova"/>
-      <p:regular r:id="rId9"/>
-      <p:bold r:id="rId10"/>
-      <p:italic r:id="rId11"/>
-      <p:boldItalic r:id="rId12"/>
+      <p:font typeface="Proxima Nova" panose="020B0604020202020204" charset="0"/>
+      <p:regular r:id="rId6"/>
+      <p:bold r:id="rId7"/>
+      <p:italic r:id="rId8"/>
+      <p:boldItalic r:id="rId9"/>
     </p:embeddedFont>
   </p:embeddedFontLst>
   <p:defaultTextStyle>
-    <a:defPPr lvl="0" marR="0" rtl="0" algn="l">
+    <a:defPPr marR="0" lvl="0" algn="l" rtl="0">
       <a:lnSpc>
         <a:spcPct val="100000"/>
       </a:lnSpc>
@@ -35,7 +35,7 @@
         <a:spcPts val="0"/>
       </a:spcAft>
     </a:defPPr>
-    <a:lvl1pPr lvl="0" marR="0" rtl="0" algn="l">
+    <a:lvl1pPr marR="0" lvl="0" algn="l" rtl="0">
       <a:lnSpc>
         <a:spcPct val="100000"/>
       </a:lnSpc>
@@ -49,7 +49,7 @@
         <a:srgbClr val="000000"/>
       </a:buClr>
       <a:buFont typeface="Arial"/>
-      <a:defRPr b="0" i="0" sz="1400" u="none" cap="none" strike="noStrike">
+      <a:defRPr sz="1400" b="0" i="0" u="none" strike="noStrike" cap="none">
         <a:solidFill>
           <a:srgbClr val="000000"/>
         </a:solidFill>
@@ -59,7 +59,7 @@
         <a:sym typeface="Arial"/>
       </a:defRPr>
     </a:lvl1pPr>
-    <a:lvl2pPr lvl="1" marR="0" rtl="0" algn="l">
+    <a:lvl2pPr marR="0" lvl="1" algn="l" rtl="0">
       <a:lnSpc>
         <a:spcPct val="100000"/>
       </a:lnSpc>
@@ -73,7 +73,7 @@
         <a:srgbClr val="000000"/>
       </a:buClr>
       <a:buFont typeface="Arial"/>
-      <a:defRPr b="0" i="0" sz="1400" u="none" cap="none" strike="noStrike">
+      <a:defRPr sz="1400" b="0" i="0" u="none" strike="noStrike" cap="none">
         <a:solidFill>
           <a:srgbClr val="000000"/>
         </a:solidFill>
@@ -83,7 +83,7 @@
         <a:sym typeface="Arial"/>
       </a:defRPr>
     </a:lvl2pPr>
-    <a:lvl3pPr lvl="2" marR="0" rtl="0" algn="l">
+    <a:lvl3pPr marR="0" lvl="2" algn="l" rtl="0">
       <a:lnSpc>
         <a:spcPct val="100000"/>
       </a:lnSpc>
@@ -97,7 +97,7 @@
         <a:srgbClr val="000000"/>
       </a:buClr>
       <a:buFont typeface="Arial"/>
-      <a:defRPr b="0" i="0" sz="1400" u="none" cap="none" strike="noStrike">
+      <a:defRPr sz="1400" b="0" i="0" u="none" strike="noStrike" cap="none">
         <a:solidFill>
           <a:srgbClr val="000000"/>
         </a:solidFill>
@@ -107,7 +107,7 @@
         <a:sym typeface="Arial"/>
       </a:defRPr>
     </a:lvl3pPr>
-    <a:lvl4pPr lvl="3" marR="0" rtl="0" algn="l">
+    <a:lvl4pPr marR="0" lvl="3" algn="l" rtl="0">
       <a:lnSpc>
         <a:spcPct val="100000"/>
       </a:lnSpc>
@@ -121,7 +121,7 @@
         <a:srgbClr val="000000"/>
       </a:buClr>
       <a:buFont typeface="Arial"/>
-      <a:defRPr b="0" i="0" sz="1400" u="none" cap="none" strike="noStrike">
+      <a:defRPr sz="1400" b="0" i="0" u="none" strike="noStrike" cap="none">
         <a:solidFill>
           <a:srgbClr val="000000"/>
         </a:solidFill>
@@ -131,7 +131,7 @@
         <a:sym typeface="Arial"/>
       </a:defRPr>
     </a:lvl4pPr>
-    <a:lvl5pPr lvl="4" marR="0" rtl="0" algn="l">
+    <a:lvl5pPr marR="0" lvl="4" algn="l" rtl="0">
       <a:lnSpc>
         <a:spcPct val="100000"/>
       </a:lnSpc>
@@ -145,7 +145,7 @@
         <a:srgbClr val="000000"/>
       </a:buClr>
       <a:buFont typeface="Arial"/>
-      <a:defRPr b="0" i="0" sz="1400" u="none" cap="none" strike="noStrike">
+      <a:defRPr sz="1400" b="0" i="0" u="none" strike="noStrike" cap="none">
         <a:solidFill>
           <a:srgbClr val="000000"/>
         </a:solidFill>
@@ -155,7 +155,7 @@
         <a:sym typeface="Arial"/>
       </a:defRPr>
     </a:lvl5pPr>
-    <a:lvl6pPr lvl="5" marR="0" rtl="0" algn="l">
+    <a:lvl6pPr marR="0" lvl="5" algn="l" rtl="0">
       <a:lnSpc>
         <a:spcPct val="100000"/>
       </a:lnSpc>
@@ -169,7 +169,7 @@
         <a:srgbClr val="000000"/>
       </a:buClr>
       <a:buFont typeface="Arial"/>
-      <a:defRPr b="0" i="0" sz="1400" u="none" cap="none" strike="noStrike">
+      <a:defRPr sz="1400" b="0" i="0" u="none" strike="noStrike" cap="none">
         <a:solidFill>
           <a:srgbClr val="000000"/>
         </a:solidFill>
@@ -179,7 +179,7 @@
         <a:sym typeface="Arial"/>
       </a:defRPr>
     </a:lvl6pPr>
-    <a:lvl7pPr lvl="6" marR="0" rtl="0" algn="l">
+    <a:lvl7pPr marR="0" lvl="6" algn="l" rtl="0">
       <a:lnSpc>
         <a:spcPct val="100000"/>
       </a:lnSpc>
@@ -193,7 +193,7 @@
         <a:srgbClr val="000000"/>
       </a:buClr>
       <a:buFont typeface="Arial"/>
-      <a:defRPr b="0" i="0" sz="1400" u="none" cap="none" strike="noStrike">
+      <a:defRPr sz="1400" b="0" i="0" u="none" strike="noStrike" cap="none">
         <a:solidFill>
           <a:srgbClr val="000000"/>
         </a:solidFill>
@@ -203,7 +203,7 @@
         <a:sym typeface="Arial"/>
       </a:defRPr>
     </a:lvl7pPr>
-    <a:lvl8pPr lvl="7" marR="0" rtl="0" algn="l">
+    <a:lvl8pPr marR="0" lvl="7" algn="l" rtl="0">
       <a:lnSpc>
         <a:spcPct val="100000"/>
       </a:lnSpc>
@@ -217,7 +217,7 @@
         <a:srgbClr val="000000"/>
       </a:buClr>
       <a:buFont typeface="Arial"/>
-      <a:defRPr b="0" i="0" sz="1400" u="none" cap="none" strike="noStrike">
+      <a:defRPr sz="1400" b="0" i="0" u="none" strike="noStrike" cap="none">
         <a:solidFill>
           <a:srgbClr val="000000"/>
         </a:solidFill>
@@ -227,7 +227,7 @@
         <a:sym typeface="Arial"/>
       </a:defRPr>
     </a:lvl8pPr>
-    <a:lvl9pPr lvl="8" marR="0" rtl="0" algn="l">
+    <a:lvl9pPr marR="0" lvl="8" algn="l" rtl="0">
       <a:lnSpc>
         <a:spcPct val="100000"/>
       </a:lnSpc>
@@ -241,7 +241,7 @@
         <a:srgbClr val="000000"/>
       </a:buClr>
       <a:buFont typeface="Arial"/>
-      <a:defRPr b="0" i="0" sz="1400" u="none" cap="none" strike="noStrike">
+      <a:defRPr sz="1400" b="0" i="0" u="none" strike="noStrike" cap="none">
         <a:solidFill>
           <a:srgbClr val="000000"/>
         </a:solidFill>
@@ -254,7 +254,7 @@
   </p:defaultTextStyle>
   <p:extLst>
     <p:ext uri="{EFAFB233-063F-42B5-8137-9DF3F51BA10A}">
-      <p15:sldGuideLst>
+      <p15:sldGuideLst xmlns:p15="http://schemas.microsoft.com/office/powerpoint/2012/main">
         <p15:guide id="1" orient="horz" pos="1620">
           <p15:clr>
             <a:srgbClr val="747775"/>
@@ -272,11 +272,16 @@
 </file>
 
 <file path=ppt/notesMasters/notesMaster1.xml><?xml version="1.0" encoding="utf-8"?>
-<p:notesMaster xmlns:a="http://schemas.openxmlformats.org/drawingml/2006/main" xmlns:r="http://schemas.openxmlformats.org/officeDocument/2006/relationships" xmlns:mc="http://schemas.openxmlformats.org/markup-compatibility/2006" xmlns:mv="urn:schemas-microsoft-com:mac:vml" xmlns:p="http://schemas.openxmlformats.org/presentationml/2006/main" xmlns:c="http://schemas.openxmlformats.org/drawingml/2006/chart" xmlns:dgm="http://schemas.openxmlformats.org/drawingml/2006/diagram" xmlns:o="urn:schemas-microsoft-com:office:office" xmlns:v="urn:schemas-microsoft-com:vml" xmlns:pvml="urn:schemas-microsoft-com:office:powerpoint" xmlns:com="http://schemas.openxmlformats.org/drawingml/2006/compatibility" xmlns:p14="http://schemas.microsoft.com/office/powerpoint/2010/main" xmlns:p15="http://schemas.microsoft.com/office/powerpoint/2012/main" xmlns:ahyp="http://schemas.microsoft.com/office/drawing/2018/hyperlinkcolor">
+<p:notesMaster xmlns:a="http://schemas.openxmlformats.org/drawingml/2006/main" xmlns:r="http://schemas.openxmlformats.org/officeDocument/2006/relationships" xmlns:p="http://schemas.openxmlformats.org/presentationml/2006/main">
   <p:cSld>
+    <p:bg>
+      <p:bgRef idx="1001">
+        <a:schemeClr val="bg1"/>
+      </p:bgRef>
+    </p:bg>
     <p:spTree>
       <p:nvGrpSpPr>
-        <p:cNvPr id="2" name="Shape 2"/>
+        <p:cNvPr id="1" name="Shape 2"/>
         <p:cNvGrpSpPr/>
         <p:nvPr/>
       </p:nvGrpSpPr>
@@ -291,9 +296,11 @@
       <p:sp>
         <p:nvSpPr>
           <p:cNvPr id="3" name="Google Shape;3;n"/>
-          <p:cNvSpPr/>
+          <p:cNvSpPr>
+            <a:spLocks noGrp="1" noRot="1" noChangeAspect="1"/>
+          </p:cNvSpPr>
           <p:nvPr>
-            <p:ph idx="2" type="sldImg"/>
+            <p:ph type="sldImg" idx="2"/>
           </p:nvPr>
         </p:nvSpPr>
         <p:spPr>
@@ -302,9 +309,13 @@
             <a:ext cx="6096075" cy="3429000"/>
           </a:xfrm>
           <a:custGeom>
-            <a:rect b="b" l="l" r="r" t="t"/>
+            <a:avLst/>
+            <a:gdLst/>
+            <a:ahLst/>
+            <a:cxnLst/>
+            <a:rect l="l" t="t" r="r" b="b"/>
             <a:pathLst>
-              <a:path extrusionOk="0" h="120000" w="120000">
+              <a:path w="120000" h="120000" extrusionOk="0">
                 <a:moveTo>
                   <a:pt x="0" y="0"/>
                 </a:moveTo>
@@ -322,23 +333,25 @@
             </a:pathLst>
           </a:custGeom>
           <a:noFill/>
-          <a:ln cap="flat" cmpd="sng" w="9525">
+          <a:ln w="9525" cap="flat" cmpd="sng">
             <a:solidFill>
               <a:srgbClr val="000000"/>
             </a:solidFill>
             <a:prstDash val="solid"/>
             <a:round/>
-            <a:headEnd len="sm" w="sm" type="none"/>
-            <a:tailEnd len="sm" w="sm" type="none"/>
+            <a:headEnd type="none" w="sm" len="sm"/>
+            <a:tailEnd type="none" w="sm" len="sm"/>
           </a:ln>
         </p:spPr>
       </p:sp>
       <p:sp>
         <p:nvSpPr>
           <p:cNvPr id="4" name="Google Shape;4;n"/>
-          <p:cNvSpPr txBox="1"/>
+          <p:cNvSpPr txBox="1">
+            <a:spLocks noGrp="1"/>
+          </p:cNvSpPr>
           <p:nvPr>
-            <p:ph idx="1" type="body"/>
+            <p:ph type="body" idx="1"/>
           </p:nvPr>
         </p:nvSpPr>
         <p:spPr>
@@ -355,11 +368,11 @@
           </a:ln>
         </p:spPr>
         <p:txBody>
-          <a:bodyPr anchorCtr="0" anchor="t" bIns="91425" lIns="91425" spcFirstLastPara="1" rIns="91425" wrap="square" tIns="91425">
+          <a:bodyPr spcFirstLastPara="1" wrap="square" lIns="91425" tIns="91425" rIns="91425" bIns="91425" anchor="t" anchorCtr="0">
             <a:noAutofit/>
           </a:bodyPr>
           <a:lstStyle>
-            <a:lvl1pPr indent="-298450" lvl="0" marL="457200">
+            <a:lvl1pPr marL="457200" lvl="0" indent="-298450">
               <a:spcBef>
                 <a:spcPts val="0"/>
               </a:spcBef>
@@ -370,7 +383,7 @@
               <a:buChar char="●"/>
               <a:defRPr sz="1100"/>
             </a:lvl1pPr>
-            <a:lvl2pPr indent="-298450" lvl="1" marL="914400">
+            <a:lvl2pPr marL="914400" lvl="1" indent="-298450">
               <a:spcBef>
                 <a:spcPts val="0"/>
               </a:spcBef>
@@ -381,7 +394,7 @@
               <a:buChar char="○"/>
               <a:defRPr sz="1100"/>
             </a:lvl2pPr>
-            <a:lvl3pPr indent="-298450" lvl="2" marL="1371600">
+            <a:lvl3pPr marL="1371600" lvl="2" indent="-298450">
               <a:spcBef>
                 <a:spcPts val="0"/>
               </a:spcBef>
@@ -392,7 +405,7 @@
               <a:buChar char="■"/>
               <a:defRPr sz="1100"/>
             </a:lvl3pPr>
-            <a:lvl4pPr indent="-298450" lvl="3" marL="1828800">
+            <a:lvl4pPr marL="1828800" lvl="3" indent="-298450">
               <a:spcBef>
                 <a:spcPts val="0"/>
               </a:spcBef>
@@ -403,7 +416,7 @@
               <a:buChar char="●"/>
               <a:defRPr sz="1100"/>
             </a:lvl4pPr>
-            <a:lvl5pPr indent="-298450" lvl="4" marL="2286000">
+            <a:lvl5pPr marL="2286000" lvl="4" indent="-298450">
               <a:spcBef>
                 <a:spcPts val="0"/>
               </a:spcBef>
@@ -414,7 +427,7 @@
               <a:buChar char="○"/>
               <a:defRPr sz="1100"/>
             </a:lvl5pPr>
-            <a:lvl6pPr indent="-298450" lvl="5" marL="2743200">
+            <a:lvl6pPr marL="2743200" lvl="5" indent="-298450">
               <a:spcBef>
                 <a:spcPts val="0"/>
               </a:spcBef>
@@ -425,7 +438,7 @@
               <a:buChar char="■"/>
               <a:defRPr sz="1100"/>
             </a:lvl6pPr>
-            <a:lvl7pPr indent="-298450" lvl="6" marL="3200400">
+            <a:lvl7pPr marL="3200400" lvl="6" indent="-298450">
               <a:spcBef>
                 <a:spcPts val="0"/>
               </a:spcBef>
@@ -436,7 +449,7 @@
               <a:buChar char="●"/>
               <a:defRPr sz="1100"/>
             </a:lvl7pPr>
-            <a:lvl8pPr indent="-298450" lvl="7" marL="3657600">
+            <a:lvl8pPr marL="3657600" lvl="7" indent="-298450">
               <a:spcBef>
                 <a:spcPts val="0"/>
               </a:spcBef>
@@ -447,7 +460,7 @@
               <a:buChar char="○"/>
               <a:defRPr sz="1100"/>
             </a:lvl8pPr>
-            <a:lvl9pPr indent="-298450" lvl="8" marL="4114800">
+            <a:lvl9pPr marL="4114800" lvl="8" indent="-298450">
               <a:spcBef>
                 <a:spcPts val="0"/>
               </a:spcBef>
@@ -459,14 +472,16 @@
               <a:defRPr sz="1100"/>
             </a:lvl9pPr>
           </a:lstStyle>
-          <a:p/>
+          <a:p>
+            <a:endParaRPr/>
+          </a:p>
         </p:txBody>
       </p:sp>
     </p:spTree>
   </p:cSld>
-  <p:clrMap accent1="accent1" accent2="accent2" accent3="accent3" accent4="accent4" accent5="accent5" accent6="accent6" bg1="lt1" bg2="dk2" tx1="dk1" tx2="lt2" folHlink="folHlink" hlink="hlink"/>
+  <p:clrMap bg1="lt1" tx1="dk1" bg2="dk2" tx2="lt2" accent1="accent1" accent2="accent2" accent3="accent3" accent4="accent4" accent5="accent5" accent6="accent6" hlink="hlink" folHlink="folHlink"/>
   <p:notesStyle>
-    <a:defPPr lvl="0" marR="0" rtl="0" algn="l">
+    <a:defPPr marR="0" lvl="0" algn="l" rtl="0">
       <a:lnSpc>
         <a:spcPct val="100000"/>
       </a:lnSpc>
@@ -477,7 +492,7 @@
         <a:spcPts val="0"/>
       </a:spcAft>
     </a:defPPr>
-    <a:lvl1pPr lvl="0" marR="0" rtl="0" algn="l">
+    <a:lvl1pPr marR="0" lvl="0" algn="l" rtl="0">
       <a:lnSpc>
         <a:spcPct val="100000"/>
       </a:lnSpc>
@@ -491,7 +506,7 @@
         <a:srgbClr val="000000"/>
       </a:buClr>
       <a:buFont typeface="Arial"/>
-      <a:defRPr b="0" i="0" sz="1400" u="none" cap="none" strike="noStrike">
+      <a:defRPr sz="1400" b="0" i="0" u="none" strike="noStrike" cap="none">
         <a:solidFill>
           <a:srgbClr val="000000"/>
         </a:solidFill>
@@ -501,7 +516,7 @@
         <a:sym typeface="Arial"/>
       </a:defRPr>
     </a:lvl1pPr>
-    <a:lvl2pPr lvl="1" marR="0" rtl="0" algn="l">
+    <a:lvl2pPr marR="0" lvl="1" algn="l" rtl="0">
       <a:lnSpc>
         <a:spcPct val="100000"/>
       </a:lnSpc>
@@ -515,7 +530,7 @@
         <a:srgbClr val="000000"/>
       </a:buClr>
       <a:buFont typeface="Arial"/>
-      <a:defRPr b="0" i="0" sz="1400" u="none" cap="none" strike="noStrike">
+      <a:defRPr sz="1400" b="0" i="0" u="none" strike="noStrike" cap="none">
         <a:solidFill>
           <a:srgbClr val="000000"/>
         </a:solidFill>
@@ -525,7 +540,7 @@
         <a:sym typeface="Arial"/>
       </a:defRPr>
     </a:lvl2pPr>
-    <a:lvl3pPr lvl="2" marR="0" rtl="0" algn="l">
+    <a:lvl3pPr marR="0" lvl="2" algn="l" rtl="0">
       <a:lnSpc>
         <a:spcPct val="100000"/>
       </a:lnSpc>
@@ -539,7 +554,7 @@
         <a:srgbClr val="000000"/>
       </a:buClr>
       <a:buFont typeface="Arial"/>
-      <a:defRPr b="0" i="0" sz="1400" u="none" cap="none" strike="noStrike">
+      <a:defRPr sz="1400" b="0" i="0" u="none" strike="noStrike" cap="none">
         <a:solidFill>
           <a:srgbClr val="000000"/>
         </a:solidFill>
@@ -549,7 +564,7 @@
         <a:sym typeface="Arial"/>
       </a:defRPr>
     </a:lvl3pPr>
-    <a:lvl4pPr lvl="3" marR="0" rtl="0" algn="l">
+    <a:lvl4pPr marR="0" lvl="3" algn="l" rtl="0">
       <a:lnSpc>
         <a:spcPct val="100000"/>
       </a:lnSpc>
@@ -563,7 +578,7 @@
         <a:srgbClr val="000000"/>
       </a:buClr>
       <a:buFont typeface="Arial"/>
-      <a:defRPr b="0" i="0" sz="1400" u="none" cap="none" strike="noStrike">
+      <a:defRPr sz="1400" b="0" i="0" u="none" strike="noStrike" cap="none">
         <a:solidFill>
           <a:srgbClr val="000000"/>
         </a:solidFill>
@@ -573,7 +588,7 @@
         <a:sym typeface="Arial"/>
       </a:defRPr>
     </a:lvl4pPr>
-    <a:lvl5pPr lvl="4" marR="0" rtl="0" algn="l">
+    <a:lvl5pPr marR="0" lvl="4" algn="l" rtl="0">
       <a:lnSpc>
         <a:spcPct val="100000"/>
       </a:lnSpc>
@@ -587,7 +602,7 @@
         <a:srgbClr val="000000"/>
       </a:buClr>
       <a:buFont typeface="Arial"/>
-      <a:defRPr b="0" i="0" sz="1400" u="none" cap="none" strike="noStrike">
+      <a:defRPr sz="1400" b="0" i="0" u="none" strike="noStrike" cap="none">
         <a:solidFill>
           <a:srgbClr val="000000"/>
         </a:solidFill>
@@ -597,7 +612,7 @@
         <a:sym typeface="Arial"/>
       </a:defRPr>
     </a:lvl5pPr>
-    <a:lvl6pPr lvl="5" marR="0" rtl="0" algn="l">
+    <a:lvl6pPr marR="0" lvl="5" algn="l" rtl="0">
       <a:lnSpc>
         <a:spcPct val="100000"/>
       </a:lnSpc>
@@ -611,7 +626,7 @@
         <a:srgbClr val="000000"/>
       </a:buClr>
       <a:buFont typeface="Arial"/>
-      <a:defRPr b="0" i="0" sz="1400" u="none" cap="none" strike="noStrike">
+      <a:defRPr sz="1400" b="0" i="0" u="none" strike="noStrike" cap="none">
         <a:solidFill>
           <a:srgbClr val="000000"/>
         </a:solidFill>
@@ -621,7 +636,7 @@
         <a:sym typeface="Arial"/>
       </a:defRPr>
     </a:lvl6pPr>
-    <a:lvl7pPr lvl="6" marR="0" rtl="0" algn="l">
+    <a:lvl7pPr marR="0" lvl="6" algn="l" rtl="0">
       <a:lnSpc>
         <a:spcPct val="100000"/>
       </a:lnSpc>
@@ -635,7 +650,7 @@
         <a:srgbClr val="000000"/>
       </a:buClr>
       <a:buFont typeface="Arial"/>
-      <a:defRPr b="0" i="0" sz="1400" u="none" cap="none" strike="noStrike">
+      <a:defRPr sz="1400" b="0" i="0" u="none" strike="noStrike" cap="none">
         <a:solidFill>
           <a:srgbClr val="000000"/>
         </a:solidFill>
@@ -645,7 +660,7 @@
         <a:sym typeface="Arial"/>
       </a:defRPr>
     </a:lvl7pPr>
-    <a:lvl8pPr lvl="7" marR="0" rtl="0" algn="l">
+    <a:lvl8pPr marR="0" lvl="7" algn="l" rtl="0">
       <a:lnSpc>
         <a:spcPct val="100000"/>
       </a:lnSpc>
@@ -659,7 +674,7 @@
         <a:srgbClr val="000000"/>
       </a:buClr>
       <a:buFont typeface="Arial"/>
-      <a:defRPr b="0" i="0" sz="1400" u="none" cap="none" strike="noStrike">
+      <a:defRPr sz="1400" b="0" i="0" u="none" strike="noStrike" cap="none">
         <a:solidFill>
           <a:srgbClr val="000000"/>
         </a:solidFill>
@@ -669,7 +684,7 @@
         <a:sym typeface="Arial"/>
       </a:defRPr>
     </a:lvl8pPr>
-    <a:lvl9pPr lvl="8" marR="0" rtl="0" algn="l">
+    <a:lvl9pPr marR="0" lvl="8" algn="l" rtl="0">
       <a:lnSpc>
         <a:spcPct val="100000"/>
       </a:lnSpc>
@@ -683,7 +698,7 @@
         <a:srgbClr val="000000"/>
       </a:buClr>
       <a:buFont typeface="Arial"/>
-      <a:defRPr b="0" i="0" sz="1400" u="none" cap="none" strike="noStrike">
+      <a:defRPr sz="1400" b="0" i="0" u="none" strike="noStrike" cap="none">
         <a:solidFill>
           <a:srgbClr val="000000"/>
         </a:solidFill>
@@ -698,11 +713,11 @@
 </file>
 
 <file path=ppt/notesSlides/notesSlide1.xml><?xml version="1.0" encoding="utf-8"?>
-<p:notes xmlns:a="http://schemas.openxmlformats.org/drawingml/2006/main" xmlns:r="http://schemas.openxmlformats.org/officeDocument/2006/relationships" xmlns:mc="http://schemas.openxmlformats.org/markup-compatibility/2006" xmlns:mv="urn:schemas-microsoft-com:mac:vml" xmlns:p="http://schemas.openxmlformats.org/presentationml/2006/main" xmlns:c="http://schemas.openxmlformats.org/drawingml/2006/chart" xmlns:dgm="http://schemas.openxmlformats.org/drawingml/2006/diagram" xmlns:o="urn:schemas-microsoft-com:office:office" xmlns:v="urn:schemas-microsoft-com:vml" xmlns:pvml="urn:schemas-microsoft-com:office:powerpoint" xmlns:com="http://schemas.openxmlformats.org/drawingml/2006/compatibility" xmlns:p14="http://schemas.microsoft.com/office/powerpoint/2010/main" xmlns:p15="http://schemas.microsoft.com/office/powerpoint/2012/main" xmlns:ahyp="http://schemas.microsoft.com/office/drawing/2018/hyperlinkcolor" showMasterPhAnim="0" showMasterSp="0">
+<p:notes xmlns:a="http://schemas.openxmlformats.org/drawingml/2006/main" xmlns:r="http://schemas.openxmlformats.org/officeDocument/2006/relationships" xmlns:p="http://schemas.openxmlformats.org/presentationml/2006/main" showMasterSp="0" showMasterPhAnim="0">
   <p:cSld>
     <p:spTree>
       <p:nvGrpSpPr>
-        <p:cNvPr id="55" name="Shape 55"/>
+        <p:cNvPr id="1" name="Shape 55"/>
         <p:cNvGrpSpPr/>
         <p:nvPr/>
       </p:nvGrpSpPr>
@@ -717,20 +732,26 @@
       <p:sp>
         <p:nvSpPr>
           <p:cNvPr id="56" name="Google Shape;56;p:notes"/>
-          <p:cNvSpPr/>
+          <p:cNvSpPr>
+            <a:spLocks noGrp="1" noRot="1" noChangeAspect="1"/>
+          </p:cNvSpPr>
           <p:nvPr>
-            <p:ph idx="2" type="sldImg"/>
+            <p:ph type="sldImg" idx="2"/>
           </p:nvPr>
         </p:nvSpPr>
         <p:spPr>
           <a:xfrm>
-            <a:off x="381300" y="685800"/>
-            <a:ext cx="6096075" cy="3429000"/>
+            <a:off x="381000" y="685800"/>
+            <a:ext cx="6096000" cy="3429000"/>
           </a:xfrm>
           <a:custGeom>
-            <a:rect b="b" l="l" r="r" t="t"/>
+            <a:avLst/>
+            <a:gdLst/>
+            <a:ahLst/>
+            <a:cxnLst/>
+            <a:rect l="l" t="t" r="r" b="b"/>
             <a:pathLst>
-              <a:path extrusionOk="0" h="120000" w="120000">
+              <a:path w="120000" h="120000" extrusionOk="0">
                 <a:moveTo>
                   <a:pt x="0" y="0"/>
                 </a:moveTo>
@@ -752,9 +773,11 @@
       <p:sp>
         <p:nvSpPr>
           <p:cNvPr id="57" name="Google Shape;57;p:notes"/>
-          <p:cNvSpPr txBox="1"/>
+          <p:cNvSpPr txBox="1">
+            <a:spLocks noGrp="1"/>
+          </p:cNvSpPr>
           <p:nvPr>
-            <p:ph idx="1" type="body"/>
+            <p:ph type="body" idx="1"/>
           </p:nvPr>
         </p:nvSpPr>
         <p:spPr>
@@ -767,12 +790,12 @@
           </a:prstGeom>
         </p:spPr>
         <p:txBody>
-          <a:bodyPr anchorCtr="0" anchor="t" bIns="91425" lIns="91425" spcFirstLastPara="1" rIns="91425" wrap="square" tIns="91425">
+          <a:bodyPr spcFirstLastPara="1" wrap="square" lIns="91425" tIns="91425" rIns="91425" bIns="91425" anchor="t" anchorCtr="0">
             <a:noAutofit/>
           </a:bodyPr>
           <a:lstStyle/>
           <a:p>
-            <a:pPr indent="0" lvl="0" marL="0" rtl="0" algn="l">
+            <a:pPr marL="0" lvl="0" indent="0" algn="l" rtl="0">
               <a:spcBef>
                 <a:spcPts val="0"/>
               </a:spcBef>
@@ -781,9 +804,6 @@
               </a:spcAft>
               <a:buNone/>
             </a:pPr>
-            <a:r>
-              <a:t/>
-            </a:r>
             <a:endParaRPr/>
           </a:p>
         </p:txBody>
@@ -797,11 +817,11 @@
 </file>
 
 <file path=ppt/notesSlides/notesSlide2.xml><?xml version="1.0" encoding="utf-8"?>
-<p:notes xmlns:a="http://schemas.openxmlformats.org/drawingml/2006/main" xmlns:r="http://schemas.openxmlformats.org/officeDocument/2006/relationships" xmlns:mc="http://schemas.openxmlformats.org/markup-compatibility/2006" xmlns:mv="urn:schemas-microsoft-com:mac:vml" xmlns:p="http://schemas.openxmlformats.org/presentationml/2006/main" xmlns:c="http://schemas.openxmlformats.org/drawingml/2006/chart" xmlns:dgm="http://schemas.openxmlformats.org/drawingml/2006/diagram" xmlns:o="urn:schemas-microsoft-com:office:office" xmlns:v="urn:schemas-microsoft-com:vml" xmlns:pvml="urn:schemas-microsoft-com:office:powerpoint" xmlns:com="http://schemas.openxmlformats.org/drawingml/2006/compatibility" xmlns:p14="http://schemas.microsoft.com/office/powerpoint/2010/main" xmlns:p15="http://schemas.microsoft.com/office/powerpoint/2012/main" xmlns:ahyp="http://schemas.microsoft.com/office/drawing/2018/hyperlinkcolor" showMasterPhAnim="0" showMasterSp="0">
+<p:notes xmlns:a="http://schemas.openxmlformats.org/drawingml/2006/main" xmlns:r="http://schemas.openxmlformats.org/officeDocument/2006/relationships" xmlns:p="http://schemas.openxmlformats.org/presentationml/2006/main" showMasterSp="0" showMasterPhAnim="0">
   <p:cSld>
     <p:spTree>
       <p:nvGrpSpPr>
-        <p:cNvPr id="61" name="Shape 61"/>
+        <p:cNvPr id="1" name="Shape 61"/>
         <p:cNvGrpSpPr/>
         <p:nvPr/>
       </p:nvGrpSpPr>
@@ -816,20 +836,26 @@
       <p:sp>
         <p:nvSpPr>
           <p:cNvPr id="62" name="Google Shape;62;g3737ac35431_0_50:notes"/>
-          <p:cNvSpPr/>
+          <p:cNvSpPr>
+            <a:spLocks noGrp="1" noRot="1" noChangeAspect="1"/>
+          </p:cNvSpPr>
           <p:nvPr>
-            <p:ph idx="2" type="sldImg"/>
+            <p:ph type="sldImg" idx="2"/>
           </p:nvPr>
         </p:nvSpPr>
         <p:spPr>
           <a:xfrm>
-            <a:off x="381300" y="685800"/>
+            <a:off x="381000" y="685800"/>
             <a:ext cx="6096000" cy="3429000"/>
           </a:xfrm>
           <a:custGeom>
-            <a:rect b="b" l="l" r="r" t="t"/>
+            <a:avLst/>
+            <a:gdLst/>
+            <a:ahLst/>
+            <a:cxnLst/>
+            <a:rect l="l" t="t" r="r" b="b"/>
             <a:pathLst>
-              <a:path extrusionOk="0" h="120000" w="120000">
+              <a:path w="120000" h="120000" extrusionOk="0">
                 <a:moveTo>
                   <a:pt x="0" y="0"/>
                 </a:moveTo>
@@ -851,9 +877,11 @@
       <p:sp>
         <p:nvSpPr>
           <p:cNvPr id="63" name="Google Shape;63;g3737ac35431_0_50:notes"/>
-          <p:cNvSpPr txBox="1"/>
+          <p:cNvSpPr txBox="1">
+            <a:spLocks noGrp="1"/>
+          </p:cNvSpPr>
           <p:nvPr>
-            <p:ph idx="1" type="body"/>
+            <p:ph type="body" idx="1"/>
           </p:nvPr>
         </p:nvSpPr>
         <p:spPr>
@@ -866,12 +894,12 @@
           </a:prstGeom>
         </p:spPr>
         <p:txBody>
-          <a:bodyPr anchorCtr="0" anchor="t" bIns="91425" lIns="91425" spcFirstLastPara="1" rIns="91425" wrap="square" tIns="91425">
+          <a:bodyPr spcFirstLastPara="1" wrap="square" lIns="91425" tIns="91425" rIns="91425" bIns="91425" anchor="t" anchorCtr="0">
             <a:noAutofit/>
           </a:bodyPr>
           <a:lstStyle/>
           <a:p>
-            <a:pPr indent="0" lvl="0" marL="0" rtl="0" algn="l">
+            <a:pPr marL="0" lvl="0" indent="0" algn="l" rtl="0">
               <a:spcBef>
                 <a:spcPts val="0"/>
               </a:spcBef>
@@ -880,9 +908,6 @@
               </a:spcAft>
               <a:buNone/>
             </a:pPr>
-            <a:r>
-              <a:t/>
-            </a:r>
             <a:endParaRPr/>
           </a:p>
         </p:txBody>
@@ -896,11 +921,11 @@
 </file>
 
 <file path=ppt/notesSlides/notesSlide3.xml><?xml version="1.0" encoding="utf-8"?>
-<p:notes xmlns:a="http://schemas.openxmlformats.org/drawingml/2006/main" xmlns:r="http://schemas.openxmlformats.org/officeDocument/2006/relationships" xmlns:mc="http://schemas.openxmlformats.org/markup-compatibility/2006" xmlns:mv="urn:schemas-microsoft-com:mac:vml" xmlns:p="http://schemas.openxmlformats.org/presentationml/2006/main" xmlns:c="http://schemas.openxmlformats.org/drawingml/2006/chart" xmlns:dgm="http://schemas.openxmlformats.org/drawingml/2006/diagram" xmlns:o="urn:schemas-microsoft-com:office:office" xmlns:v="urn:schemas-microsoft-com:vml" xmlns:pvml="urn:schemas-microsoft-com:office:powerpoint" xmlns:com="http://schemas.openxmlformats.org/drawingml/2006/compatibility" xmlns:p14="http://schemas.microsoft.com/office/powerpoint/2010/main" xmlns:p15="http://schemas.microsoft.com/office/powerpoint/2012/main" xmlns:ahyp="http://schemas.microsoft.com/office/drawing/2018/hyperlinkcolor" showMasterPhAnim="0" showMasterSp="0">
+<p:notes xmlns:a="http://schemas.openxmlformats.org/drawingml/2006/main" xmlns:r="http://schemas.openxmlformats.org/officeDocument/2006/relationships" xmlns:p="http://schemas.openxmlformats.org/presentationml/2006/main" showMasterSp="0" showMasterPhAnim="0">
   <p:cSld>
     <p:spTree>
       <p:nvGrpSpPr>
-        <p:cNvPr id="67" name="Shape 67"/>
+        <p:cNvPr id="1" name="Shape 67"/>
         <p:cNvGrpSpPr/>
         <p:nvPr/>
       </p:nvGrpSpPr>
@@ -915,20 +940,26 @@
       <p:sp>
         <p:nvSpPr>
           <p:cNvPr id="68" name="Google Shape;68;g3737ac35431_0_57:notes"/>
-          <p:cNvSpPr/>
+          <p:cNvSpPr>
+            <a:spLocks noGrp="1" noRot="1" noChangeAspect="1"/>
+          </p:cNvSpPr>
           <p:nvPr>
-            <p:ph idx="2" type="sldImg"/>
+            <p:ph type="sldImg" idx="2"/>
           </p:nvPr>
         </p:nvSpPr>
         <p:spPr>
           <a:xfrm>
-            <a:off x="381300" y="685800"/>
+            <a:off x="381000" y="685800"/>
             <a:ext cx="6096000" cy="3429000"/>
           </a:xfrm>
           <a:custGeom>
-            <a:rect b="b" l="l" r="r" t="t"/>
+            <a:avLst/>
+            <a:gdLst/>
+            <a:ahLst/>
+            <a:cxnLst/>
+            <a:rect l="l" t="t" r="r" b="b"/>
             <a:pathLst>
-              <a:path extrusionOk="0" h="120000" w="120000">
+              <a:path w="120000" h="120000" extrusionOk="0">
                 <a:moveTo>
                   <a:pt x="0" y="0"/>
                 </a:moveTo>
@@ -950,9 +981,11 @@
       <p:sp>
         <p:nvSpPr>
           <p:cNvPr id="69" name="Google Shape;69;g3737ac35431_0_57:notes"/>
-          <p:cNvSpPr txBox="1"/>
+          <p:cNvSpPr txBox="1">
+            <a:spLocks noGrp="1"/>
+          </p:cNvSpPr>
           <p:nvPr>
-            <p:ph idx="1" type="body"/>
+            <p:ph type="body" idx="1"/>
           </p:nvPr>
         </p:nvSpPr>
         <p:spPr>
@@ -965,12 +998,12 @@
           </a:prstGeom>
         </p:spPr>
         <p:txBody>
-          <a:bodyPr anchorCtr="0" anchor="t" bIns="91425" lIns="91425" spcFirstLastPara="1" rIns="91425" wrap="square" tIns="91425">
+          <a:bodyPr spcFirstLastPara="1" wrap="square" lIns="91425" tIns="91425" rIns="91425" bIns="91425" anchor="t" anchorCtr="0">
             <a:noAutofit/>
           </a:bodyPr>
           <a:lstStyle/>
           <a:p>
-            <a:pPr indent="0" lvl="0" marL="0" rtl="0" algn="l">
+            <a:pPr marL="0" lvl="0" indent="0" algn="l" rtl="0">
               <a:spcBef>
                 <a:spcPts val="0"/>
               </a:spcBef>
@@ -979,9 +1012,6 @@
               </a:spcAft>
               <a:buNone/>
             </a:pPr>
-            <a:r>
-              <a:t/>
-            </a:r>
             <a:endParaRPr/>
           </a:p>
         </p:txBody>
@@ -995,18 +1025,19 @@
 </file>
 
 <file path=ppt/slideLayouts/slideLayout1.xml><?xml version="1.0" encoding="utf-8"?>
-<p:sldLayout xmlns:a="http://schemas.openxmlformats.org/drawingml/2006/main" xmlns:r="http://schemas.openxmlformats.org/officeDocument/2006/relationships" xmlns:mc="http://schemas.openxmlformats.org/markup-compatibility/2006" xmlns:mv="urn:schemas-microsoft-com:mac:vml" xmlns:p="http://schemas.openxmlformats.org/presentationml/2006/main" xmlns:c="http://schemas.openxmlformats.org/drawingml/2006/chart" xmlns:dgm="http://schemas.openxmlformats.org/drawingml/2006/diagram" xmlns:o="urn:schemas-microsoft-com:office:office" xmlns:v="urn:schemas-microsoft-com:vml" xmlns:pvml="urn:schemas-microsoft-com:office:powerpoint" xmlns:com="http://schemas.openxmlformats.org/drawingml/2006/compatibility" xmlns:p14="http://schemas.microsoft.com/office/powerpoint/2010/main" xmlns:p15="http://schemas.microsoft.com/office/powerpoint/2012/main" xmlns:ahyp="http://schemas.microsoft.com/office/drawing/2018/hyperlinkcolor" matchingName="Title slide" type="title">
+<p:sldLayout xmlns:a="http://schemas.openxmlformats.org/drawingml/2006/main" xmlns:r="http://schemas.openxmlformats.org/officeDocument/2006/relationships" xmlns:p="http://schemas.openxmlformats.org/presentationml/2006/main" matchingName="Title slide" type="title">
   <p:cSld name="TITLE">
     <p:bg>
       <p:bgPr>
         <a:solidFill>
           <a:schemeClr val="dk1"/>
         </a:solidFill>
+        <a:effectLst/>
       </p:bgPr>
     </p:bg>
     <p:spTree>
       <p:nvGrpSpPr>
-        <p:cNvPr id="9" name="Shape 9"/>
+        <p:cNvPr id="1" name="Shape 9"/>
         <p:cNvGrpSpPr/>
         <p:nvPr/>
       </p:nvGrpSpPr>
@@ -1033,21 +1064,23 @@
             <a:avLst/>
           </a:prstGeom>
           <a:noFill/>
-          <a:ln cap="flat" cmpd="sng" w="19050">
+          <a:ln w="19050" cap="flat" cmpd="sng">
             <a:solidFill>
               <a:schemeClr val="lt2"/>
             </a:solidFill>
             <a:prstDash val="solid"/>
             <a:round/>
-            <a:headEnd len="sm" w="sm" type="none"/>
-            <a:tailEnd len="sm" w="sm" type="none"/>
+            <a:headEnd type="none" w="sm" len="sm"/>
+            <a:tailEnd type="none" w="sm" len="sm"/>
           </a:ln>
         </p:spPr>
       </p:cxnSp>
       <p:sp>
         <p:nvSpPr>
           <p:cNvPr id="11" name="Google Shape;11;p2"/>
-          <p:cNvSpPr txBox="1"/>
+          <p:cNvSpPr txBox="1">
+            <a:spLocks noGrp="1"/>
+          </p:cNvSpPr>
           <p:nvPr>
             <p:ph type="ctrTitle"/>
           </p:nvPr>
@@ -1062,7 +1095,7 @@
           </a:prstGeom>
         </p:spPr>
         <p:txBody>
-          <a:bodyPr anchorCtr="0" anchor="b" bIns="91425" lIns="91425" spcFirstLastPara="1" rIns="91425" wrap="square" tIns="91425">
+          <a:bodyPr spcFirstLastPara="1" wrap="square" lIns="91425" tIns="91425" rIns="91425" bIns="91425" anchor="b" anchorCtr="0">
             <a:normAutofit/>
           </a:bodyPr>
           <a:lstStyle>
@@ -1229,15 +1262,19 @@
               </a:defRPr>
             </a:lvl9pPr>
           </a:lstStyle>
-          <a:p/>
+          <a:p>
+            <a:endParaRPr/>
+          </a:p>
         </p:txBody>
       </p:sp>
       <p:sp>
         <p:nvSpPr>
           <p:cNvPr id="12" name="Google Shape;12;p2"/>
-          <p:cNvSpPr txBox="1"/>
+          <p:cNvSpPr txBox="1">
+            <a:spLocks noGrp="1"/>
+          </p:cNvSpPr>
           <p:nvPr>
-            <p:ph idx="1" type="subTitle"/>
+            <p:ph type="subTitle" idx="1"/>
           </p:nvPr>
         </p:nvSpPr>
         <p:spPr>
@@ -1250,7 +1287,7 @@
           </a:prstGeom>
         </p:spPr>
         <p:txBody>
-          <a:bodyPr anchorCtr="0" anchor="t" bIns="91425" lIns="91425" spcFirstLastPara="1" rIns="91425" wrap="square" tIns="91425">
+          <a:bodyPr spcFirstLastPara="1" wrap="square" lIns="91425" tIns="91425" rIns="91425" bIns="91425" anchor="t" anchorCtr="0">
             <a:normAutofit/>
           </a:bodyPr>
           <a:lstStyle>
@@ -1444,15 +1481,19 @@
               </a:defRPr>
             </a:lvl9pPr>
           </a:lstStyle>
-          <a:p/>
+          <a:p>
+            <a:endParaRPr/>
+          </a:p>
         </p:txBody>
       </p:sp>
       <p:sp>
         <p:nvSpPr>
           <p:cNvPr id="13" name="Google Shape;13;p2"/>
-          <p:cNvSpPr txBox="1"/>
+          <p:cNvSpPr txBox="1">
+            <a:spLocks noGrp="1"/>
+          </p:cNvSpPr>
           <p:nvPr>
-            <p:ph idx="12" type="sldNum"/>
+            <p:ph type="sldNum" idx="12"/>
           </p:nvPr>
         </p:nvSpPr>
         <p:spPr>
@@ -1465,7 +1506,7 @@
           </a:prstGeom>
         </p:spPr>
         <p:txBody>
-          <a:bodyPr anchorCtr="0" anchor="ctr" bIns="91425" lIns="91425" spcFirstLastPara="1" rIns="91425" wrap="square" tIns="91425">
+          <a:bodyPr spcFirstLastPara="1" wrap="square" lIns="91425" tIns="91425" rIns="91425" bIns="91425" anchor="ctr" anchorCtr="0">
             <a:normAutofit/>
           </a:bodyPr>
           <a:lstStyle>
@@ -1543,7 +1584,7 @@
             </a:lvl9pPr>
           </a:lstStyle>
           <a:p>
-            <a:pPr indent="0" lvl="0" marL="0" rtl="0" algn="r">
+            <a:pPr marL="0" lvl="0" indent="0" algn="r" rtl="0">
               <a:spcBef>
                 <a:spcPts val="0"/>
               </a:spcBef>
@@ -1569,11 +1610,11 @@
 </file>
 
 <file path=ppt/slideLayouts/slideLayout10.xml><?xml version="1.0" encoding="utf-8"?>
-<p:sldLayout xmlns:a="http://schemas.openxmlformats.org/drawingml/2006/main" xmlns:r="http://schemas.openxmlformats.org/officeDocument/2006/relationships" xmlns:mc="http://schemas.openxmlformats.org/markup-compatibility/2006" xmlns:mv="urn:schemas-microsoft-com:mac:vml" xmlns:p="http://schemas.openxmlformats.org/presentationml/2006/main" xmlns:c="http://schemas.openxmlformats.org/drawingml/2006/chart" xmlns:dgm="http://schemas.openxmlformats.org/drawingml/2006/diagram" xmlns:o="urn:schemas-microsoft-com:office:office" xmlns:v="urn:schemas-microsoft-com:vml" xmlns:pvml="urn:schemas-microsoft-com:office:powerpoint" xmlns:com="http://schemas.openxmlformats.org/drawingml/2006/compatibility" xmlns:p14="http://schemas.microsoft.com/office/powerpoint/2010/main" xmlns:p15="http://schemas.microsoft.com/office/powerpoint/2012/main" xmlns:ahyp="http://schemas.microsoft.com/office/drawing/2018/hyperlinkcolor" matchingName="Big number">
+<p:sldLayout xmlns:a="http://schemas.openxmlformats.org/drawingml/2006/main" xmlns:r="http://schemas.openxmlformats.org/officeDocument/2006/relationships" xmlns:p="http://schemas.openxmlformats.org/presentationml/2006/main" matchingName="Big number">
   <p:cSld name="BIG_NUMBER">
     <p:spTree>
       <p:nvGrpSpPr>
-        <p:cNvPr id="48" name="Shape 48"/>
+        <p:cNvPr id="1" name="Shape 48"/>
         <p:cNvGrpSpPr/>
         <p:nvPr/>
       </p:nvGrpSpPr>
@@ -1607,12 +1648,12 @@
           </a:ln>
         </p:spPr>
         <p:txBody>
-          <a:bodyPr anchorCtr="0" anchor="ctr" bIns="91425" lIns="91425" spcFirstLastPara="1" rIns="91425" wrap="square" tIns="91425">
+          <a:bodyPr spcFirstLastPara="1" wrap="square" lIns="91425" tIns="91425" rIns="91425" bIns="91425" anchor="ctr" anchorCtr="0">
             <a:noAutofit/>
           </a:bodyPr>
           <a:lstStyle/>
           <a:p>
-            <a:pPr indent="0" lvl="0" marL="0" rtl="0" algn="l">
+            <a:pPr marL="0" lvl="0" indent="0" algn="l" rtl="0">
               <a:spcBef>
                 <a:spcPts val="0"/>
               </a:spcBef>
@@ -1621,9 +1662,6 @@
               </a:spcAft>
               <a:buNone/>
             </a:pPr>
-            <a:r>
-              <a:t/>
-            </a:r>
             <a:endParaRPr/>
           </a:p>
         </p:txBody>
@@ -1631,9 +1669,11 @@
       <p:sp>
         <p:nvSpPr>
           <p:cNvPr id="50" name="Google Shape;50;p11"/>
-          <p:cNvSpPr txBox="1"/>
+          <p:cNvSpPr txBox="1">
+            <a:spLocks noGrp="1"/>
+          </p:cNvSpPr>
           <p:nvPr>
-            <p:ph hasCustomPrompt="1" type="title"/>
+            <p:ph type="title" hasCustomPrompt="1"/>
           </p:nvPr>
         </p:nvSpPr>
         <p:spPr>
@@ -1646,7 +1686,7 @@
           </a:prstGeom>
         </p:spPr>
         <p:txBody>
-          <a:bodyPr anchorCtr="0" anchor="ctr" bIns="91425" lIns="91425" spcFirstLastPara="1" rIns="91425" wrap="square" tIns="91425">
+          <a:bodyPr spcFirstLastPara="1" wrap="square" lIns="91425" tIns="91425" rIns="91425" bIns="91425" anchor="ctr" anchorCtr="0">
             <a:normAutofit/>
           </a:bodyPr>
           <a:lstStyle>
@@ -1659,7 +1699,7 @@
               </a:spcAft>
               <a:buSzPts val="14000"/>
               <a:buNone/>
-              <a:defRPr b="1" sz="14000"/>
+              <a:defRPr sz="14000" b="1"/>
             </a:lvl1pPr>
             <a:lvl2pPr lvl="1" algn="ctr">
               <a:spcBef>
@@ -1670,7 +1710,7 @@
               </a:spcAft>
               <a:buSzPts val="14000"/>
               <a:buNone/>
-              <a:defRPr b="1" sz="14000"/>
+              <a:defRPr sz="14000" b="1"/>
             </a:lvl2pPr>
             <a:lvl3pPr lvl="2" algn="ctr">
               <a:spcBef>
@@ -1681,7 +1721,7 @@
               </a:spcAft>
               <a:buSzPts val="14000"/>
               <a:buNone/>
-              <a:defRPr b="1" sz="14000"/>
+              <a:defRPr sz="14000" b="1"/>
             </a:lvl3pPr>
             <a:lvl4pPr lvl="3" algn="ctr">
               <a:spcBef>
@@ -1692,7 +1732,7 @@
               </a:spcAft>
               <a:buSzPts val="14000"/>
               <a:buNone/>
-              <a:defRPr b="1" sz="14000"/>
+              <a:defRPr sz="14000" b="1"/>
             </a:lvl4pPr>
             <a:lvl5pPr lvl="4" algn="ctr">
               <a:spcBef>
@@ -1703,7 +1743,7 @@
               </a:spcAft>
               <a:buSzPts val="14000"/>
               <a:buNone/>
-              <a:defRPr b="1" sz="14000"/>
+              <a:defRPr sz="14000" b="1"/>
             </a:lvl5pPr>
             <a:lvl6pPr lvl="5" algn="ctr">
               <a:spcBef>
@@ -1714,7 +1754,7 @@
               </a:spcAft>
               <a:buSzPts val="14000"/>
               <a:buNone/>
-              <a:defRPr b="1" sz="14000"/>
+              <a:defRPr sz="14000" b="1"/>
             </a:lvl6pPr>
             <a:lvl7pPr lvl="6" algn="ctr">
               <a:spcBef>
@@ -1725,7 +1765,7 @@
               </a:spcAft>
               <a:buSzPts val="14000"/>
               <a:buNone/>
-              <a:defRPr b="1" sz="14000"/>
+              <a:defRPr sz="14000" b="1"/>
             </a:lvl7pPr>
             <a:lvl8pPr lvl="7" algn="ctr">
               <a:spcBef>
@@ -1736,7 +1776,7 @@
               </a:spcAft>
               <a:buSzPts val="14000"/>
               <a:buNone/>
-              <a:defRPr b="1" sz="14000"/>
+              <a:defRPr sz="14000" b="1"/>
             </a:lvl8pPr>
             <a:lvl9pPr lvl="8" algn="ctr">
               <a:spcBef>
@@ -1747,7 +1787,7 @@
               </a:spcAft>
               <a:buSzPts val="14000"/>
               <a:buNone/>
-              <a:defRPr b="1" sz="14000"/>
+              <a:defRPr sz="14000" b="1"/>
             </a:lvl9pPr>
           </a:lstStyle>
           <a:p>
@@ -1760,9 +1800,11 @@
       <p:sp>
         <p:nvSpPr>
           <p:cNvPr id="51" name="Google Shape;51;p11"/>
-          <p:cNvSpPr txBox="1"/>
+          <p:cNvSpPr txBox="1">
+            <a:spLocks noGrp="1"/>
+          </p:cNvSpPr>
           <p:nvPr>
-            <p:ph idx="1" type="body"/>
+            <p:ph type="body" idx="1"/>
           </p:nvPr>
         </p:nvSpPr>
         <p:spPr>
@@ -1775,11 +1817,11 @@
           </a:prstGeom>
         </p:spPr>
         <p:txBody>
-          <a:bodyPr anchorCtr="0" anchor="t" bIns="91425" lIns="91425" spcFirstLastPara="1" rIns="91425" wrap="square" tIns="91425">
+          <a:bodyPr spcFirstLastPara="1" wrap="square" lIns="91425" tIns="91425" rIns="91425" bIns="91425" anchor="t" anchorCtr="0">
             <a:normAutofit/>
           </a:bodyPr>
           <a:lstStyle>
-            <a:lvl1pPr indent="-342900" lvl="0" marL="457200" algn="ctr">
+            <a:lvl1pPr marL="457200" lvl="0" indent="-342900" algn="ctr">
               <a:spcBef>
                 <a:spcPts val="0"/>
               </a:spcBef>
@@ -1790,7 +1832,7 @@
               <a:buChar char="●"/>
               <a:defRPr/>
             </a:lvl1pPr>
-            <a:lvl2pPr indent="-317500" lvl="1" marL="914400" algn="ctr">
+            <a:lvl2pPr marL="914400" lvl="1" indent="-317500" algn="ctr">
               <a:spcBef>
                 <a:spcPts val="0"/>
               </a:spcBef>
@@ -1801,7 +1843,7 @@
               <a:buChar char="○"/>
               <a:defRPr/>
             </a:lvl2pPr>
-            <a:lvl3pPr indent="-317500" lvl="2" marL="1371600" algn="ctr">
+            <a:lvl3pPr marL="1371600" lvl="2" indent="-317500" algn="ctr">
               <a:spcBef>
                 <a:spcPts val="0"/>
               </a:spcBef>
@@ -1812,7 +1854,7 @@
               <a:buChar char="■"/>
               <a:defRPr/>
             </a:lvl3pPr>
-            <a:lvl4pPr indent="-317500" lvl="3" marL="1828800" algn="ctr">
+            <a:lvl4pPr marL="1828800" lvl="3" indent="-317500" algn="ctr">
               <a:spcBef>
                 <a:spcPts val="0"/>
               </a:spcBef>
@@ -1823,7 +1865,7 @@
               <a:buChar char="●"/>
               <a:defRPr/>
             </a:lvl4pPr>
-            <a:lvl5pPr indent="-317500" lvl="4" marL="2286000" algn="ctr">
+            <a:lvl5pPr marL="2286000" lvl="4" indent="-317500" algn="ctr">
               <a:spcBef>
                 <a:spcPts val="0"/>
               </a:spcBef>
@@ -1834,7 +1876,7 @@
               <a:buChar char="○"/>
               <a:defRPr/>
             </a:lvl5pPr>
-            <a:lvl6pPr indent="-317500" lvl="5" marL="2743200" algn="ctr">
+            <a:lvl6pPr marL="2743200" lvl="5" indent="-317500" algn="ctr">
               <a:spcBef>
                 <a:spcPts val="0"/>
               </a:spcBef>
@@ -1845,7 +1887,7 @@
               <a:buChar char="■"/>
               <a:defRPr/>
             </a:lvl6pPr>
-            <a:lvl7pPr indent="-317500" lvl="6" marL="3200400" algn="ctr">
+            <a:lvl7pPr marL="3200400" lvl="6" indent="-317500" algn="ctr">
               <a:spcBef>
                 <a:spcPts val="0"/>
               </a:spcBef>
@@ -1856,7 +1898,7 @@
               <a:buChar char="●"/>
               <a:defRPr/>
             </a:lvl7pPr>
-            <a:lvl8pPr indent="-317500" lvl="7" marL="3657600" algn="ctr">
+            <a:lvl8pPr marL="3657600" lvl="7" indent="-317500" algn="ctr">
               <a:spcBef>
                 <a:spcPts val="0"/>
               </a:spcBef>
@@ -1867,7 +1909,7 @@
               <a:buChar char="○"/>
               <a:defRPr/>
             </a:lvl8pPr>
-            <a:lvl9pPr indent="-317500" lvl="8" marL="4114800" algn="ctr">
+            <a:lvl9pPr marL="4114800" lvl="8" indent="-317500" algn="ctr">
               <a:spcBef>
                 <a:spcPts val="0"/>
               </a:spcBef>
@@ -1879,15 +1921,19 @@
               <a:defRPr/>
             </a:lvl9pPr>
           </a:lstStyle>
-          <a:p/>
+          <a:p>
+            <a:endParaRPr/>
+          </a:p>
         </p:txBody>
       </p:sp>
       <p:sp>
         <p:nvSpPr>
           <p:cNvPr id="52" name="Google Shape;52;p11"/>
-          <p:cNvSpPr txBox="1"/>
+          <p:cNvSpPr txBox="1">
+            <a:spLocks noGrp="1"/>
+          </p:cNvSpPr>
           <p:nvPr>
-            <p:ph idx="12" type="sldNum"/>
+            <p:ph type="sldNum" idx="12"/>
           </p:nvPr>
         </p:nvSpPr>
         <p:spPr>
@@ -1900,7 +1946,7 @@
           </a:prstGeom>
         </p:spPr>
         <p:txBody>
-          <a:bodyPr anchorCtr="0" anchor="ctr" bIns="91425" lIns="91425" spcFirstLastPara="1" rIns="91425" wrap="square" tIns="91425">
+          <a:bodyPr spcFirstLastPara="1" wrap="square" lIns="91425" tIns="91425" rIns="91425" bIns="91425" anchor="ctr" anchorCtr="0">
             <a:normAutofit/>
           </a:bodyPr>
           <a:lstStyle>
@@ -1942,7 +1988,7 @@
             </a:lvl9pPr>
           </a:lstStyle>
           <a:p>
-            <a:pPr indent="0" lvl="0" marL="0" rtl="0" algn="r">
+            <a:pPr marL="0" lvl="0" indent="0" algn="r" rtl="0">
               <a:spcBef>
                 <a:spcPts val="0"/>
               </a:spcBef>
@@ -1968,11 +2014,11 @@
 </file>
 
 <file path=ppt/slideLayouts/slideLayout11.xml><?xml version="1.0" encoding="utf-8"?>
-<p:sldLayout xmlns:a="http://schemas.openxmlformats.org/drawingml/2006/main" xmlns:r="http://schemas.openxmlformats.org/officeDocument/2006/relationships" xmlns:mc="http://schemas.openxmlformats.org/markup-compatibility/2006" xmlns:mv="urn:schemas-microsoft-com:mac:vml" xmlns:p="http://schemas.openxmlformats.org/presentationml/2006/main" xmlns:c="http://schemas.openxmlformats.org/drawingml/2006/chart" xmlns:dgm="http://schemas.openxmlformats.org/drawingml/2006/diagram" xmlns:o="urn:schemas-microsoft-com:office:office" xmlns:v="urn:schemas-microsoft-com:vml" xmlns:pvml="urn:schemas-microsoft-com:office:powerpoint" xmlns:com="http://schemas.openxmlformats.org/drawingml/2006/compatibility" xmlns:p14="http://schemas.microsoft.com/office/powerpoint/2010/main" xmlns:p15="http://schemas.microsoft.com/office/powerpoint/2012/main" xmlns:ahyp="http://schemas.microsoft.com/office/drawing/2018/hyperlinkcolor" matchingName="Blank" type="blank">
+<p:sldLayout xmlns:a="http://schemas.openxmlformats.org/drawingml/2006/main" xmlns:r="http://schemas.openxmlformats.org/officeDocument/2006/relationships" xmlns:p="http://schemas.openxmlformats.org/presentationml/2006/main" matchingName="Blank" type="blank">
   <p:cSld name="BLANK">
     <p:spTree>
       <p:nvGrpSpPr>
-        <p:cNvPr id="53" name="Shape 53"/>
+        <p:cNvPr id="1" name="Shape 53"/>
         <p:cNvGrpSpPr/>
         <p:nvPr/>
       </p:nvGrpSpPr>
@@ -1987,9 +2033,11 @@
       <p:sp>
         <p:nvSpPr>
           <p:cNvPr id="54" name="Google Shape;54;p12"/>
-          <p:cNvSpPr txBox="1"/>
+          <p:cNvSpPr txBox="1">
+            <a:spLocks noGrp="1"/>
+          </p:cNvSpPr>
           <p:nvPr>
-            <p:ph idx="12" type="sldNum"/>
+            <p:ph type="sldNum" idx="12"/>
           </p:nvPr>
         </p:nvSpPr>
         <p:spPr>
@@ -2002,7 +2050,7 @@
           </a:prstGeom>
         </p:spPr>
         <p:txBody>
-          <a:bodyPr anchorCtr="0" anchor="ctr" bIns="91425" lIns="91425" spcFirstLastPara="1" rIns="91425" wrap="square" tIns="91425">
+          <a:bodyPr spcFirstLastPara="1" wrap="square" lIns="91425" tIns="91425" rIns="91425" bIns="91425" anchor="ctr" anchorCtr="0">
             <a:normAutofit/>
           </a:bodyPr>
           <a:lstStyle>
@@ -2044,7 +2092,7 @@
             </a:lvl9pPr>
           </a:lstStyle>
           <a:p>
-            <a:pPr indent="0" lvl="0" marL="0" rtl="0" algn="r">
+            <a:pPr marL="0" lvl="0" indent="0" algn="r" rtl="0">
               <a:spcBef>
                 <a:spcPts val="0"/>
               </a:spcBef>
@@ -2070,18 +2118,19 @@
 </file>
 
 <file path=ppt/slideLayouts/slideLayout2.xml><?xml version="1.0" encoding="utf-8"?>
-<p:sldLayout xmlns:a="http://schemas.openxmlformats.org/drawingml/2006/main" xmlns:r="http://schemas.openxmlformats.org/officeDocument/2006/relationships" xmlns:mc="http://schemas.openxmlformats.org/markup-compatibility/2006" xmlns:mv="urn:schemas-microsoft-com:mac:vml" xmlns:p="http://schemas.openxmlformats.org/presentationml/2006/main" xmlns:c="http://schemas.openxmlformats.org/drawingml/2006/chart" xmlns:dgm="http://schemas.openxmlformats.org/drawingml/2006/diagram" xmlns:o="urn:schemas-microsoft-com:office:office" xmlns:v="urn:schemas-microsoft-com:vml" xmlns:pvml="urn:schemas-microsoft-com:office:powerpoint" xmlns:com="http://schemas.openxmlformats.org/drawingml/2006/compatibility" xmlns:p14="http://schemas.microsoft.com/office/powerpoint/2010/main" xmlns:p15="http://schemas.microsoft.com/office/powerpoint/2012/main" xmlns:ahyp="http://schemas.microsoft.com/office/drawing/2018/hyperlinkcolor" matchingName="Section header" type="secHead">
+<p:sldLayout xmlns:a="http://schemas.openxmlformats.org/drawingml/2006/main" xmlns:r="http://schemas.openxmlformats.org/officeDocument/2006/relationships" xmlns:p="http://schemas.openxmlformats.org/presentationml/2006/main" matchingName="Section header" type="secHead">
   <p:cSld name="SECTION_HEADER">
     <p:bg>
       <p:bgPr>
         <a:solidFill>
           <a:schemeClr val="dk1"/>
         </a:solidFill>
+        <a:effectLst/>
       </p:bgPr>
     </p:bg>
     <p:spTree>
       <p:nvGrpSpPr>
-        <p:cNvPr id="14" name="Shape 14"/>
+        <p:cNvPr id="1" name="Shape 14"/>
         <p:cNvGrpSpPr/>
         <p:nvPr/>
       </p:nvGrpSpPr>
@@ -2108,21 +2157,23 @@
             <a:avLst/>
           </a:prstGeom>
           <a:noFill/>
-          <a:ln cap="flat" cmpd="sng" w="19050">
+          <a:ln w="19050" cap="flat" cmpd="sng">
             <a:solidFill>
               <a:schemeClr val="lt2"/>
             </a:solidFill>
             <a:prstDash val="solid"/>
             <a:round/>
-            <a:headEnd len="sm" w="sm" type="none"/>
-            <a:tailEnd len="sm" w="sm" type="none"/>
+            <a:headEnd type="none" w="sm" len="sm"/>
+            <a:tailEnd type="none" w="sm" len="sm"/>
           </a:ln>
         </p:spPr>
       </p:cxnSp>
       <p:sp>
         <p:nvSpPr>
           <p:cNvPr id="16" name="Google Shape;16;p3"/>
-          <p:cNvSpPr txBox="1"/>
+          <p:cNvSpPr txBox="1">
+            <a:spLocks noGrp="1"/>
+          </p:cNvSpPr>
           <p:nvPr>
             <p:ph type="title"/>
           </p:nvPr>
@@ -2137,7 +2188,7 @@
           </a:prstGeom>
         </p:spPr>
         <p:txBody>
-          <a:bodyPr anchorCtr="0" anchor="b" bIns="91425" lIns="91425" spcFirstLastPara="1" rIns="91425" wrap="square" tIns="91425">
+          <a:bodyPr spcFirstLastPara="1" wrap="square" lIns="91425" tIns="91425" rIns="91425" bIns="91425" anchor="b" anchorCtr="0">
             <a:normAutofit/>
           </a:bodyPr>
           <a:lstStyle>
@@ -2304,15 +2355,19 @@
               </a:defRPr>
             </a:lvl9pPr>
           </a:lstStyle>
-          <a:p/>
+          <a:p>
+            <a:endParaRPr/>
+          </a:p>
         </p:txBody>
       </p:sp>
       <p:sp>
         <p:nvSpPr>
           <p:cNvPr id="17" name="Google Shape;17;p3"/>
-          <p:cNvSpPr txBox="1"/>
+          <p:cNvSpPr txBox="1">
+            <a:spLocks noGrp="1"/>
+          </p:cNvSpPr>
           <p:nvPr>
-            <p:ph idx="12" type="sldNum"/>
+            <p:ph type="sldNum" idx="12"/>
           </p:nvPr>
         </p:nvSpPr>
         <p:spPr>
@@ -2325,7 +2380,7 @@
           </a:prstGeom>
         </p:spPr>
         <p:txBody>
-          <a:bodyPr anchorCtr="0" anchor="ctr" bIns="91425" lIns="91425" spcFirstLastPara="1" rIns="91425" wrap="square" tIns="91425">
+          <a:bodyPr spcFirstLastPara="1" wrap="square" lIns="91425" tIns="91425" rIns="91425" bIns="91425" anchor="ctr" anchorCtr="0">
             <a:normAutofit/>
           </a:bodyPr>
           <a:lstStyle>
@@ -2403,7 +2458,7 @@
             </a:lvl9pPr>
           </a:lstStyle>
           <a:p>
-            <a:pPr indent="0" lvl="0" marL="0" rtl="0" algn="r">
+            <a:pPr marL="0" lvl="0" indent="0" algn="r" rtl="0">
               <a:spcBef>
                 <a:spcPts val="0"/>
               </a:spcBef>
@@ -2429,11 +2484,11 @@
 </file>
 
 <file path=ppt/slideLayouts/slideLayout3.xml><?xml version="1.0" encoding="utf-8"?>
-<p:sldLayout xmlns:a="http://schemas.openxmlformats.org/drawingml/2006/main" xmlns:r="http://schemas.openxmlformats.org/officeDocument/2006/relationships" xmlns:mc="http://schemas.openxmlformats.org/markup-compatibility/2006" xmlns:mv="urn:schemas-microsoft-com:mac:vml" xmlns:p="http://schemas.openxmlformats.org/presentationml/2006/main" xmlns:c="http://schemas.openxmlformats.org/drawingml/2006/chart" xmlns:dgm="http://schemas.openxmlformats.org/drawingml/2006/diagram" xmlns:o="urn:schemas-microsoft-com:office:office" xmlns:v="urn:schemas-microsoft-com:vml" xmlns:pvml="urn:schemas-microsoft-com:office:powerpoint" xmlns:com="http://schemas.openxmlformats.org/drawingml/2006/compatibility" xmlns:p14="http://schemas.microsoft.com/office/powerpoint/2010/main" xmlns:p15="http://schemas.microsoft.com/office/powerpoint/2012/main" xmlns:ahyp="http://schemas.microsoft.com/office/drawing/2018/hyperlinkcolor" matchingName="Title and body" type="tx">
+<p:sldLayout xmlns:a="http://schemas.openxmlformats.org/drawingml/2006/main" xmlns:r="http://schemas.openxmlformats.org/officeDocument/2006/relationships" xmlns:p="http://schemas.openxmlformats.org/presentationml/2006/main" matchingName="Title and body" type="tx">
   <p:cSld name="TITLE_AND_BODY">
     <p:spTree>
       <p:nvGrpSpPr>
-        <p:cNvPr id="18" name="Shape 18"/>
+        <p:cNvPr id="1" name="Shape 18"/>
         <p:cNvGrpSpPr/>
         <p:nvPr/>
       </p:nvGrpSpPr>
@@ -2467,12 +2522,12 @@
           </a:ln>
         </p:spPr>
         <p:txBody>
-          <a:bodyPr anchorCtr="0" anchor="ctr" bIns="91425" lIns="91425" spcFirstLastPara="1" rIns="91425" wrap="square" tIns="91425">
+          <a:bodyPr spcFirstLastPara="1" wrap="square" lIns="91425" tIns="91425" rIns="91425" bIns="91425" anchor="ctr" anchorCtr="0">
             <a:noAutofit/>
           </a:bodyPr>
           <a:lstStyle/>
           <a:p>
-            <a:pPr indent="0" lvl="0" marL="0" rtl="0" algn="l">
+            <a:pPr marL="0" lvl="0" indent="0" algn="l" rtl="0">
               <a:spcBef>
                 <a:spcPts val="0"/>
               </a:spcBef>
@@ -2481,9 +2536,6 @@
               </a:spcAft>
               <a:buNone/>
             </a:pPr>
-            <a:r>
-              <a:t/>
-            </a:r>
             <a:endParaRPr/>
           </a:p>
         </p:txBody>
@@ -2491,7 +2543,9 @@
       <p:sp>
         <p:nvSpPr>
           <p:cNvPr id="20" name="Google Shape;20;p4"/>
-          <p:cNvSpPr txBox="1"/>
+          <p:cNvSpPr txBox="1">
+            <a:spLocks noGrp="1"/>
+          </p:cNvSpPr>
           <p:nvPr>
             <p:ph type="title"/>
           </p:nvPr>
@@ -2506,7 +2560,7 @@
           </a:prstGeom>
         </p:spPr>
         <p:txBody>
-          <a:bodyPr anchorCtr="0" anchor="t" bIns="91425" lIns="91425" spcFirstLastPara="1" rIns="91425" wrap="square" tIns="91425">
+          <a:bodyPr spcFirstLastPara="1" wrap="square" lIns="91425" tIns="91425" rIns="91425" bIns="91425" anchor="t" anchorCtr="0">
             <a:normAutofit/>
           </a:bodyPr>
           <a:lstStyle>
@@ -2610,15 +2664,19 @@
               <a:defRPr/>
             </a:lvl9pPr>
           </a:lstStyle>
-          <a:p/>
+          <a:p>
+            <a:endParaRPr/>
+          </a:p>
         </p:txBody>
       </p:sp>
       <p:sp>
         <p:nvSpPr>
           <p:cNvPr id="21" name="Google Shape;21;p4"/>
-          <p:cNvSpPr txBox="1"/>
+          <p:cNvSpPr txBox="1">
+            <a:spLocks noGrp="1"/>
+          </p:cNvSpPr>
           <p:nvPr>
-            <p:ph idx="1" type="body"/>
+            <p:ph type="body" idx="1"/>
           </p:nvPr>
         </p:nvSpPr>
         <p:spPr>
@@ -2631,11 +2689,11 @@
           </a:prstGeom>
         </p:spPr>
         <p:txBody>
-          <a:bodyPr anchorCtr="0" anchor="t" bIns="91425" lIns="91425" spcFirstLastPara="1" rIns="91425" wrap="square" tIns="91425">
+          <a:bodyPr spcFirstLastPara="1" wrap="square" lIns="91425" tIns="91425" rIns="91425" bIns="91425" anchor="t" anchorCtr="0">
             <a:normAutofit/>
           </a:bodyPr>
           <a:lstStyle>
-            <a:lvl1pPr indent="-342900" lvl="0" marL="457200">
+            <a:lvl1pPr marL="457200" lvl="0" indent="-342900">
               <a:spcBef>
                 <a:spcPts val="0"/>
               </a:spcBef>
@@ -2646,7 +2704,7 @@
               <a:buChar char="●"/>
               <a:defRPr/>
             </a:lvl1pPr>
-            <a:lvl2pPr indent="-317500" lvl="1" marL="914400">
+            <a:lvl2pPr marL="914400" lvl="1" indent="-317500">
               <a:spcBef>
                 <a:spcPts val="0"/>
               </a:spcBef>
@@ -2657,7 +2715,7 @@
               <a:buChar char="○"/>
               <a:defRPr/>
             </a:lvl2pPr>
-            <a:lvl3pPr indent="-317500" lvl="2" marL="1371600">
+            <a:lvl3pPr marL="1371600" lvl="2" indent="-317500">
               <a:spcBef>
                 <a:spcPts val="0"/>
               </a:spcBef>
@@ -2668,7 +2726,7 @@
               <a:buChar char="■"/>
               <a:defRPr/>
             </a:lvl3pPr>
-            <a:lvl4pPr indent="-317500" lvl="3" marL="1828800">
+            <a:lvl4pPr marL="1828800" lvl="3" indent="-317500">
               <a:spcBef>
                 <a:spcPts val="0"/>
               </a:spcBef>
@@ -2679,7 +2737,7 @@
               <a:buChar char="●"/>
               <a:defRPr/>
             </a:lvl4pPr>
-            <a:lvl5pPr indent="-317500" lvl="4" marL="2286000">
+            <a:lvl5pPr marL="2286000" lvl="4" indent="-317500">
               <a:spcBef>
                 <a:spcPts val="0"/>
               </a:spcBef>
@@ -2690,7 +2748,7 @@
               <a:buChar char="○"/>
               <a:defRPr/>
             </a:lvl5pPr>
-            <a:lvl6pPr indent="-317500" lvl="5" marL="2743200">
+            <a:lvl6pPr marL="2743200" lvl="5" indent="-317500">
               <a:spcBef>
                 <a:spcPts val="0"/>
               </a:spcBef>
@@ -2701,7 +2759,7 @@
               <a:buChar char="■"/>
               <a:defRPr/>
             </a:lvl6pPr>
-            <a:lvl7pPr indent="-317500" lvl="6" marL="3200400">
+            <a:lvl7pPr marL="3200400" lvl="6" indent="-317500">
               <a:spcBef>
                 <a:spcPts val="0"/>
               </a:spcBef>
@@ -2712,7 +2770,7 @@
               <a:buChar char="●"/>
               <a:defRPr/>
             </a:lvl7pPr>
-            <a:lvl8pPr indent="-317500" lvl="7" marL="3657600">
+            <a:lvl8pPr marL="3657600" lvl="7" indent="-317500">
               <a:spcBef>
                 <a:spcPts val="0"/>
               </a:spcBef>
@@ -2723,7 +2781,7 @@
               <a:buChar char="○"/>
               <a:defRPr/>
             </a:lvl8pPr>
-            <a:lvl9pPr indent="-317500" lvl="8" marL="4114800">
+            <a:lvl9pPr marL="4114800" lvl="8" indent="-317500">
               <a:spcBef>
                 <a:spcPts val="0"/>
               </a:spcBef>
@@ -2735,15 +2793,19 @@
               <a:defRPr/>
             </a:lvl9pPr>
           </a:lstStyle>
-          <a:p/>
+          <a:p>
+            <a:endParaRPr/>
+          </a:p>
         </p:txBody>
       </p:sp>
       <p:sp>
         <p:nvSpPr>
           <p:cNvPr id="22" name="Google Shape;22;p4"/>
-          <p:cNvSpPr txBox="1"/>
+          <p:cNvSpPr txBox="1">
+            <a:spLocks noGrp="1"/>
+          </p:cNvSpPr>
           <p:nvPr>
-            <p:ph idx="12" type="sldNum"/>
+            <p:ph type="sldNum" idx="12"/>
           </p:nvPr>
         </p:nvSpPr>
         <p:spPr>
@@ -2756,7 +2818,7 @@
           </a:prstGeom>
         </p:spPr>
         <p:txBody>
-          <a:bodyPr anchorCtr="0" anchor="ctr" bIns="91425" lIns="91425" spcFirstLastPara="1" rIns="91425" wrap="square" tIns="91425">
+          <a:bodyPr spcFirstLastPara="1" wrap="square" lIns="91425" tIns="91425" rIns="91425" bIns="91425" anchor="ctr" anchorCtr="0">
             <a:normAutofit/>
           </a:bodyPr>
           <a:lstStyle>
@@ -2798,7 +2860,7 @@
             </a:lvl9pPr>
           </a:lstStyle>
           <a:p>
-            <a:pPr indent="0" lvl="0" marL="0" rtl="0" algn="r">
+            <a:pPr marL="0" lvl="0" indent="0" algn="r" rtl="0">
               <a:spcBef>
                 <a:spcPts val="0"/>
               </a:spcBef>
@@ -2824,11 +2886,11 @@
 </file>
 
 <file path=ppt/slideLayouts/slideLayout4.xml><?xml version="1.0" encoding="utf-8"?>
-<p:sldLayout xmlns:a="http://schemas.openxmlformats.org/drawingml/2006/main" xmlns:r="http://schemas.openxmlformats.org/officeDocument/2006/relationships" xmlns:mc="http://schemas.openxmlformats.org/markup-compatibility/2006" xmlns:mv="urn:schemas-microsoft-com:mac:vml" xmlns:p="http://schemas.openxmlformats.org/presentationml/2006/main" xmlns:c="http://schemas.openxmlformats.org/drawingml/2006/chart" xmlns:dgm="http://schemas.openxmlformats.org/drawingml/2006/diagram" xmlns:o="urn:schemas-microsoft-com:office:office" xmlns:v="urn:schemas-microsoft-com:vml" xmlns:pvml="urn:schemas-microsoft-com:office:powerpoint" xmlns:com="http://schemas.openxmlformats.org/drawingml/2006/compatibility" xmlns:p14="http://schemas.microsoft.com/office/powerpoint/2010/main" xmlns:p15="http://schemas.microsoft.com/office/powerpoint/2012/main" xmlns:ahyp="http://schemas.microsoft.com/office/drawing/2018/hyperlinkcolor" matchingName="Title and two columns" type="twoColTx">
+<p:sldLayout xmlns:a="http://schemas.openxmlformats.org/drawingml/2006/main" xmlns:r="http://schemas.openxmlformats.org/officeDocument/2006/relationships" xmlns:p="http://schemas.openxmlformats.org/presentationml/2006/main" matchingName="Title and two columns" type="twoColTx">
   <p:cSld name="TITLE_AND_TWO_COLUMNS">
     <p:spTree>
       <p:nvGrpSpPr>
-        <p:cNvPr id="23" name="Shape 23"/>
+        <p:cNvPr id="1" name="Shape 23"/>
         <p:cNvGrpSpPr/>
         <p:nvPr/>
       </p:nvGrpSpPr>
@@ -2843,7 +2905,9 @@
       <p:sp>
         <p:nvSpPr>
           <p:cNvPr id="24" name="Google Shape;24;p5"/>
-          <p:cNvSpPr txBox="1"/>
+          <p:cNvSpPr txBox="1">
+            <a:spLocks noGrp="1"/>
+          </p:cNvSpPr>
           <p:nvPr>
             <p:ph type="title"/>
           </p:nvPr>
@@ -2858,7 +2922,7 @@
           </a:prstGeom>
         </p:spPr>
         <p:txBody>
-          <a:bodyPr anchorCtr="0" anchor="t" bIns="91425" lIns="91425" spcFirstLastPara="1" rIns="91425" wrap="square" tIns="91425">
+          <a:bodyPr spcFirstLastPara="1" wrap="square" lIns="91425" tIns="91425" rIns="91425" bIns="91425" anchor="t" anchorCtr="0">
             <a:normAutofit/>
           </a:bodyPr>
           <a:lstStyle>
@@ -2962,15 +3026,19 @@
               <a:defRPr/>
             </a:lvl9pPr>
           </a:lstStyle>
-          <a:p/>
+          <a:p>
+            <a:endParaRPr/>
+          </a:p>
         </p:txBody>
       </p:sp>
       <p:sp>
         <p:nvSpPr>
           <p:cNvPr id="25" name="Google Shape;25;p5"/>
-          <p:cNvSpPr txBox="1"/>
+          <p:cNvSpPr txBox="1">
+            <a:spLocks noGrp="1"/>
+          </p:cNvSpPr>
           <p:nvPr>
-            <p:ph idx="1" type="body"/>
+            <p:ph type="body" idx="1"/>
           </p:nvPr>
         </p:nvSpPr>
         <p:spPr>
@@ -2983,11 +3051,11 @@
           </a:prstGeom>
         </p:spPr>
         <p:txBody>
-          <a:bodyPr anchorCtr="0" anchor="t" bIns="91425" lIns="91425" spcFirstLastPara="1" rIns="91425" wrap="square" tIns="91425">
+          <a:bodyPr spcFirstLastPara="1" wrap="square" lIns="91425" tIns="91425" rIns="91425" bIns="91425" anchor="t" anchorCtr="0">
             <a:normAutofit/>
           </a:bodyPr>
           <a:lstStyle>
-            <a:lvl1pPr indent="-317500" lvl="0" marL="457200">
+            <a:lvl1pPr marL="457200" lvl="0" indent="-317500">
               <a:spcBef>
                 <a:spcPts val="0"/>
               </a:spcBef>
@@ -2998,7 +3066,7 @@
               <a:buChar char="●"/>
               <a:defRPr sz="1400"/>
             </a:lvl1pPr>
-            <a:lvl2pPr indent="-304800" lvl="1" marL="914400">
+            <a:lvl2pPr marL="914400" lvl="1" indent="-304800">
               <a:spcBef>
                 <a:spcPts val="0"/>
               </a:spcBef>
@@ -3009,7 +3077,7 @@
               <a:buChar char="○"/>
               <a:defRPr sz="1200"/>
             </a:lvl2pPr>
-            <a:lvl3pPr indent="-304800" lvl="2" marL="1371600">
+            <a:lvl3pPr marL="1371600" lvl="2" indent="-304800">
               <a:spcBef>
                 <a:spcPts val="0"/>
               </a:spcBef>
@@ -3020,7 +3088,7 @@
               <a:buChar char="■"/>
               <a:defRPr sz="1200"/>
             </a:lvl3pPr>
-            <a:lvl4pPr indent="-304800" lvl="3" marL="1828800">
+            <a:lvl4pPr marL="1828800" lvl="3" indent="-304800">
               <a:spcBef>
                 <a:spcPts val="0"/>
               </a:spcBef>
@@ -3031,7 +3099,7 @@
               <a:buChar char="●"/>
               <a:defRPr sz="1200"/>
             </a:lvl4pPr>
-            <a:lvl5pPr indent="-304800" lvl="4" marL="2286000">
+            <a:lvl5pPr marL="2286000" lvl="4" indent="-304800">
               <a:spcBef>
                 <a:spcPts val="0"/>
               </a:spcBef>
@@ -3042,7 +3110,7 @@
               <a:buChar char="○"/>
               <a:defRPr sz="1200"/>
             </a:lvl5pPr>
-            <a:lvl6pPr indent="-304800" lvl="5" marL="2743200">
+            <a:lvl6pPr marL="2743200" lvl="5" indent="-304800">
               <a:spcBef>
                 <a:spcPts val="0"/>
               </a:spcBef>
@@ -3053,7 +3121,7 @@
               <a:buChar char="■"/>
               <a:defRPr sz="1200"/>
             </a:lvl6pPr>
-            <a:lvl7pPr indent="-304800" lvl="6" marL="3200400">
+            <a:lvl7pPr marL="3200400" lvl="6" indent="-304800">
               <a:spcBef>
                 <a:spcPts val="0"/>
               </a:spcBef>
@@ -3064,7 +3132,7 @@
               <a:buChar char="●"/>
               <a:defRPr sz="1200"/>
             </a:lvl7pPr>
-            <a:lvl8pPr indent="-304800" lvl="7" marL="3657600">
+            <a:lvl8pPr marL="3657600" lvl="7" indent="-304800">
               <a:spcBef>
                 <a:spcPts val="0"/>
               </a:spcBef>
@@ -3075,7 +3143,7 @@
               <a:buChar char="○"/>
               <a:defRPr sz="1200"/>
             </a:lvl8pPr>
-            <a:lvl9pPr indent="-304800" lvl="8" marL="4114800">
+            <a:lvl9pPr marL="4114800" lvl="8" indent="-304800">
               <a:spcBef>
                 <a:spcPts val="0"/>
               </a:spcBef>
@@ -3087,15 +3155,19 @@
               <a:defRPr sz="1200"/>
             </a:lvl9pPr>
           </a:lstStyle>
-          <a:p/>
+          <a:p>
+            <a:endParaRPr/>
+          </a:p>
         </p:txBody>
       </p:sp>
       <p:sp>
         <p:nvSpPr>
           <p:cNvPr id="26" name="Google Shape;26;p5"/>
-          <p:cNvSpPr txBox="1"/>
+          <p:cNvSpPr txBox="1">
+            <a:spLocks noGrp="1"/>
+          </p:cNvSpPr>
           <p:nvPr>
-            <p:ph idx="2" type="body"/>
+            <p:ph type="body" idx="2"/>
           </p:nvPr>
         </p:nvSpPr>
         <p:spPr>
@@ -3108,11 +3180,11 @@
           </a:prstGeom>
         </p:spPr>
         <p:txBody>
-          <a:bodyPr anchorCtr="0" anchor="t" bIns="91425" lIns="91425" spcFirstLastPara="1" rIns="91425" wrap="square" tIns="91425">
+          <a:bodyPr spcFirstLastPara="1" wrap="square" lIns="91425" tIns="91425" rIns="91425" bIns="91425" anchor="t" anchorCtr="0">
             <a:normAutofit/>
           </a:bodyPr>
           <a:lstStyle>
-            <a:lvl1pPr indent="-317500" lvl="0" marL="457200">
+            <a:lvl1pPr marL="457200" lvl="0" indent="-317500">
               <a:spcBef>
                 <a:spcPts val="0"/>
               </a:spcBef>
@@ -3123,7 +3195,7 @@
               <a:buChar char="●"/>
               <a:defRPr sz="1400"/>
             </a:lvl1pPr>
-            <a:lvl2pPr indent="-304800" lvl="1" marL="914400">
+            <a:lvl2pPr marL="914400" lvl="1" indent="-304800">
               <a:spcBef>
                 <a:spcPts val="0"/>
               </a:spcBef>
@@ -3134,7 +3206,7 @@
               <a:buChar char="○"/>
               <a:defRPr sz="1200"/>
             </a:lvl2pPr>
-            <a:lvl3pPr indent="-304800" lvl="2" marL="1371600">
+            <a:lvl3pPr marL="1371600" lvl="2" indent="-304800">
               <a:spcBef>
                 <a:spcPts val="0"/>
               </a:spcBef>
@@ -3145,7 +3217,7 @@
               <a:buChar char="■"/>
               <a:defRPr sz="1200"/>
             </a:lvl3pPr>
-            <a:lvl4pPr indent="-304800" lvl="3" marL="1828800">
+            <a:lvl4pPr marL="1828800" lvl="3" indent="-304800">
               <a:spcBef>
                 <a:spcPts val="0"/>
               </a:spcBef>
@@ -3156,7 +3228,7 @@
               <a:buChar char="●"/>
               <a:defRPr sz="1200"/>
             </a:lvl4pPr>
-            <a:lvl5pPr indent="-304800" lvl="4" marL="2286000">
+            <a:lvl5pPr marL="2286000" lvl="4" indent="-304800">
               <a:spcBef>
                 <a:spcPts val="0"/>
               </a:spcBef>
@@ -3167,7 +3239,7 @@
               <a:buChar char="○"/>
               <a:defRPr sz="1200"/>
             </a:lvl5pPr>
-            <a:lvl6pPr indent="-304800" lvl="5" marL="2743200">
+            <a:lvl6pPr marL="2743200" lvl="5" indent="-304800">
               <a:spcBef>
                 <a:spcPts val="0"/>
               </a:spcBef>
@@ -3178,7 +3250,7 @@
               <a:buChar char="■"/>
               <a:defRPr sz="1200"/>
             </a:lvl6pPr>
-            <a:lvl7pPr indent="-304800" lvl="6" marL="3200400">
+            <a:lvl7pPr marL="3200400" lvl="6" indent="-304800">
               <a:spcBef>
                 <a:spcPts val="0"/>
               </a:spcBef>
@@ -3189,7 +3261,7 @@
               <a:buChar char="●"/>
               <a:defRPr sz="1200"/>
             </a:lvl7pPr>
-            <a:lvl8pPr indent="-304800" lvl="7" marL="3657600">
+            <a:lvl8pPr marL="3657600" lvl="7" indent="-304800">
               <a:spcBef>
                 <a:spcPts val="0"/>
               </a:spcBef>
@@ -3200,7 +3272,7 @@
               <a:buChar char="○"/>
               <a:defRPr sz="1200"/>
             </a:lvl8pPr>
-            <a:lvl9pPr indent="-304800" lvl="8" marL="4114800">
+            <a:lvl9pPr marL="4114800" lvl="8" indent="-304800">
               <a:spcBef>
                 <a:spcPts val="0"/>
               </a:spcBef>
@@ -3212,15 +3284,19 @@
               <a:defRPr sz="1200"/>
             </a:lvl9pPr>
           </a:lstStyle>
-          <a:p/>
+          <a:p>
+            <a:endParaRPr/>
+          </a:p>
         </p:txBody>
       </p:sp>
       <p:sp>
         <p:nvSpPr>
           <p:cNvPr id="27" name="Google Shape;27;p5"/>
-          <p:cNvSpPr txBox="1"/>
+          <p:cNvSpPr txBox="1">
+            <a:spLocks noGrp="1"/>
+          </p:cNvSpPr>
           <p:nvPr>
-            <p:ph idx="12" type="sldNum"/>
+            <p:ph type="sldNum" idx="12"/>
           </p:nvPr>
         </p:nvSpPr>
         <p:spPr>
@@ -3233,7 +3309,7 @@
           </a:prstGeom>
         </p:spPr>
         <p:txBody>
-          <a:bodyPr anchorCtr="0" anchor="ctr" bIns="91425" lIns="91425" spcFirstLastPara="1" rIns="91425" wrap="square" tIns="91425">
+          <a:bodyPr spcFirstLastPara="1" wrap="square" lIns="91425" tIns="91425" rIns="91425" bIns="91425" anchor="ctr" anchorCtr="0">
             <a:normAutofit/>
           </a:bodyPr>
           <a:lstStyle>
@@ -3275,7 +3351,7 @@
             </a:lvl9pPr>
           </a:lstStyle>
           <a:p>
-            <a:pPr indent="0" lvl="0" marL="0" rtl="0" algn="r">
+            <a:pPr marL="0" lvl="0" indent="0" algn="r" rtl="0">
               <a:spcBef>
                 <a:spcPts val="0"/>
               </a:spcBef>
@@ -3301,11 +3377,11 @@
 </file>
 
 <file path=ppt/slideLayouts/slideLayout5.xml><?xml version="1.0" encoding="utf-8"?>
-<p:sldLayout xmlns:a="http://schemas.openxmlformats.org/drawingml/2006/main" xmlns:r="http://schemas.openxmlformats.org/officeDocument/2006/relationships" xmlns:mc="http://schemas.openxmlformats.org/markup-compatibility/2006" xmlns:mv="urn:schemas-microsoft-com:mac:vml" xmlns:p="http://schemas.openxmlformats.org/presentationml/2006/main" xmlns:c="http://schemas.openxmlformats.org/drawingml/2006/chart" xmlns:dgm="http://schemas.openxmlformats.org/drawingml/2006/diagram" xmlns:o="urn:schemas-microsoft-com:office:office" xmlns:v="urn:schemas-microsoft-com:vml" xmlns:pvml="urn:schemas-microsoft-com:office:powerpoint" xmlns:com="http://schemas.openxmlformats.org/drawingml/2006/compatibility" xmlns:p14="http://schemas.microsoft.com/office/powerpoint/2010/main" xmlns:p15="http://schemas.microsoft.com/office/powerpoint/2012/main" xmlns:ahyp="http://schemas.microsoft.com/office/drawing/2018/hyperlinkcolor" matchingName="Title only" type="titleOnly">
+<p:sldLayout xmlns:a="http://schemas.openxmlformats.org/drawingml/2006/main" xmlns:r="http://schemas.openxmlformats.org/officeDocument/2006/relationships" xmlns:p="http://schemas.openxmlformats.org/presentationml/2006/main" matchingName="Title only" type="titleOnly">
   <p:cSld name="TITLE_ONLY">
     <p:spTree>
       <p:nvGrpSpPr>
-        <p:cNvPr id="28" name="Shape 28"/>
+        <p:cNvPr id="1" name="Shape 28"/>
         <p:cNvGrpSpPr/>
         <p:nvPr/>
       </p:nvGrpSpPr>
@@ -3320,7 +3396,9 @@
       <p:sp>
         <p:nvSpPr>
           <p:cNvPr id="29" name="Google Shape;29;p6"/>
-          <p:cNvSpPr txBox="1"/>
+          <p:cNvSpPr txBox="1">
+            <a:spLocks noGrp="1"/>
+          </p:cNvSpPr>
           <p:nvPr>
             <p:ph type="title"/>
           </p:nvPr>
@@ -3335,7 +3413,7 @@
           </a:prstGeom>
         </p:spPr>
         <p:txBody>
-          <a:bodyPr anchorCtr="0" anchor="t" bIns="91425" lIns="91425" spcFirstLastPara="1" rIns="91425" wrap="square" tIns="91425">
+          <a:bodyPr spcFirstLastPara="1" wrap="square" lIns="91425" tIns="91425" rIns="91425" bIns="91425" anchor="t" anchorCtr="0">
             <a:normAutofit/>
           </a:bodyPr>
           <a:lstStyle>
@@ -3439,15 +3517,19 @@
               <a:defRPr/>
             </a:lvl9pPr>
           </a:lstStyle>
-          <a:p/>
+          <a:p>
+            <a:endParaRPr/>
+          </a:p>
         </p:txBody>
       </p:sp>
       <p:sp>
         <p:nvSpPr>
           <p:cNvPr id="30" name="Google Shape;30;p6"/>
-          <p:cNvSpPr txBox="1"/>
+          <p:cNvSpPr txBox="1">
+            <a:spLocks noGrp="1"/>
+          </p:cNvSpPr>
           <p:nvPr>
-            <p:ph idx="12" type="sldNum"/>
+            <p:ph type="sldNum" idx="12"/>
           </p:nvPr>
         </p:nvSpPr>
         <p:spPr>
@@ -3460,7 +3542,7 @@
           </a:prstGeom>
         </p:spPr>
         <p:txBody>
-          <a:bodyPr anchorCtr="0" anchor="ctr" bIns="91425" lIns="91425" spcFirstLastPara="1" rIns="91425" wrap="square" tIns="91425">
+          <a:bodyPr spcFirstLastPara="1" wrap="square" lIns="91425" tIns="91425" rIns="91425" bIns="91425" anchor="ctr" anchorCtr="0">
             <a:normAutofit/>
           </a:bodyPr>
           <a:lstStyle>
@@ -3502,7 +3584,7 @@
             </a:lvl9pPr>
           </a:lstStyle>
           <a:p>
-            <a:pPr indent="0" lvl="0" marL="0" rtl="0" algn="r">
+            <a:pPr marL="0" lvl="0" indent="0" algn="r" rtl="0">
               <a:spcBef>
                 <a:spcPts val="0"/>
               </a:spcBef>
@@ -3528,11 +3610,11 @@
 </file>
 
 <file path=ppt/slideLayouts/slideLayout6.xml><?xml version="1.0" encoding="utf-8"?>
-<p:sldLayout xmlns:a="http://schemas.openxmlformats.org/drawingml/2006/main" xmlns:r="http://schemas.openxmlformats.org/officeDocument/2006/relationships" xmlns:mc="http://schemas.openxmlformats.org/markup-compatibility/2006" xmlns:mv="urn:schemas-microsoft-com:mac:vml" xmlns:p="http://schemas.openxmlformats.org/presentationml/2006/main" xmlns:c="http://schemas.openxmlformats.org/drawingml/2006/chart" xmlns:dgm="http://schemas.openxmlformats.org/drawingml/2006/diagram" xmlns:o="urn:schemas-microsoft-com:office:office" xmlns:v="urn:schemas-microsoft-com:vml" xmlns:pvml="urn:schemas-microsoft-com:office:powerpoint" xmlns:com="http://schemas.openxmlformats.org/drawingml/2006/compatibility" xmlns:p14="http://schemas.microsoft.com/office/powerpoint/2010/main" xmlns:p15="http://schemas.microsoft.com/office/powerpoint/2012/main" xmlns:ahyp="http://schemas.microsoft.com/office/drawing/2018/hyperlinkcolor" matchingName="One column text">
+<p:sldLayout xmlns:a="http://schemas.openxmlformats.org/drawingml/2006/main" xmlns:r="http://schemas.openxmlformats.org/officeDocument/2006/relationships" xmlns:p="http://schemas.openxmlformats.org/presentationml/2006/main" matchingName="One column text">
   <p:cSld name="ONE_COLUMN_TEXT">
     <p:spTree>
       <p:nvGrpSpPr>
-        <p:cNvPr id="31" name="Shape 31"/>
+        <p:cNvPr id="1" name="Shape 31"/>
         <p:cNvGrpSpPr/>
         <p:nvPr/>
       </p:nvGrpSpPr>
@@ -3547,7 +3629,9 @@
       <p:sp>
         <p:nvSpPr>
           <p:cNvPr id="32" name="Google Shape;32;p7"/>
-          <p:cNvSpPr txBox="1"/>
+          <p:cNvSpPr txBox="1">
+            <a:spLocks noGrp="1"/>
+          </p:cNvSpPr>
           <p:nvPr>
             <p:ph type="title"/>
           </p:nvPr>
@@ -3562,7 +3646,7 @@
           </a:prstGeom>
         </p:spPr>
         <p:txBody>
-          <a:bodyPr anchorCtr="0" anchor="b" bIns="91425" lIns="91425" spcFirstLastPara="1" rIns="91425" wrap="square" tIns="91425">
+          <a:bodyPr spcFirstLastPara="1" wrap="square" lIns="91425" tIns="91425" rIns="91425" bIns="91425" anchor="b" anchorCtr="0">
             <a:normAutofit/>
           </a:bodyPr>
           <a:lstStyle>
@@ -3666,15 +3750,19 @@
               <a:defRPr sz="2400"/>
             </a:lvl9pPr>
           </a:lstStyle>
-          <a:p/>
+          <a:p>
+            <a:endParaRPr/>
+          </a:p>
         </p:txBody>
       </p:sp>
       <p:sp>
         <p:nvSpPr>
           <p:cNvPr id="33" name="Google Shape;33;p7"/>
-          <p:cNvSpPr txBox="1"/>
+          <p:cNvSpPr txBox="1">
+            <a:spLocks noGrp="1"/>
+          </p:cNvSpPr>
           <p:nvPr>
-            <p:ph idx="1" type="body"/>
+            <p:ph type="body" idx="1"/>
           </p:nvPr>
         </p:nvSpPr>
         <p:spPr>
@@ -3687,11 +3775,11 @@
           </a:prstGeom>
         </p:spPr>
         <p:txBody>
-          <a:bodyPr anchorCtr="0" anchor="t" bIns="91425" lIns="91425" spcFirstLastPara="1" rIns="91425" wrap="square" tIns="91425">
+          <a:bodyPr spcFirstLastPara="1" wrap="square" lIns="91425" tIns="91425" rIns="91425" bIns="91425" anchor="t" anchorCtr="0">
             <a:normAutofit/>
           </a:bodyPr>
           <a:lstStyle>
-            <a:lvl1pPr indent="-304800" lvl="0" marL="457200">
+            <a:lvl1pPr marL="457200" lvl="0" indent="-304800">
               <a:spcBef>
                 <a:spcPts val="0"/>
               </a:spcBef>
@@ -3702,7 +3790,7 @@
               <a:buChar char="●"/>
               <a:defRPr sz="1200"/>
             </a:lvl1pPr>
-            <a:lvl2pPr indent="-304800" lvl="1" marL="914400">
+            <a:lvl2pPr marL="914400" lvl="1" indent="-304800">
               <a:spcBef>
                 <a:spcPts val="0"/>
               </a:spcBef>
@@ -3713,7 +3801,7 @@
               <a:buChar char="○"/>
               <a:defRPr sz="1200"/>
             </a:lvl2pPr>
-            <a:lvl3pPr indent="-304800" lvl="2" marL="1371600">
+            <a:lvl3pPr marL="1371600" lvl="2" indent="-304800">
               <a:spcBef>
                 <a:spcPts val="0"/>
               </a:spcBef>
@@ -3724,7 +3812,7 @@
               <a:buChar char="■"/>
               <a:defRPr sz="1200"/>
             </a:lvl3pPr>
-            <a:lvl4pPr indent="-304800" lvl="3" marL="1828800">
+            <a:lvl4pPr marL="1828800" lvl="3" indent="-304800">
               <a:spcBef>
                 <a:spcPts val="0"/>
               </a:spcBef>
@@ -3735,7 +3823,7 @@
               <a:buChar char="●"/>
               <a:defRPr sz="1200"/>
             </a:lvl4pPr>
-            <a:lvl5pPr indent="-304800" lvl="4" marL="2286000">
+            <a:lvl5pPr marL="2286000" lvl="4" indent="-304800">
               <a:spcBef>
                 <a:spcPts val="0"/>
               </a:spcBef>
@@ -3746,7 +3834,7 @@
               <a:buChar char="○"/>
               <a:defRPr sz="1200"/>
             </a:lvl5pPr>
-            <a:lvl6pPr indent="-304800" lvl="5" marL="2743200">
+            <a:lvl6pPr marL="2743200" lvl="5" indent="-304800">
               <a:spcBef>
                 <a:spcPts val="0"/>
               </a:spcBef>
@@ -3757,7 +3845,7 @@
               <a:buChar char="■"/>
               <a:defRPr sz="1200"/>
             </a:lvl6pPr>
-            <a:lvl7pPr indent="-304800" lvl="6" marL="3200400">
+            <a:lvl7pPr marL="3200400" lvl="6" indent="-304800">
               <a:spcBef>
                 <a:spcPts val="0"/>
               </a:spcBef>
@@ -3768,7 +3856,7 @@
               <a:buChar char="●"/>
               <a:defRPr sz="1200"/>
             </a:lvl7pPr>
-            <a:lvl8pPr indent="-304800" lvl="7" marL="3657600">
+            <a:lvl8pPr marL="3657600" lvl="7" indent="-304800">
               <a:spcBef>
                 <a:spcPts val="0"/>
               </a:spcBef>
@@ -3779,7 +3867,7 @@
               <a:buChar char="○"/>
               <a:defRPr sz="1200"/>
             </a:lvl8pPr>
-            <a:lvl9pPr indent="-304800" lvl="8" marL="4114800">
+            <a:lvl9pPr marL="4114800" lvl="8" indent="-304800">
               <a:spcBef>
                 <a:spcPts val="0"/>
               </a:spcBef>
@@ -3791,15 +3879,19 @@
               <a:defRPr sz="1200"/>
             </a:lvl9pPr>
           </a:lstStyle>
-          <a:p/>
+          <a:p>
+            <a:endParaRPr/>
+          </a:p>
         </p:txBody>
       </p:sp>
       <p:sp>
         <p:nvSpPr>
           <p:cNvPr id="34" name="Google Shape;34;p7"/>
-          <p:cNvSpPr txBox="1"/>
+          <p:cNvSpPr txBox="1">
+            <a:spLocks noGrp="1"/>
+          </p:cNvSpPr>
           <p:nvPr>
-            <p:ph idx="12" type="sldNum"/>
+            <p:ph type="sldNum" idx="12"/>
           </p:nvPr>
         </p:nvSpPr>
         <p:spPr>
@@ -3812,7 +3904,7 @@
           </a:prstGeom>
         </p:spPr>
         <p:txBody>
-          <a:bodyPr anchorCtr="0" anchor="ctr" bIns="91425" lIns="91425" spcFirstLastPara="1" rIns="91425" wrap="square" tIns="91425">
+          <a:bodyPr spcFirstLastPara="1" wrap="square" lIns="91425" tIns="91425" rIns="91425" bIns="91425" anchor="ctr" anchorCtr="0">
             <a:normAutofit/>
           </a:bodyPr>
           <a:lstStyle>
@@ -3854,7 +3946,7 @@
             </a:lvl9pPr>
           </a:lstStyle>
           <a:p>
-            <a:pPr indent="0" lvl="0" marL="0" rtl="0" algn="r">
+            <a:pPr marL="0" lvl="0" indent="0" algn="r" rtl="0">
               <a:spcBef>
                 <a:spcPts val="0"/>
               </a:spcBef>
@@ -3880,18 +3972,19 @@
 </file>
 
 <file path=ppt/slideLayouts/slideLayout7.xml><?xml version="1.0" encoding="utf-8"?>
-<p:sldLayout xmlns:a="http://schemas.openxmlformats.org/drawingml/2006/main" xmlns:r="http://schemas.openxmlformats.org/officeDocument/2006/relationships" xmlns:mc="http://schemas.openxmlformats.org/markup-compatibility/2006" xmlns:mv="urn:schemas-microsoft-com:mac:vml" xmlns:p="http://schemas.openxmlformats.org/presentationml/2006/main" xmlns:c="http://schemas.openxmlformats.org/drawingml/2006/chart" xmlns:dgm="http://schemas.openxmlformats.org/drawingml/2006/diagram" xmlns:o="urn:schemas-microsoft-com:office:office" xmlns:v="urn:schemas-microsoft-com:vml" xmlns:pvml="urn:schemas-microsoft-com:office:powerpoint" xmlns:com="http://schemas.openxmlformats.org/drawingml/2006/compatibility" xmlns:p14="http://schemas.microsoft.com/office/powerpoint/2010/main" xmlns:p15="http://schemas.microsoft.com/office/powerpoint/2012/main" xmlns:ahyp="http://schemas.microsoft.com/office/drawing/2018/hyperlinkcolor" matchingName="Main point">
+<p:sldLayout xmlns:a="http://schemas.openxmlformats.org/drawingml/2006/main" xmlns:r="http://schemas.openxmlformats.org/officeDocument/2006/relationships" xmlns:p="http://schemas.openxmlformats.org/presentationml/2006/main" matchingName="Main point">
   <p:cSld name="MAIN_POINT">
     <p:bg>
       <p:bgPr>
         <a:solidFill>
           <a:schemeClr val="lt2"/>
         </a:solidFill>
+        <a:effectLst/>
       </p:bgPr>
     </p:bg>
     <p:spTree>
       <p:nvGrpSpPr>
-        <p:cNvPr id="35" name="Shape 35"/>
+        <p:cNvPr id="1" name="Shape 35"/>
         <p:cNvGrpSpPr/>
         <p:nvPr/>
       </p:nvGrpSpPr>
@@ -3906,7 +3999,9 @@
       <p:sp>
         <p:nvSpPr>
           <p:cNvPr id="36" name="Google Shape;36;p8"/>
-          <p:cNvSpPr txBox="1"/>
+          <p:cNvSpPr txBox="1">
+            <a:spLocks noGrp="1"/>
+          </p:cNvSpPr>
           <p:nvPr>
             <p:ph type="title"/>
           </p:nvPr>
@@ -3921,7 +4016,7 @@
           </a:prstGeom>
         </p:spPr>
         <p:txBody>
-          <a:bodyPr anchorCtr="0" anchor="ctr" bIns="91425" lIns="91425" spcFirstLastPara="1" rIns="91425" wrap="square" tIns="91425">
+          <a:bodyPr spcFirstLastPara="1" wrap="square" lIns="91425" tIns="91425" rIns="91425" bIns="91425" anchor="ctr" anchorCtr="0">
             <a:normAutofit/>
           </a:bodyPr>
           <a:lstStyle>
@@ -4025,15 +4120,19 @@
               <a:defRPr sz="4800"/>
             </a:lvl9pPr>
           </a:lstStyle>
-          <a:p/>
+          <a:p>
+            <a:endParaRPr/>
+          </a:p>
         </p:txBody>
       </p:sp>
       <p:sp>
         <p:nvSpPr>
           <p:cNvPr id="37" name="Google Shape;37;p8"/>
-          <p:cNvSpPr txBox="1"/>
+          <p:cNvSpPr txBox="1">
+            <a:spLocks noGrp="1"/>
+          </p:cNvSpPr>
           <p:nvPr>
-            <p:ph idx="12" type="sldNum"/>
+            <p:ph type="sldNum" idx="12"/>
           </p:nvPr>
         </p:nvSpPr>
         <p:spPr>
@@ -4046,7 +4145,7 @@
           </a:prstGeom>
         </p:spPr>
         <p:txBody>
-          <a:bodyPr anchorCtr="0" anchor="ctr" bIns="91425" lIns="91425" spcFirstLastPara="1" rIns="91425" wrap="square" tIns="91425">
+          <a:bodyPr spcFirstLastPara="1" wrap="square" lIns="91425" tIns="91425" rIns="91425" bIns="91425" anchor="ctr" anchorCtr="0">
             <a:normAutofit/>
           </a:bodyPr>
           <a:lstStyle>
@@ -4088,7 +4187,7 @@
             </a:lvl9pPr>
           </a:lstStyle>
           <a:p>
-            <a:pPr indent="0" lvl="0" marL="0" rtl="0" algn="r">
+            <a:pPr marL="0" lvl="0" indent="0" algn="r" rtl="0">
               <a:spcBef>
                 <a:spcPts val="0"/>
               </a:spcBef>
@@ -4114,11 +4213,11 @@
 </file>
 
 <file path=ppt/slideLayouts/slideLayout8.xml><?xml version="1.0" encoding="utf-8"?>
-<p:sldLayout xmlns:a="http://schemas.openxmlformats.org/drawingml/2006/main" xmlns:r="http://schemas.openxmlformats.org/officeDocument/2006/relationships" xmlns:mc="http://schemas.openxmlformats.org/markup-compatibility/2006" xmlns:mv="urn:schemas-microsoft-com:mac:vml" xmlns:p="http://schemas.openxmlformats.org/presentationml/2006/main" xmlns:c="http://schemas.openxmlformats.org/drawingml/2006/chart" xmlns:dgm="http://schemas.openxmlformats.org/drawingml/2006/diagram" xmlns:o="urn:schemas-microsoft-com:office:office" xmlns:v="urn:schemas-microsoft-com:vml" xmlns:pvml="urn:schemas-microsoft-com:office:powerpoint" xmlns:com="http://schemas.openxmlformats.org/drawingml/2006/compatibility" xmlns:p14="http://schemas.microsoft.com/office/powerpoint/2010/main" xmlns:p15="http://schemas.microsoft.com/office/powerpoint/2012/main" xmlns:ahyp="http://schemas.microsoft.com/office/drawing/2018/hyperlinkcolor" matchingName="Section title and description">
+<p:sldLayout xmlns:a="http://schemas.openxmlformats.org/drawingml/2006/main" xmlns:r="http://schemas.openxmlformats.org/officeDocument/2006/relationships" xmlns:p="http://schemas.openxmlformats.org/presentationml/2006/main" matchingName="Section title and description">
   <p:cSld name="SECTION_TITLE_AND_DESCRIPTION">
     <p:spTree>
       <p:nvGrpSpPr>
-        <p:cNvPr id="38" name="Shape 38"/>
+        <p:cNvPr id="1" name="Shape 38"/>
         <p:cNvGrpSpPr/>
         <p:nvPr/>
       </p:nvGrpSpPr>
@@ -4152,12 +4251,12 @@
           </a:ln>
         </p:spPr>
         <p:txBody>
-          <a:bodyPr anchorCtr="0" anchor="ctr" bIns="91425" lIns="91425" spcFirstLastPara="1" rIns="91425" wrap="square" tIns="91425">
+          <a:bodyPr spcFirstLastPara="1" wrap="square" lIns="91425" tIns="91425" rIns="91425" bIns="91425" anchor="ctr" anchorCtr="0">
             <a:noAutofit/>
           </a:bodyPr>
           <a:lstStyle/>
           <a:p>
-            <a:pPr indent="0" lvl="0" marL="0" rtl="0" algn="l">
+            <a:pPr marL="0" lvl="0" indent="0" algn="l" rtl="0">
               <a:spcBef>
                 <a:spcPts val="0"/>
               </a:spcBef>
@@ -4166,9 +4265,6 @@
               </a:spcAft>
               <a:buNone/>
             </a:pPr>
-            <a:r>
-              <a:t/>
-            </a:r>
             <a:endParaRPr/>
           </a:p>
         </p:txBody>
@@ -4188,21 +4284,23 @@
             <a:avLst/>
           </a:prstGeom>
           <a:noFill/>
-          <a:ln cap="flat" cmpd="sng" w="19050">
+          <a:ln w="19050" cap="flat" cmpd="sng">
             <a:solidFill>
               <a:schemeClr val="lt2"/>
             </a:solidFill>
             <a:prstDash val="solid"/>
             <a:round/>
-            <a:headEnd len="sm" w="sm" type="none"/>
-            <a:tailEnd len="sm" w="sm" type="none"/>
+            <a:headEnd type="none" w="sm" len="sm"/>
+            <a:tailEnd type="none" w="sm" len="sm"/>
           </a:ln>
         </p:spPr>
       </p:cxnSp>
       <p:sp>
         <p:nvSpPr>
           <p:cNvPr id="41" name="Google Shape;41;p9"/>
-          <p:cNvSpPr txBox="1"/>
+          <p:cNvSpPr txBox="1">
+            <a:spLocks noGrp="1"/>
+          </p:cNvSpPr>
           <p:nvPr>
             <p:ph type="title"/>
           </p:nvPr>
@@ -4217,7 +4315,7 @@
           </a:prstGeom>
         </p:spPr>
         <p:txBody>
-          <a:bodyPr anchorCtr="0" anchor="b" bIns="91425" lIns="91425" spcFirstLastPara="1" rIns="91425" wrap="square" tIns="91425">
+          <a:bodyPr spcFirstLastPara="1" wrap="square" lIns="91425" tIns="91425" rIns="91425" bIns="91425" anchor="b" anchorCtr="0">
             <a:normAutofit/>
           </a:bodyPr>
           <a:lstStyle>
@@ -4321,15 +4419,19 @@
               <a:defRPr sz="4200"/>
             </a:lvl9pPr>
           </a:lstStyle>
-          <a:p/>
+          <a:p>
+            <a:endParaRPr/>
+          </a:p>
         </p:txBody>
       </p:sp>
       <p:sp>
         <p:nvSpPr>
           <p:cNvPr id="42" name="Google Shape;42;p9"/>
-          <p:cNvSpPr txBox="1"/>
+          <p:cNvSpPr txBox="1">
+            <a:spLocks noGrp="1"/>
+          </p:cNvSpPr>
           <p:nvPr>
-            <p:ph idx="1" type="subTitle"/>
+            <p:ph type="subTitle" idx="1"/>
           </p:nvPr>
         </p:nvSpPr>
         <p:spPr>
@@ -4342,7 +4444,7 @@
           </a:prstGeom>
         </p:spPr>
         <p:txBody>
-          <a:bodyPr anchorCtr="0" anchor="t" bIns="91425" lIns="91425" spcFirstLastPara="1" rIns="91425" wrap="square" tIns="91425">
+          <a:bodyPr spcFirstLastPara="1" wrap="square" lIns="91425" tIns="91425" rIns="91425" bIns="91425" anchor="t" anchorCtr="0">
             <a:normAutofit/>
           </a:bodyPr>
           <a:lstStyle>
@@ -4473,15 +4575,19 @@
               <a:defRPr sz="2100"/>
             </a:lvl9pPr>
           </a:lstStyle>
-          <a:p/>
+          <a:p>
+            <a:endParaRPr/>
+          </a:p>
         </p:txBody>
       </p:sp>
       <p:sp>
         <p:nvSpPr>
           <p:cNvPr id="43" name="Google Shape;43;p9"/>
-          <p:cNvSpPr txBox="1"/>
+          <p:cNvSpPr txBox="1">
+            <a:spLocks noGrp="1"/>
+          </p:cNvSpPr>
           <p:nvPr>
-            <p:ph idx="2" type="body"/>
+            <p:ph type="body" idx="2"/>
           </p:nvPr>
         </p:nvSpPr>
         <p:spPr>
@@ -4494,11 +4600,11 @@
           </a:prstGeom>
         </p:spPr>
         <p:txBody>
-          <a:bodyPr anchorCtr="0" anchor="ctr" bIns="91425" lIns="91425" spcFirstLastPara="1" rIns="91425" wrap="square" tIns="91425">
+          <a:bodyPr spcFirstLastPara="1" wrap="square" lIns="91425" tIns="91425" rIns="91425" bIns="91425" anchor="ctr" anchorCtr="0">
             <a:normAutofit/>
           </a:bodyPr>
           <a:lstStyle>
-            <a:lvl1pPr indent="-342900" lvl="0" marL="457200">
+            <a:lvl1pPr marL="457200" lvl="0" indent="-342900">
               <a:spcBef>
                 <a:spcPts val="0"/>
               </a:spcBef>
@@ -4516,7 +4622,7 @@
                 </a:solidFill>
               </a:defRPr>
             </a:lvl1pPr>
-            <a:lvl2pPr indent="-317500" lvl="1" marL="914400">
+            <a:lvl2pPr marL="914400" lvl="1" indent="-317500">
               <a:spcBef>
                 <a:spcPts val="0"/>
               </a:spcBef>
@@ -4534,7 +4640,7 @@
                 </a:solidFill>
               </a:defRPr>
             </a:lvl2pPr>
-            <a:lvl3pPr indent="-317500" lvl="2" marL="1371600">
+            <a:lvl3pPr marL="1371600" lvl="2" indent="-317500">
               <a:spcBef>
                 <a:spcPts val="0"/>
               </a:spcBef>
@@ -4552,7 +4658,7 @@
                 </a:solidFill>
               </a:defRPr>
             </a:lvl3pPr>
-            <a:lvl4pPr indent="-317500" lvl="3" marL="1828800">
+            <a:lvl4pPr marL="1828800" lvl="3" indent="-317500">
               <a:spcBef>
                 <a:spcPts val="0"/>
               </a:spcBef>
@@ -4570,7 +4676,7 @@
                 </a:solidFill>
               </a:defRPr>
             </a:lvl4pPr>
-            <a:lvl5pPr indent="-317500" lvl="4" marL="2286000">
+            <a:lvl5pPr marL="2286000" lvl="4" indent="-317500">
               <a:spcBef>
                 <a:spcPts val="0"/>
               </a:spcBef>
@@ -4588,7 +4694,7 @@
                 </a:solidFill>
               </a:defRPr>
             </a:lvl5pPr>
-            <a:lvl6pPr indent="-317500" lvl="5" marL="2743200">
+            <a:lvl6pPr marL="2743200" lvl="5" indent="-317500">
               <a:spcBef>
                 <a:spcPts val="0"/>
               </a:spcBef>
@@ -4606,7 +4712,7 @@
                 </a:solidFill>
               </a:defRPr>
             </a:lvl6pPr>
-            <a:lvl7pPr indent="-317500" lvl="6" marL="3200400">
+            <a:lvl7pPr marL="3200400" lvl="6" indent="-317500">
               <a:spcBef>
                 <a:spcPts val="0"/>
               </a:spcBef>
@@ -4624,7 +4730,7 @@
                 </a:solidFill>
               </a:defRPr>
             </a:lvl7pPr>
-            <a:lvl8pPr indent="-317500" lvl="7" marL="3657600">
+            <a:lvl8pPr marL="3657600" lvl="7" indent="-317500">
               <a:spcBef>
                 <a:spcPts val="0"/>
               </a:spcBef>
@@ -4642,7 +4748,7 @@
                 </a:solidFill>
               </a:defRPr>
             </a:lvl8pPr>
-            <a:lvl9pPr indent="-317500" lvl="8" marL="4114800">
+            <a:lvl9pPr marL="4114800" lvl="8" indent="-317500">
               <a:spcBef>
                 <a:spcPts val="0"/>
               </a:spcBef>
@@ -4661,15 +4767,19 @@
               </a:defRPr>
             </a:lvl9pPr>
           </a:lstStyle>
-          <a:p/>
+          <a:p>
+            <a:endParaRPr/>
+          </a:p>
         </p:txBody>
       </p:sp>
       <p:sp>
         <p:nvSpPr>
           <p:cNvPr id="44" name="Google Shape;44;p9"/>
-          <p:cNvSpPr txBox="1"/>
+          <p:cNvSpPr txBox="1">
+            <a:spLocks noGrp="1"/>
+          </p:cNvSpPr>
           <p:nvPr>
-            <p:ph idx="12" type="sldNum"/>
+            <p:ph type="sldNum" idx="12"/>
           </p:nvPr>
         </p:nvSpPr>
         <p:spPr>
@@ -4682,7 +4792,7 @@
           </a:prstGeom>
         </p:spPr>
         <p:txBody>
-          <a:bodyPr anchorCtr="0" anchor="ctr" bIns="91425" lIns="91425" spcFirstLastPara="1" rIns="91425" wrap="square" tIns="91425">
+          <a:bodyPr spcFirstLastPara="1" wrap="square" lIns="91425" tIns="91425" rIns="91425" bIns="91425" anchor="ctr" anchorCtr="0">
             <a:normAutofit/>
           </a:bodyPr>
           <a:lstStyle>
@@ -4760,7 +4870,7 @@
             </a:lvl9pPr>
           </a:lstStyle>
           <a:p>
-            <a:pPr indent="0" lvl="0" marL="0" rtl="0" algn="r">
+            <a:pPr marL="0" lvl="0" indent="0" algn="r" rtl="0">
               <a:spcBef>
                 <a:spcPts val="0"/>
               </a:spcBef>
@@ -4786,11 +4896,11 @@
 </file>
 
 <file path=ppt/slideLayouts/slideLayout9.xml><?xml version="1.0" encoding="utf-8"?>
-<p:sldLayout xmlns:a="http://schemas.openxmlformats.org/drawingml/2006/main" xmlns:r="http://schemas.openxmlformats.org/officeDocument/2006/relationships" xmlns:mc="http://schemas.openxmlformats.org/markup-compatibility/2006" xmlns:mv="urn:schemas-microsoft-com:mac:vml" xmlns:p="http://schemas.openxmlformats.org/presentationml/2006/main" xmlns:c="http://schemas.openxmlformats.org/drawingml/2006/chart" xmlns:dgm="http://schemas.openxmlformats.org/drawingml/2006/diagram" xmlns:o="urn:schemas-microsoft-com:office:office" xmlns:v="urn:schemas-microsoft-com:vml" xmlns:pvml="urn:schemas-microsoft-com:office:powerpoint" xmlns:com="http://schemas.openxmlformats.org/drawingml/2006/compatibility" xmlns:p14="http://schemas.microsoft.com/office/powerpoint/2010/main" xmlns:p15="http://schemas.microsoft.com/office/powerpoint/2012/main" xmlns:ahyp="http://schemas.microsoft.com/office/drawing/2018/hyperlinkcolor" matchingName="Caption">
+<p:sldLayout xmlns:a="http://schemas.openxmlformats.org/drawingml/2006/main" xmlns:r="http://schemas.openxmlformats.org/officeDocument/2006/relationships" xmlns:p="http://schemas.openxmlformats.org/presentationml/2006/main" matchingName="Caption">
   <p:cSld name="CAPTION_ONLY">
     <p:spTree>
       <p:nvGrpSpPr>
-        <p:cNvPr id="45" name="Shape 45"/>
+        <p:cNvPr id="1" name="Shape 45"/>
         <p:cNvGrpSpPr/>
         <p:nvPr/>
       </p:nvGrpSpPr>
@@ -4805,9 +4915,11 @@
       <p:sp>
         <p:nvSpPr>
           <p:cNvPr id="46" name="Google Shape;46;p10"/>
-          <p:cNvSpPr txBox="1"/>
+          <p:cNvSpPr txBox="1">
+            <a:spLocks noGrp="1"/>
+          </p:cNvSpPr>
           <p:nvPr>
-            <p:ph idx="1" type="body"/>
+            <p:ph type="body" idx="1"/>
           </p:nvPr>
         </p:nvSpPr>
         <p:spPr>
@@ -4820,11 +4932,11 @@
           </a:prstGeom>
         </p:spPr>
         <p:txBody>
-          <a:bodyPr anchorCtr="0" anchor="ctr" bIns="91425" lIns="91425" spcFirstLastPara="1" rIns="91425" wrap="square" tIns="91425">
+          <a:bodyPr spcFirstLastPara="1" wrap="square" lIns="91425" tIns="91425" rIns="91425" bIns="91425" anchor="ctr" anchorCtr="0">
             <a:normAutofit/>
           </a:bodyPr>
           <a:lstStyle>
-            <a:lvl1pPr indent="-228600" lvl="0" marL="457200">
+            <a:lvl1pPr marL="457200" lvl="0" indent="-228600">
               <a:lnSpc>
                 <a:spcPct val="100000"/>
               </a:lnSpc>
@@ -4839,15 +4951,19 @@
               <a:defRPr sz="2100"/>
             </a:lvl1pPr>
           </a:lstStyle>
-          <a:p/>
+          <a:p>
+            <a:endParaRPr/>
+          </a:p>
         </p:txBody>
       </p:sp>
       <p:sp>
         <p:nvSpPr>
           <p:cNvPr id="47" name="Google Shape;47;p10"/>
-          <p:cNvSpPr txBox="1"/>
+          <p:cNvSpPr txBox="1">
+            <a:spLocks noGrp="1"/>
+          </p:cNvSpPr>
           <p:nvPr>
-            <p:ph idx="12" type="sldNum"/>
+            <p:ph type="sldNum" idx="12"/>
           </p:nvPr>
         </p:nvSpPr>
         <p:spPr>
@@ -4860,7 +4976,7 @@
           </a:prstGeom>
         </p:spPr>
         <p:txBody>
-          <a:bodyPr anchorCtr="0" anchor="ctr" bIns="91425" lIns="91425" spcFirstLastPara="1" rIns="91425" wrap="square" tIns="91425">
+          <a:bodyPr spcFirstLastPara="1" wrap="square" lIns="91425" tIns="91425" rIns="91425" bIns="91425" anchor="ctr" anchorCtr="0">
             <a:normAutofit/>
           </a:bodyPr>
           <a:lstStyle>
@@ -4902,7 +5018,7 @@
             </a:lvl9pPr>
           </a:lstStyle>
           <a:p>
-            <a:pPr indent="0" lvl="0" marL="0" rtl="0" algn="r">
+            <a:pPr marL="0" lvl="0" indent="0" algn="r" rtl="0">
               <a:spcBef>
                 <a:spcPts val="0"/>
               </a:spcBef>
@@ -4928,18 +5044,19 @@
 </file>
 
 <file path=ppt/slideMasters/slideMaster1.xml><?xml version="1.0" encoding="utf-8"?>
-<p:sldMaster xmlns:a="http://schemas.openxmlformats.org/drawingml/2006/main" xmlns:r="http://schemas.openxmlformats.org/officeDocument/2006/relationships" xmlns:mc="http://schemas.openxmlformats.org/markup-compatibility/2006" xmlns:mv="urn:schemas-microsoft-com:mac:vml" xmlns:p="http://schemas.openxmlformats.org/presentationml/2006/main" xmlns:c="http://schemas.openxmlformats.org/drawingml/2006/chart" xmlns:dgm="http://schemas.openxmlformats.org/drawingml/2006/diagram" xmlns:o="urn:schemas-microsoft-com:office:office" xmlns:v="urn:schemas-microsoft-com:vml" xmlns:pvml="urn:schemas-microsoft-com:office:powerpoint" xmlns:com="http://schemas.openxmlformats.org/drawingml/2006/compatibility" xmlns:p14="http://schemas.microsoft.com/office/powerpoint/2010/main" xmlns:p15="http://schemas.microsoft.com/office/powerpoint/2012/main" xmlns:ahyp="http://schemas.microsoft.com/office/drawing/2018/hyperlinkcolor">
+<p:sldMaster xmlns:a="http://schemas.openxmlformats.org/drawingml/2006/main" xmlns:r="http://schemas.openxmlformats.org/officeDocument/2006/relationships" xmlns:p="http://schemas.openxmlformats.org/presentationml/2006/main">
   <p:cSld name="spearmint">
     <p:bg>
       <p:bgPr>
         <a:solidFill>
           <a:schemeClr val="lt1"/>
         </a:solidFill>
+        <a:effectLst/>
       </p:bgPr>
     </p:bg>
     <p:spTree>
       <p:nvGrpSpPr>
-        <p:cNvPr id="5" name="Shape 5"/>
+        <p:cNvPr id="1" name="Shape 5"/>
         <p:cNvGrpSpPr/>
         <p:nvPr/>
       </p:nvGrpSpPr>
@@ -4954,7 +5071,9 @@
       <p:sp>
         <p:nvSpPr>
           <p:cNvPr id="6" name="Google Shape;6;p1"/>
-          <p:cNvSpPr txBox="1"/>
+          <p:cNvSpPr txBox="1">
+            <a:spLocks noGrp="1"/>
+          </p:cNvSpPr>
           <p:nvPr>
             <p:ph type="title"/>
           </p:nvPr>
@@ -4973,7 +5092,7 @@
           </a:ln>
         </p:spPr>
         <p:txBody>
-          <a:bodyPr anchorCtr="0" anchor="t" bIns="91425" lIns="91425" spcFirstLastPara="1" rIns="91425" wrap="square" tIns="91425">
+          <a:bodyPr spcFirstLastPara="1" wrap="square" lIns="91425" tIns="91425" rIns="91425" bIns="91425" anchor="t" anchorCtr="0">
             <a:normAutofit/>
           </a:bodyPr>
           <a:lstStyle>
@@ -5185,15 +5304,19 @@
               </a:defRPr>
             </a:lvl9pPr>
           </a:lstStyle>
-          <a:p/>
+          <a:p>
+            <a:endParaRPr/>
+          </a:p>
         </p:txBody>
       </p:sp>
       <p:sp>
         <p:nvSpPr>
           <p:cNvPr id="7" name="Google Shape;7;p1"/>
-          <p:cNvSpPr txBox="1"/>
+          <p:cNvSpPr txBox="1">
+            <a:spLocks noGrp="1"/>
+          </p:cNvSpPr>
           <p:nvPr>
-            <p:ph idx="1" type="body"/>
+            <p:ph type="body" idx="1"/>
           </p:nvPr>
         </p:nvSpPr>
         <p:spPr>
@@ -5210,11 +5333,11 @@
           </a:ln>
         </p:spPr>
         <p:txBody>
-          <a:bodyPr anchorCtr="0" anchor="t" bIns="91425" lIns="91425" spcFirstLastPara="1" rIns="91425" wrap="square" tIns="91425">
+          <a:bodyPr spcFirstLastPara="1" wrap="square" lIns="91425" tIns="91425" rIns="91425" bIns="91425" anchor="t" anchorCtr="0">
             <a:normAutofit/>
           </a:bodyPr>
           <a:lstStyle>
-            <a:lvl1pPr indent="-342900" lvl="0" marL="457200">
+            <a:lvl1pPr marL="457200" lvl="0" indent="-342900">
               <a:lnSpc>
                 <a:spcPct val="115000"/>
               </a:lnSpc>
@@ -5240,7 +5363,7 @@
                 <a:sym typeface="Proxima Nova"/>
               </a:defRPr>
             </a:lvl1pPr>
-            <a:lvl2pPr indent="-317500" lvl="1" marL="914400">
+            <a:lvl2pPr marL="914400" lvl="1" indent="-317500">
               <a:lnSpc>
                 <a:spcPct val="115000"/>
               </a:lnSpc>
@@ -5266,7 +5389,7 @@
                 <a:sym typeface="Proxima Nova"/>
               </a:defRPr>
             </a:lvl2pPr>
-            <a:lvl3pPr indent="-317500" lvl="2" marL="1371600">
+            <a:lvl3pPr marL="1371600" lvl="2" indent="-317500">
               <a:lnSpc>
                 <a:spcPct val="115000"/>
               </a:lnSpc>
@@ -5292,7 +5415,7 @@
                 <a:sym typeface="Proxima Nova"/>
               </a:defRPr>
             </a:lvl3pPr>
-            <a:lvl4pPr indent="-317500" lvl="3" marL="1828800">
+            <a:lvl4pPr marL="1828800" lvl="3" indent="-317500">
               <a:lnSpc>
                 <a:spcPct val="115000"/>
               </a:lnSpc>
@@ -5318,7 +5441,7 @@
                 <a:sym typeface="Proxima Nova"/>
               </a:defRPr>
             </a:lvl4pPr>
-            <a:lvl5pPr indent="-317500" lvl="4" marL="2286000">
+            <a:lvl5pPr marL="2286000" lvl="4" indent="-317500">
               <a:lnSpc>
                 <a:spcPct val="115000"/>
               </a:lnSpc>
@@ -5344,7 +5467,7 @@
                 <a:sym typeface="Proxima Nova"/>
               </a:defRPr>
             </a:lvl5pPr>
-            <a:lvl6pPr indent="-317500" lvl="5" marL="2743200">
+            <a:lvl6pPr marL="2743200" lvl="5" indent="-317500">
               <a:lnSpc>
                 <a:spcPct val="115000"/>
               </a:lnSpc>
@@ -5370,7 +5493,7 @@
                 <a:sym typeface="Proxima Nova"/>
               </a:defRPr>
             </a:lvl6pPr>
-            <a:lvl7pPr indent="-317500" lvl="6" marL="3200400">
+            <a:lvl7pPr marL="3200400" lvl="6" indent="-317500">
               <a:lnSpc>
                 <a:spcPct val="115000"/>
               </a:lnSpc>
@@ -5396,7 +5519,7 @@
                 <a:sym typeface="Proxima Nova"/>
               </a:defRPr>
             </a:lvl7pPr>
-            <a:lvl8pPr indent="-317500" lvl="7" marL="3657600">
+            <a:lvl8pPr marL="3657600" lvl="7" indent="-317500">
               <a:lnSpc>
                 <a:spcPct val="115000"/>
               </a:lnSpc>
@@ -5422,7 +5545,7 @@
                 <a:sym typeface="Proxima Nova"/>
               </a:defRPr>
             </a:lvl8pPr>
-            <a:lvl9pPr indent="-317500" lvl="8" marL="4114800">
+            <a:lvl9pPr marL="4114800" lvl="8" indent="-317500">
               <a:lnSpc>
                 <a:spcPct val="115000"/>
               </a:lnSpc>
@@ -5449,15 +5572,19 @@
               </a:defRPr>
             </a:lvl9pPr>
           </a:lstStyle>
-          <a:p/>
+          <a:p>
+            <a:endParaRPr/>
+          </a:p>
         </p:txBody>
       </p:sp>
       <p:sp>
         <p:nvSpPr>
           <p:cNvPr id="8" name="Google Shape;8;p1"/>
-          <p:cNvSpPr txBox="1"/>
+          <p:cNvSpPr txBox="1">
+            <a:spLocks noGrp="1"/>
+          </p:cNvSpPr>
           <p:nvPr>
-            <p:ph idx="12" type="sldNum"/>
+            <p:ph type="sldNum" idx="12"/>
           </p:nvPr>
         </p:nvSpPr>
         <p:spPr>
@@ -5474,7 +5601,7 @@
           </a:ln>
         </p:spPr>
         <p:txBody>
-          <a:bodyPr anchorCtr="0" anchor="ctr" bIns="91425" lIns="91425" spcFirstLastPara="1" rIns="91425" wrap="square" tIns="91425">
+          <a:bodyPr spcFirstLastPara="1" wrap="square" lIns="91425" tIns="91425" rIns="91425" bIns="91425" anchor="ctr" anchorCtr="0">
             <a:normAutofit/>
           </a:bodyPr>
           <a:lstStyle>
@@ -5588,7 +5715,7 @@
             </a:lvl9pPr>
           </a:lstStyle>
           <a:p>
-            <a:pPr indent="0" lvl="0" marL="0" rtl="0" algn="r">
+            <a:pPr marL="0" lvl="0" indent="0" algn="r" rtl="0">
               <a:spcBef>
                 <a:spcPts val="0"/>
               </a:spcBef>
@@ -5607,7 +5734,7 @@
       </p:sp>
     </p:spTree>
   </p:cSld>
-  <p:clrMap accent1="accent1" accent2="accent2" accent3="accent3" accent4="accent4" accent5="accent5" accent6="accent6" bg1="lt1" bg2="dk2" tx1="dk1" tx2="lt2" folHlink="folHlink" hlink="hlink"/>
+  <p:clrMap bg1="lt1" tx1="dk1" bg2="dk2" tx2="lt2" accent1="accent1" accent2="accent2" accent3="accent3" accent4="accent4" accent5="accent5" accent6="accent6" hlink="hlink" folHlink="folHlink"/>
   <p:sldLayoutIdLst>
     <p:sldLayoutId id="2147483648" r:id="rId1"/>
     <p:sldLayoutId id="2147483649" r:id="rId2"/>
@@ -5621,10 +5748,10 @@
     <p:sldLayoutId id="2147483657" r:id="rId10"/>
     <p:sldLayoutId id="2147483658" r:id="rId11"/>
   </p:sldLayoutIdLst>
-  <p:hf dt="0" ftr="0" hdr="0" sldNum="0"/>
+  <p:hf sldNum="0" hdr="0" ftr="0" dt="0"/>
   <p:txStyles>
     <p:titleStyle>
-      <a:defPPr lvl="0" marR="0" rtl="0" algn="l">
+      <a:defPPr marR="0" lvl="0" algn="l" rtl="0">
         <a:lnSpc>
           <a:spcPct val="100000"/>
         </a:lnSpc>
@@ -5635,7 +5762,7 @@
           <a:spcPts val="0"/>
         </a:spcAft>
       </a:defPPr>
-      <a:lvl1pPr lvl="0" marR="0" rtl="0" algn="l">
+      <a:lvl1pPr marR="0" lvl="0" algn="l" rtl="0">
         <a:lnSpc>
           <a:spcPct val="100000"/>
         </a:lnSpc>
@@ -5649,7 +5776,7 @@
           <a:srgbClr val="000000"/>
         </a:buClr>
         <a:buFont typeface="Arial"/>
-        <a:defRPr b="0" i="0" sz="1400" u="none" cap="none" strike="noStrike">
+        <a:defRPr sz="1400" b="0" i="0" u="none" strike="noStrike" cap="none">
           <a:solidFill>
             <a:srgbClr val="000000"/>
           </a:solidFill>
@@ -5659,7 +5786,7 @@
           <a:sym typeface="Arial"/>
         </a:defRPr>
       </a:lvl1pPr>
-      <a:lvl2pPr lvl="1" marR="0" rtl="0" algn="l">
+      <a:lvl2pPr marR="0" lvl="1" algn="l" rtl="0">
         <a:lnSpc>
           <a:spcPct val="100000"/>
         </a:lnSpc>
@@ -5673,7 +5800,7 @@
           <a:srgbClr val="000000"/>
         </a:buClr>
         <a:buFont typeface="Arial"/>
-        <a:defRPr b="0" i="0" sz="1400" u="none" cap="none" strike="noStrike">
+        <a:defRPr sz="1400" b="0" i="0" u="none" strike="noStrike" cap="none">
           <a:solidFill>
             <a:srgbClr val="000000"/>
           </a:solidFill>
@@ -5683,7 +5810,7 @@
           <a:sym typeface="Arial"/>
         </a:defRPr>
       </a:lvl2pPr>
-      <a:lvl3pPr lvl="2" marR="0" rtl="0" algn="l">
+      <a:lvl3pPr marR="0" lvl="2" algn="l" rtl="0">
         <a:lnSpc>
           <a:spcPct val="100000"/>
         </a:lnSpc>
@@ -5697,7 +5824,7 @@
           <a:srgbClr val="000000"/>
         </a:buClr>
         <a:buFont typeface="Arial"/>
-        <a:defRPr b="0" i="0" sz="1400" u="none" cap="none" strike="noStrike">
+        <a:defRPr sz="1400" b="0" i="0" u="none" strike="noStrike" cap="none">
           <a:solidFill>
             <a:srgbClr val="000000"/>
           </a:solidFill>
@@ -5707,7 +5834,7 @@
           <a:sym typeface="Arial"/>
         </a:defRPr>
       </a:lvl3pPr>
-      <a:lvl4pPr lvl="3" marR="0" rtl="0" algn="l">
+      <a:lvl4pPr marR="0" lvl="3" algn="l" rtl="0">
         <a:lnSpc>
           <a:spcPct val="100000"/>
         </a:lnSpc>
@@ -5721,7 +5848,7 @@
           <a:srgbClr val="000000"/>
         </a:buClr>
         <a:buFont typeface="Arial"/>
-        <a:defRPr b="0" i="0" sz="1400" u="none" cap="none" strike="noStrike">
+        <a:defRPr sz="1400" b="0" i="0" u="none" strike="noStrike" cap="none">
           <a:solidFill>
             <a:srgbClr val="000000"/>
           </a:solidFill>
@@ -5731,7 +5858,7 @@
           <a:sym typeface="Arial"/>
         </a:defRPr>
       </a:lvl4pPr>
-      <a:lvl5pPr lvl="4" marR="0" rtl="0" algn="l">
+      <a:lvl5pPr marR="0" lvl="4" algn="l" rtl="0">
         <a:lnSpc>
           <a:spcPct val="100000"/>
         </a:lnSpc>
@@ -5745,7 +5872,7 @@
           <a:srgbClr val="000000"/>
         </a:buClr>
         <a:buFont typeface="Arial"/>
-        <a:defRPr b="0" i="0" sz="1400" u="none" cap="none" strike="noStrike">
+        <a:defRPr sz="1400" b="0" i="0" u="none" strike="noStrike" cap="none">
           <a:solidFill>
             <a:srgbClr val="000000"/>
           </a:solidFill>
@@ -5755,7 +5882,7 @@
           <a:sym typeface="Arial"/>
         </a:defRPr>
       </a:lvl5pPr>
-      <a:lvl6pPr lvl="5" marR="0" rtl="0" algn="l">
+      <a:lvl6pPr marR="0" lvl="5" algn="l" rtl="0">
         <a:lnSpc>
           <a:spcPct val="100000"/>
         </a:lnSpc>
@@ -5769,7 +5896,7 @@
           <a:srgbClr val="000000"/>
         </a:buClr>
         <a:buFont typeface="Arial"/>
-        <a:defRPr b="0" i="0" sz="1400" u="none" cap="none" strike="noStrike">
+        <a:defRPr sz="1400" b="0" i="0" u="none" strike="noStrike" cap="none">
           <a:solidFill>
             <a:srgbClr val="000000"/>
           </a:solidFill>
@@ -5779,7 +5906,7 @@
           <a:sym typeface="Arial"/>
         </a:defRPr>
       </a:lvl6pPr>
-      <a:lvl7pPr lvl="6" marR="0" rtl="0" algn="l">
+      <a:lvl7pPr marR="0" lvl="6" algn="l" rtl="0">
         <a:lnSpc>
           <a:spcPct val="100000"/>
         </a:lnSpc>
@@ -5793,7 +5920,7 @@
           <a:srgbClr val="000000"/>
         </a:buClr>
         <a:buFont typeface="Arial"/>
-        <a:defRPr b="0" i="0" sz="1400" u="none" cap="none" strike="noStrike">
+        <a:defRPr sz="1400" b="0" i="0" u="none" strike="noStrike" cap="none">
           <a:solidFill>
             <a:srgbClr val="000000"/>
           </a:solidFill>
@@ -5803,7 +5930,7 @@
           <a:sym typeface="Arial"/>
         </a:defRPr>
       </a:lvl7pPr>
-      <a:lvl8pPr lvl="7" marR="0" rtl="0" algn="l">
+      <a:lvl8pPr marR="0" lvl="7" algn="l" rtl="0">
         <a:lnSpc>
           <a:spcPct val="100000"/>
         </a:lnSpc>
@@ -5817,7 +5944,7 @@
           <a:srgbClr val="000000"/>
         </a:buClr>
         <a:buFont typeface="Arial"/>
-        <a:defRPr b="0" i="0" sz="1400" u="none" cap="none" strike="noStrike">
+        <a:defRPr sz="1400" b="0" i="0" u="none" strike="noStrike" cap="none">
           <a:solidFill>
             <a:srgbClr val="000000"/>
           </a:solidFill>
@@ -5827,7 +5954,7 @@
           <a:sym typeface="Arial"/>
         </a:defRPr>
       </a:lvl8pPr>
-      <a:lvl9pPr lvl="8" marR="0" rtl="0" algn="l">
+      <a:lvl9pPr marR="0" lvl="8" algn="l" rtl="0">
         <a:lnSpc>
           <a:spcPct val="100000"/>
         </a:lnSpc>
@@ -5841,7 +5968,7 @@
           <a:srgbClr val="000000"/>
         </a:buClr>
         <a:buFont typeface="Arial"/>
-        <a:defRPr b="0" i="0" sz="1400" u="none" cap="none" strike="noStrike">
+        <a:defRPr sz="1400" b="0" i="0" u="none" strike="noStrike" cap="none">
           <a:solidFill>
             <a:srgbClr val="000000"/>
           </a:solidFill>
@@ -5853,7 +5980,7 @@
       </a:lvl9pPr>
     </p:titleStyle>
     <p:bodyStyle>
-      <a:defPPr lvl="0" marR="0" rtl="0" algn="l">
+      <a:defPPr marR="0" lvl="0" algn="l" rtl="0">
         <a:lnSpc>
           <a:spcPct val="100000"/>
         </a:lnSpc>
@@ -5864,7 +5991,7 @@
           <a:spcPts val="0"/>
         </a:spcAft>
       </a:defPPr>
-      <a:lvl1pPr lvl="0" marR="0" rtl="0" algn="l">
+      <a:lvl1pPr marR="0" lvl="0" algn="l" rtl="0">
         <a:lnSpc>
           <a:spcPct val="100000"/>
         </a:lnSpc>
@@ -5878,7 +6005,7 @@
           <a:srgbClr val="000000"/>
         </a:buClr>
         <a:buFont typeface="Arial"/>
-        <a:defRPr b="0" i="0" sz="1400" u="none" cap="none" strike="noStrike">
+        <a:defRPr sz="1400" b="0" i="0" u="none" strike="noStrike" cap="none">
           <a:solidFill>
             <a:srgbClr val="000000"/>
           </a:solidFill>
@@ -5888,7 +6015,7 @@
           <a:sym typeface="Arial"/>
         </a:defRPr>
       </a:lvl1pPr>
-      <a:lvl2pPr lvl="1" marR="0" rtl="0" algn="l">
+      <a:lvl2pPr marR="0" lvl="1" algn="l" rtl="0">
         <a:lnSpc>
           <a:spcPct val="100000"/>
         </a:lnSpc>
@@ -5902,7 +6029,7 @@
           <a:srgbClr val="000000"/>
         </a:buClr>
         <a:buFont typeface="Arial"/>
-        <a:defRPr b="0" i="0" sz="1400" u="none" cap="none" strike="noStrike">
+        <a:defRPr sz="1400" b="0" i="0" u="none" strike="noStrike" cap="none">
           <a:solidFill>
             <a:srgbClr val="000000"/>
           </a:solidFill>
@@ -5912,7 +6039,7 @@
           <a:sym typeface="Arial"/>
         </a:defRPr>
       </a:lvl2pPr>
-      <a:lvl3pPr lvl="2" marR="0" rtl="0" algn="l">
+      <a:lvl3pPr marR="0" lvl="2" algn="l" rtl="0">
         <a:lnSpc>
           <a:spcPct val="100000"/>
         </a:lnSpc>
@@ -5926,7 +6053,7 @@
           <a:srgbClr val="000000"/>
         </a:buClr>
         <a:buFont typeface="Arial"/>
-        <a:defRPr b="0" i="0" sz="1400" u="none" cap="none" strike="noStrike">
+        <a:defRPr sz="1400" b="0" i="0" u="none" strike="noStrike" cap="none">
           <a:solidFill>
             <a:srgbClr val="000000"/>
           </a:solidFill>
@@ -5936,7 +6063,7 @@
           <a:sym typeface="Arial"/>
         </a:defRPr>
       </a:lvl3pPr>
-      <a:lvl4pPr lvl="3" marR="0" rtl="0" algn="l">
+      <a:lvl4pPr marR="0" lvl="3" algn="l" rtl="0">
         <a:lnSpc>
           <a:spcPct val="100000"/>
         </a:lnSpc>
@@ -5950,7 +6077,7 @@
           <a:srgbClr val="000000"/>
         </a:buClr>
         <a:buFont typeface="Arial"/>
-        <a:defRPr b="0" i="0" sz="1400" u="none" cap="none" strike="noStrike">
+        <a:defRPr sz="1400" b="0" i="0" u="none" strike="noStrike" cap="none">
           <a:solidFill>
             <a:srgbClr val="000000"/>
           </a:solidFill>
@@ -5960,7 +6087,7 @@
           <a:sym typeface="Arial"/>
         </a:defRPr>
       </a:lvl4pPr>
-      <a:lvl5pPr lvl="4" marR="0" rtl="0" algn="l">
+      <a:lvl5pPr marR="0" lvl="4" algn="l" rtl="0">
         <a:lnSpc>
           <a:spcPct val="100000"/>
         </a:lnSpc>
@@ -5974,7 +6101,7 @@
           <a:srgbClr val="000000"/>
         </a:buClr>
         <a:buFont typeface="Arial"/>
-        <a:defRPr b="0" i="0" sz="1400" u="none" cap="none" strike="noStrike">
+        <a:defRPr sz="1400" b="0" i="0" u="none" strike="noStrike" cap="none">
           <a:solidFill>
             <a:srgbClr val="000000"/>
           </a:solidFill>
@@ -5984,7 +6111,7 @@
           <a:sym typeface="Arial"/>
         </a:defRPr>
       </a:lvl5pPr>
-      <a:lvl6pPr lvl="5" marR="0" rtl="0" algn="l">
+      <a:lvl6pPr marR="0" lvl="5" algn="l" rtl="0">
         <a:lnSpc>
           <a:spcPct val="100000"/>
         </a:lnSpc>
@@ -5998,7 +6125,7 @@
           <a:srgbClr val="000000"/>
         </a:buClr>
         <a:buFont typeface="Arial"/>
-        <a:defRPr b="0" i="0" sz="1400" u="none" cap="none" strike="noStrike">
+        <a:defRPr sz="1400" b="0" i="0" u="none" strike="noStrike" cap="none">
           <a:solidFill>
             <a:srgbClr val="000000"/>
           </a:solidFill>
@@ -6008,7 +6135,7 @@
           <a:sym typeface="Arial"/>
         </a:defRPr>
       </a:lvl6pPr>
-      <a:lvl7pPr lvl="6" marR="0" rtl="0" algn="l">
+      <a:lvl7pPr marR="0" lvl="6" algn="l" rtl="0">
         <a:lnSpc>
           <a:spcPct val="100000"/>
         </a:lnSpc>
@@ -6022,7 +6149,7 @@
           <a:srgbClr val="000000"/>
         </a:buClr>
         <a:buFont typeface="Arial"/>
-        <a:defRPr b="0" i="0" sz="1400" u="none" cap="none" strike="noStrike">
+        <a:defRPr sz="1400" b="0" i="0" u="none" strike="noStrike" cap="none">
           <a:solidFill>
             <a:srgbClr val="000000"/>
           </a:solidFill>
@@ -6032,7 +6159,7 @@
           <a:sym typeface="Arial"/>
         </a:defRPr>
       </a:lvl7pPr>
-      <a:lvl8pPr lvl="7" marR="0" rtl="0" algn="l">
+      <a:lvl8pPr marR="0" lvl="7" algn="l" rtl="0">
         <a:lnSpc>
           <a:spcPct val="100000"/>
         </a:lnSpc>
@@ -6046,7 +6173,7 @@
           <a:srgbClr val="000000"/>
         </a:buClr>
         <a:buFont typeface="Arial"/>
-        <a:defRPr b="0" i="0" sz="1400" u="none" cap="none" strike="noStrike">
+        <a:defRPr sz="1400" b="0" i="0" u="none" strike="noStrike" cap="none">
           <a:solidFill>
             <a:srgbClr val="000000"/>
           </a:solidFill>
@@ -6056,7 +6183,7 @@
           <a:sym typeface="Arial"/>
         </a:defRPr>
       </a:lvl8pPr>
-      <a:lvl9pPr lvl="8" marR="0" rtl="0" algn="l">
+      <a:lvl9pPr marR="0" lvl="8" algn="l" rtl="0">
         <a:lnSpc>
           <a:spcPct val="100000"/>
         </a:lnSpc>
@@ -6070,7 +6197,7 @@
           <a:srgbClr val="000000"/>
         </a:buClr>
         <a:buFont typeface="Arial"/>
-        <a:defRPr b="0" i="0" sz="1400" u="none" cap="none" strike="noStrike">
+        <a:defRPr sz="1400" b="0" i="0" u="none" strike="noStrike" cap="none">
           <a:solidFill>
             <a:srgbClr val="000000"/>
           </a:solidFill>
@@ -6082,7 +6209,7 @@
       </a:lvl9pPr>
     </p:bodyStyle>
     <p:otherStyle>
-      <a:defPPr lvl="0" marR="0" rtl="0" algn="l">
+      <a:defPPr marR="0" lvl="0" algn="l" rtl="0">
         <a:lnSpc>
           <a:spcPct val="100000"/>
         </a:lnSpc>
@@ -6093,7 +6220,7 @@
           <a:spcPts val="0"/>
         </a:spcAft>
       </a:defPPr>
-      <a:lvl1pPr lvl="0" marR="0" rtl="0" algn="l">
+      <a:lvl1pPr marR="0" lvl="0" algn="l" rtl="0">
         <a:lnSpc>
           <a:spcPct val="100000"/>
         </a:lnSpc>
@@ -6107,7 +6234,7 @@
           <a:srgbClr val="000000"/>
         </a:buClr>
         <a:buFont typeface="Arial"/>
-        <a:defRPr b="0" i="0" sz="1400" u="none" cap="none" strike="noStrike">
+        <a:defRPr sz="1400" b="0" i="0" u="none" strike="noStrike" cap="none">
           <a:solidFill>
             <a:srgbClr val="000000"/>
           </a:solidFill>
@@ -6117,7 +6244,7 @@
           <a:sym typeface="Arial"/>
         </a:defRPr>
       </a:lvl1pPr>
-      <a:lvl2pPr lvl="1" marR="0" rtl="0" algn="l">
+      <a:lvl2pPr marR="0" lvl="1" algn="l" rtl="0">
         <a:lnSpc>
           <a:spcPct val="100000"/>
         </a:lnSpc>
@@ -6131,7 +6258,7 @@
           <a:srgbClr val="000000"/>
         </a:buClr>
         <a:buFont typeface="Arial"/>
-        <a:defRPr b="0" i="0" sz="1400" u="none" cap="none" strike="noStrike">
+        <a:defRPr sz="1400" b="0" i="0" u="none" strike="noStrike" cap="none">
           <a:solidFill>
             <a:srgbClr val="000000"/>
           </a:solidFill>
@@ -6141,7 +6268,7 @@
           <a:sym typeface="Arial"/>
         </a:defRPr>
       </a:lvl2pPr>
-      <a:lvl3pPr lvl="2" marR="0" rtl="0" algn="l">
+      <a:lvl3pPr marR="0" lvl="2" algn="l" rtl="0">
         <a:lnSpc>
           <a:spcPct val="100000"/>
         </a:lnSpc>
@@ -6155,7 +6282,7 @@
           <a:srgbClr val="000000"/>
         </a:buClr>
         <a:buFont typeface="Arial"/>
-        <a:defRPr b="0" i="0" sz="1400" u="none" cap="none" strike="noStrike">
+        <a:defRPr sz="1400" b="0" i="0" u="none" strike="noStrike" cap="none">
           <a:solidFill>
             <a:srgbClr val="000000"/>
           </a:solidFill>
@@ -6165,7 +6292,7 @@
           <a:sym typeface="Arial"/>
         </a:defRPr>
       </a:lvl3pPr>
-      <a:lvl4pPr lvl="3" marR="0" rtl="0" algn="l">
+      <a:lvl4pPr marR="0" lvl="3" algn="l" rtl="0">
         <a:lnSpc>
           <a:spcPct val="100000"/>
         </a:lnSpc>
@@ -6179,7 +6306,7 @@
           <a:srgbClr val="000000"/>
         </a:buClr>
         <a:buFont typeface="Arial"/>
-        <a:defRPr b="0" i="0" sz="1400" u="none" cap="none" strike="noStrike">
+        <a:defRPr sz="1400" b="0" i="0" u="none" strike="noStrike" cap="none">
           <a:solidFill>
             <a:srgbClr val="000000"/>
           </a:solidFill>
@@ -6189,7 +6316,7 @@
           <a:sym typeface="Arial"/>
         </a:defRPr>
       </a:lvl4pPr>
-      <a:lvl5pPr lvl="4" marR="0" rtl="0" algn="l">
+      <a:lvl5pPr marR="0" lvl="4" algn="l" rtl="0">
         <a:lnSpc>
           <a:spcPct val="100000"/>
         </a:lnSpc>
@@ -6203,7 +6330,7 @@
           <a:srgbClr val="000000"/>
         </a:buClr>
         <a:buFont typeface="Arial"/>
-        <a:defRPr b="0" i="0" sz="1400" u="none" cap="none" strike="noStrike">
+        <a:defRPr sz="1400" b="0" i="0" u="none" strike="noStrike" cap="none">
           <a:solidFill>
             <a:srgbClr val="000000"/>
           </a:solidFill>
@@ -6213,7 +6340,7 @@
           <a:sym typeface="Arial"/>
         </a:defRPr>
       </a:lvl5pPr>
-      <a:lvl6pPr lvl="5" marR="0" rtl="0" algn="l">
+      <a:lvl6pPr marR="0" lvl="5" algn="l" rtl="0">
         <a:lnSpc>
           <a:spcPct val="100000"/>
         </a:lnSpc>
@@ -6227,7 +6354,7 @@
           <a:srgbClr val="000000"/>
         </a:buClr>
         <a:buFont typeface="Arial"/>
-        <a:defRPr b="0" i="0" sz="1400" u="none" cap="none" strike="noStrike">
+        <a:defRPr sz="1400" b="0" i="0" u="none" strike="noStrike" cap="none">
           <a:solidFill>
             <a:srgbClr val="000000"/>
           </a:solidFill>
@@ -6237,7 +6364,7 @@
           <a:sym typeface="Arial"/>
         </a:defRPr>
       </a:lvl6pPr>
-      <a:lvl7pPr lvl="6" marR="0" rtl="0" algn="l">
+      <a:lvl7pPr marR="0" lvl="6" algn="l" rtl="0">
         <a:lnSpc>
           <a:spcPct val="100000"/>
         </a:lnSpc>
@@ -6251,7 +6378,7 @@
           <a:srgbClr val="000000"/>
         </a:buClr>
         <a:buFont typeface="Arial"/>
-        <a:defRPr b="0" i="0" sz="1400" u="none" cap="none" strike="noStrike">
+        <a:defRPr sz="1400" b="0" i="0" u="none" strike="noStrike" cap="none">
           <a:solidFill>
             <a:srgbClr val="000000"/>
           </a:solidFill>
@@ -6261,7 +6388,7 @@
           <a:sym typeface="Arial"/>
         </a:defRPr>
       </a:lvl7pPr>
-      <a:lvl8pPr lvl="7" marR="0" rtl="0" algn="l">
+      <a:lvl8pPr marR="0" lvl="7" algn="l" rtl="0">
         <a:lnSpc>
           <a:spcPct val="100000"/>
         </a:lnSpc>
@@ -6275,7 +6402,7 @@
           <a:srgbClr val="000000"/>
         </a:buClr>
         <a:buFont typeface="Arial"/>
-        <a:defRPr b="0" i="0" sz="1400" u="none" cap="none" strike="noStrike">
+        <a:defRPr sz="1400" b="0" i="0" u="none" strike="noStrike" cap="none">
           <a:solidFill>
             <a:srgbClr val="000000"/>
           </a:solidFill>
@@ -6285,7 +6412,7 @@
           <a:sym typeface="Arial"/>
         </a:defRPr>
       </a:lvl8pPr>
-      <a:lvl9pPr lvl="8" marR="0" rtl="0" algn="l">
+      <a:lvl9pPr marR="0" lvl="8" algn="l" rtl="0">
         <a:lnSpc>
           <a:spcPct val="100000"/>
         </a:lnSpc>
@@ -6299,7 +6426,7 @@
           <a:srgbClr val="000000"/>
         </a:buClr>
         <a:buFont typeface="Arial"/>
-        <a:defRPr b="0" i="0" sz="1400" u="none" cap="none" strike="noStrike">
+        <a:defRPr sz="1400" b="0" i="0" u="none" strike="noStrike" cap="none">
           <a:solidFill>
             <a:srgbClr val="000000"/>
           </a:solidFill>
@@ -6315,11 +6442,11 @@
 </file>
 
 <file path=ppt/slides/slide1.xml><?xml version="1.0" encoding="utf-8"?>
-<p:sld xmlns:a="http://schemas.openxmlformats.org/drawingml/2006/main" xmlns:r="http://schemas.openxmlformats.org/officeDocument/2006/relationships" xmlns:mc="http://schemas.openxmlformats.org/markup-compatibility/2006" xmlns:mv="urn:schemas-microsoft-com:mac:vml" xmlns:p="http://schemas.openxmlformats.org/presentationml/2006/main" xmlns:c="http://schemas.openxmlformats.org/drawingml/2006/chart" xmlns:dgm="http://schemas.openxmlformats.org/drawingml/2006/diagram" xmlns:o="urn:schemas-microsoft-com:office:office" xmlns:v="urn:schemas-microsoft-com:vml" xmlns:pvml="urn:schemas-microsoft-com:office:powerpoint" xmlns:com="http://schemas.openxmlformats.org/drawingml/2006/compatibility" xmlns:p14="http://schemas.microsoft.com/office/powerpoint/2010/main" xmlns:p15="http://schemas.microsoft.com/office/powerpoint/2012/main" xmlns:ahyp="http://schemas.microsoft.com/office/drawing/2018/hyperlinkcolor">
+<p:sld xmlns:a="http://schemas.openxmlformats.org/drawingml/2006/main" xmlns:r="http://schemas.openxmlformats.org/officeDocument/2006/relationships" xmlns:p="http://schemas.openxmlformats.org/presentationml/2006/main">
   <p:cSld>
     <p:spTree>
       <p:nvGrpSpPr>
-        <p:cNvPr id="58" name="Shape 58"/>
+        <p:cNvPr id="1" name="Shape 58"/>
         <p:cNvGrpSpPr/>
         <p:nvPr/>
       </p:nvGrpSpPr>
@@ -6334,7 +6461,9 @@
       <p:sp>
         <p:nvSpPr>
           <p:cNvPr id="59" name="Google Shape;59;p13"/>
-          <p:cNvSpPr txBox="1"/>
+          <p:cNvSpPr txBox="1">
+            <a:spLocks noGrp="1"/>
+          </p:cNvSpPr>
           <p:nvPr>
             <p:ph type="ctrTitle"/>
           </p:nvPr>
@@ -6349,12 +6478,12 @@
           </a:prstGeom>
         </p:spPr>
         <p:txBody>
-          <a:bodyPr anchorCtr="0" anchor="b" bIns="91425" lIns="91425" spcFirstLastPara="1" rIns="91425" wrap="square" tIns="91425">
+          <a:bodyPr spcFirstLastPara="1" wrap="square" lIns="91425" tIns="91425" rIns="91425" bIns="91425" anchor="b" anchorCtr="0">
             <a:normAutofit/>
           </a:bodyPr>
           <a:lstStyle/>
           <a:p>
-            <a:pPr indent="0" lvl="0" marL="0" rtl="0" algn="l">
+            <a:pPr marL="0" lvl="0" indent="0" algn="l" rtl="0">
               <a:spcBef>
                 <a:spcPts val="0"/>
               </a:spcBef>
@@ -6364,19 +6493,21 @@
               <a:buNone/>
             </a:pPr>
             <a:r>
-              <a:rPr lang="en"/>
-              <a:t>Cohort 6 Small Project</a:t>
+              <a:rPr lang="en" dirty="0"/>
+              <a:t>Cohort 7 Small Project</a:t>
             </a:r>
-            <a:endParaRPr/>
+            <a:endParaRPr dirty="0"/>
           </a:p>
         </p:txBody>
       </p:sp>
       <p:sp>
         <p:nvSpPr>
           <p:cNvPr id="60" name="Google Shape;60;p13"/>
-          <p:cNvSpPr txBox="1"/>
+          <p:cNvSpPr txBox="1">
+            <a:spLocks noGrp="1"/>
+          </p:cNvSpPr>
           <p:nvPr>
-            <p:ph idx="1" type="subTitle"/>
+            <p:ph type="subTitle" idx="1"/>
           </p:nvPr>
         </p:nvSpPr>
         <p:spPr>
@@ -6389,12 +6520,12 @@
           </a:prstGeom>
         </p:spPr>
         <p:txBody>
-          <a:bodyPr anchorCtr="0" anchor="t" bIns="91425" lIns="91425" spcFirstLastPara="1" rIns="91425" wrap="square" tIns="91425">
+          <a:bodyPr spcFirstLastPara="1" wrap="square" lIns="91425" tIns="91425" rIns="91425" bIns="91425" anchor="t" anchorCtr="0">
             <a:normAutofit/>
           </a:bodyPr>
           <a:lstStyle/>
           <a:p>
-            <a:pPr indent="0" lvl="0" marL="0" rtl="0" algn="l">
+            <a:pPr marL="0" lvl="0" indent="0" algn="l" rtl="0">
               <a:spcBef>
                 <a:spcPts val="0"/>
               </a:spcBef>
@@ -6403,9 +6534,6 @@
               </a:spcAft>
               <a:buNone/>
             </a:pPr>
-            <a:r>
-              <a:t/>
-            </a:r>
             <a:endParaRPr/>
           </a:p>
         </p:txBody>
@@ -6419,11 +6547,11 @@
 </file>
 
 <file path=ppt/slides/slide2.xml><?xml version="1.0" encoding="utf-8"?>
-<p:sld xmlns:a="http://schemas.openxmlformats.org/drawingml/2006/main" xmlns:r="http://schemas.openxmlformats.org/officeDocument/2006/relationships" xmlns:mc="http://schemas.openxmlformats.org/markup-compatibility/2006" xmlns:mv="urn:schemas-microsoft-com:mac:vml" xmlns:p="http://schemas.openxmlformats.org/presentationml/2006/main" xmlns:c="http://schemas.openxmlformats.org/drawingml/2006/chart" xmlns:dgm="http://schemas.openxmlformats.org/drawingml/2006/diagram" xmlns:o="urn:schemas-microsoft-com:office:office" xmlns:v="urn:schemas-microsoft-com:vml" xmlns:pvml="urn:schemas-microsoft-com:office:powerpoint" xmlns:com="http://schemas.openxmlformats.org/drawingml/2006/compatibility" xmlns:p14="http://schemas.microsoft.com/office/powerpoint/2010/main" xmlns:p15="http://schemas.microsoft.com/office/powerpoint/2012/main" xmlns:ahyp="http://schemas.microsoft.com/office/drawing/2018/hyperlinkcolor">
+<p:sld xmlns:a="http://schemas.openxmlformats.org/drawingml/2006/main" xmlns:r="http://schemas.openxmlformats.org/officeDocument/2006/relationships" xmlns:p="http://schemas.openxmlformats.org/presentationml/2006/main">
   <p:cSld>
     <p:spTree>
       <p:nvGrpSpPr>
-        <p:cNvPr id="64" name="Shape 64"/>
+        <p:cNvPr id="1" name="Shape 64"/>
         <p:cNvGrpSpPr/>
         <p:nvPr/>
       </p:nvGrpSpPr>
@@ -6438,7 +6566,9 @@
       <p:sp>
         <p:nvSpPr>
           <p:cNvPr id="65" name="Google Shape;65;p14"/>
-          <p:cNvSpPr txBox="1"/>
+          <p:cNvSpPr txBox="1">
+            <a:spLocks noGrp="1"/>
+          </p:cNvSpPr>
           <p:nvPr>
             <p:ph type="title"/>
           </p:nvPr>
@@ -6453,12 +6583,12 @@
           </a:prstGeom>
         </p:spPr>
         <p:txBody>
-          <a:bodyPr anchorCtr="0" anchor="t" bIns="91425" lIns="91425" spcFirstLastPara="1" rIns="91425" wrap="square" tIns="91425">
+          <a:bodyPr spcFirstLastPara="1" wrap="square" lIns="91425" tIns="91425" rIns="91425" bIns="91425" anchor="t" anchorCtr="0">
             <a:normAutofit fontScale="90000"/>
           </a:bodyPr>
           <a:lstStyle/>
           <a:p>
-            <a:pPr indent="0" lvl="0" marL="0" rtl="0" algn="l">
+            <a:pPr marL="0" lvl="0" indent="0" algn="l" rtl="0">
               <a:spcBef>
                 <a:spcPts val="0"/>
               </a:spcBef>
@@ -6478,9 +6608,11 @@
       <p:sp>
         <p:nvSpPr>
           <p:cNvPr id="66" name="Google Shape;66;p14"/>
-          <p:cNvSpPr txBox="1"/>
+          <p:cNvSpPr txBox="1">
+            <a:spLocks noGrp="1"/>
+          </p:cNvSpPr>
           <p:nvPr>
-            <p:ph idx="1" type="body"/>
+            <p:ph type="body" idx="1"/>
           </p:nvPr>
         </p:nvSpPr>
         <p:spPr>
@@ -6493,12 +6625,12 @@
           </a:prstGeom>
         </p:spPr>
         <p:txBody>
-          <a:bodyPr anchorCtr="0" anchor="t" bIns="91425" lIns="91425" spcFirstLastPara="1" rIns="91425" wrap="square" tIns="91425">
-            <a:normAutofit fontScale="40000" lnSpcReduction="10000"/>
+          <a:bodyPr spcFirstLastPara="1" wrap="square" lIns="91425" tIns="91425" rIns="91425" bIns="91425" anchor="t" anchorCtr="0">
+            <a:normAutofit fontScale="47500" lnSpcReduction="20000"/>
           </a:bodyPr>
           <a:lstStyle/>
           <a:p>
-            <a:pPr indent="0" lvl="0" marL="0" rtl="0" algn="l">
+            <a:pPr marL="0" lvl="0" indent="0" algn="l" rtl="0">
               <a:spcBef>
                 <a:spcPts val="0"/>
               </a:spcBef>
@@ -6508,13 +6640,13 @@
               <a:buNone/>
             </a:pPr>
             <a:r>
-              <a:rPr lang="en" sz="4600"/>
+              <a:rPr lang="en" sz="4600" dirty="0"/>
               <a:t>🧭 Mission Briefing: Mars Colonist Systems — Mission Control Online</a:t>
             </a:r>
-            <a:endParaRPr sz="4600"/>
+            <a:endParaRPr sz="4600" dirty="0"/>
           </a:p>
           <a:p>
-            <a:pPr indent="0" lvl="0" marL="0" rtl="0" algn="l">
+            <a:pPr marL="0" lvl="0" indent="0" algn="l" rtl="0">
               <a:spcBef>
                 <a:spcPts val="1200"/>
               </a:spcBef>
@@ -6524,13 +6656,13 @@
               <a:buNone/>
             </a:pPr>
             <a:r>
-              <a:rPr lang="en" sz="4600"/>
+              <a:rPr lang="en" sz="4600" dirty="0"/>
               <a:t>Transmission Received: 07:41 MST / Sol 147</a:t>
             </a:r>
-            <a:endParaRPr sz="4600"/>
+            <a:endParaRPr sz="4600" dirty="0"/>
           </a:p>
           <a:p>
-            <a:pPr indent="0" lvl="0" marL="0" rtl="0" algn="l">
+            <a:pPr marL="0" lvl="0" indent="0" algn="l" rtl="0">
               <a:spcBef>
                 <a:spcPts val="1200"/>
               </a:spcBef>
@@ -6540,13 +6672,13 @@
               <a:buNone/>
             </a:pPr>
             <a:r>
-              <a:rPr lang="en" sz="4600"/>
+              <a:rPr lang="en" sz="4600" dirty="0"/>
               <a:t>Source: Central Mars Orbital Relay</a:t>
             </a:r>
-            <a:endParaRPr sz="4600"/>
+            <a:endParaRPr sz="4600" dirty="0"/>
           </a:p>
           <a:p>
-            <a:pPr indent="0" lvl="0" marL="0" rtl="0" algn="l">
+            <a:pPr marL="0" lvl="0" indent="0" algn="l" rtl="0">
               <a:spcBef>
                 <a:spcPts val="1200"/>
               </a:spcBef>
@@ -6556,13 +6688,13 @@
               <a:buNone/>
             </a:pPr>
             <a:r>
-              <a:rPr lang="en" sz="4600"/>
+              <a:rPr lang="en" sz="4600" dirty="0"/>
               <a:t>To: Chief Engineer [TEAM: Nova Six]</a:t>
             </a:r>
-            <a:endParaRPr sz="4600"/>
+            <a:endParaRPr sz="4600" dirty="0"/>
           </a:p>
           <a:p>
-            <a:pPr indent="0" lvl="0" marL="0" rtl="0" algn="l">
+            <a:pPr marL="0" lvl="0" indent="0" algn="l" rtl="0">
               <a:spcBef>
                 <a:spcPts val="1200"/>
               </a:spcBef>
@@ -6572,13 +6704,13 @@
               <a:buNone/>
             </a:pPr>
             <a:r>
-              <a:rPr lang="en" sz="4600"/>
+              <a:rPr lang="en" sz="4600" dirty="0"/>
               <a:t>Priority: ALPHA — System Restore Protocol</a:t>
             </a:r>
-            <a:endParaRPr sz="4600"/>
+            <a:endParaRPr sz="4600" dirty="0"/>
           </a:p>
           <a:p>
-            <a:pPr indent="0" lvl="0" marL="0" rtl="0" algn="l">
+            <a:pPr marL="0" lvl="0" indent="0" algn="l" rtl="0">
               <a:spcBef>
                 <a:spcPts val="1200"/>
               </a:spcBef>
@@ -6588,13 +6720,13 @@
               <a:buNone/>
             </a:pPr>
             <a:r>
-              <a:rPr lang="en" sz="4600"/>
-              <a:t>Commander Goulding – Mars Base One Operations Chief</a:t>
+              <a:rPr lang="en" sz="4600" dirty="0"/>
+              <a:t>Commander Weiss – Mars Base One Operations Chief</a:t>
             </a:r>
-            <a:endParaRPr sz="4600"/>
+            <a:endParaRPr sz="4600" dirty="0"/>
           </a:p>
           <a:p>
-            <a:pPr indent="0" lvl="0" marL="0" rtl="0" algn="l">
+            <a:pPr marL="0" lvl="0" indent="0" algn="l" rtl="0">
               <a:spcBef>
                 <a:spcPts val="1200"/>
               </a:spcBef>
@@ -6603,13 +6735,10 @@
               </a:spcAft>
               <a:buNone/>
             </a:pPr>
-            <a:r>
-              <a:t/>
-            </a:r>
-            <a:endParaRPr/>
+            <a:endParaRPr dirty="0"/>
           </a:p>
           <a:p>
-            <a:pPr indent="0" lvl="0" marL="0" rtl="0" algn="l">
+            <a:pPr marL="0" lvl="0" indent="0" algn="l" rtl="0">
               <a:spcBef>
                 <a:spcPts val="1200"/>
               </a:spcBef>
@@ -6618,10 +6747,7 @@
               </a:spcAft>
               <a:buNone/>
             </a:pPr>
-            <a:r>
-              <a:t/>
-            </a:r>
-            <a:endParaRPr/>
+            <a:endParaRPr dirty="0"/>
           </a:p>
         </p:txBody>
       </p:sp>
@@ -6634,11 +6760,11 @@
 </file>
 
 <file path=ppt/slides/slide3.xml><?xml version="1.0" encoding="utf-8"?>
-<p:sld xmlns:a="http://schemas.openxmlformats.org/drawingml/2006/main" xmlns:r="http://schemas.openxmlformats.org/officeDocument/2006/relationships" xmlns:mc="http://schemas.openxmlformats.org/markup-compatibility/2006" xmlns:mv="urn:schemas-microsoft-com:mac:vml" xmlns:p="http://schemas.openxmlformats.org/presentationml/2006/main" xmlns:c="http://schemas.openxmlformats.org/drawingml/2006/chart" xmlns:dgm="http://schemas.openxmlformats.org/drawingml/2006/diagram" xmlns:o="urn:schemas-microsoft-com:office:office" xmlns:v="urn:schemas-microsoft-com:vml" xmlns:pvml="urn:schemas-microsoft-com:office:powerpoint" xmlns:com="http://schemas.openxmlformats.org/drawingml/2006/compatibility" xmlns:p14="http://schemas.microsoft.com/office/powerpoint/2010/main" xmlns:p15="http://schemas.microsoft.com/office/powerpoint/2012/main" xmlns:ahyp="http://schemas.microsoft.com/office/drawing/2018/hyperlinkcolor">
+<p:sld xmlns:a="http://schemas.openxmlformats.org/drawingml/2006/main" xmlns:r="http://schemas.openxmlformats.org/officeDocument/2006/relationships" xmlns:p="http://schemas.openxmlformats.org/presentationml/2006/main">
   <p:cSld>
     <p:spTree>
       <p:nvGrpSpPr>
-        <p:cNvPr id="70" name="Shape 70"/>
+        <p:cNvPr id="1" name="Shape 70"/>
         <p:cNvGrpSpPr/>
         <p:nvPr/>
       </p:nvGrpSpPr>
@@ -6653,9 +6779,11 @@
       <p:sp>
         <p:nvSpPr>
           <p:cNvPr id="71" name="Google Shape;71;p15"/>
-          <p:cNvSpPr txBox="1"/>
+          <p:cNvSpPr txBox="1">
+            <a:spLocks noGrp="1"/>
+          </p:cNvSpPr>
           <p:nvPr>
-            <p:ph idx="1" type="body"/>
+            <p:ph type="body" idx="1"/>
           </p:nvPr>
         </p:nvSpPr>
         <p:spPr>
@@ -6668,12 +6796,25 @@
           </a:prstGeom>
         </p:spPr>
         <p:txBody>
-          <a:bodyPr anchorCtr="0" anchor="t" bIns="91425" lIns="91425" spcFirstLastPara="1" rIns="91425" wrap="square" tIns="91425">
+          <a:bodyPr spcFirstLastPara="1" wrap="square" lIns="91425" tIns="91425" rIns="91425" bIns="91425" anchor="t" anchorCtr="0">
             <a:noAutofit/>
           </a:bodyPr>
           <a:lstStyle/>
           <a:p>
-            <a:pPr indent="0" lvl="0" marL="0" rtl="0" algn="l">
+            <a:pPr marL="0" lvl="0" indent="0" algn="l" rtl="0">
+              <a:spcBef>
+                <a:spcPts val="0"/>
+              </a:spcBef>
+              <a:spcAft>
+                <a:spcPts val="0"/>
+              </a:spcAft>
+              <a:buSzPts val="358"/>
+              <a:buNone/>
+            </a:pPr>
+            <a:endParaRPr lang="en" sz="1147" b="1" dirty="0"/>
+          </a:p>
+          <a:p>
+            <a:pPr marL="0" lvl="0" indent="0" algn="l" rtl="0">
               <a:spcBef>
                 <a:spcPts val="0"/>
               </a:spcBef>
@@ -6684,115 +6825,129 @@
               <a:buNone/>
             </a:pPr>
             <a:r>
-              <a:rPr b="1" lang="en" sz="1147"/>
+              <a:rPr lang="en" sz="1147" b="1" dirty="0"/>
               <a:t>“</a:t>
             </a:r>
             <a:r>
-              <a:rPr b="1" lang="en" sz="1277"/>
+              <a:rPr lang="en" sz="1277" b="1" dirty="0"/>
               <a:t>Chief Engineer — you're receiving this message because you ranked top in systems diagnostics during pre-deployment training. We need that expertise now. Three sols ago, an unexpected solar flare—classified X9.3—hit the upper atmosphere, causing a cascading failure in Base One’s remote operations stack. Our telemetry systems, environmental monitors, and autonomous rover schedulers all went dark.</a:t>
             </a:r>
-            <a:endParaRPr b="1" sz="1277"/>
+            <a:endParaRPr sz="1277" b="1" dirty="0"/>
           </a:p>
           <a:p>
-            <a:pPr indent="0" lvl="0" marL="0" rtl="0" algn="l">
+            <a:pPr marL="0" lvl="0" indent="0">
               <a:spcBef>
                 <a:spcPts val="1200"/>
               </a:spcBef>
-              <a:spcAft>
-                <a:spcPts val="0"/>
-              </a:spcAft>
               <a:buSzPts val="358"/>
               <a:buNone/>
             </a:pPr>
             <a:r>
-              <a:rPr b="1" lang="en" sz="1277"/>
-              <a:t>We’ve managed to bring emergency power online, but mission control remains offline. We have less than 72 hours before the incoming resupply and colonist wave lands. If core systems aren’t restored, we can expect to lose all 1000 people on board.Your assignment is clear: gain remote access of Mission Control (log in to the VM), solve telemetry systems issues (Python Problem 1),  recalculate food resources (Python Problem 2), launch the emergency comms rocket (Python Problem 3), and share your solutions with  (pull request).  Lastly, you will need to create a broadcast beacon to Earth, to re-establish comms and signal that all is under control (create a website through your own VM).</a:t>
+              <a:rPr lang="en" sz="1277" b="1" dirty="0"/>
+              <a:t>We’ve managed to bring emergency power online, but mission control remains offline. We have less than 72 hours before the incoming resupply and colonist wave lands. If core systems aren’t restored, we can expect to lose all 1000 people on board. Your assignment is clear: </a:t>
             </a:r>
-            <a:endParaRPr b="1" sz="1277"/>
           </a:p>
           <a:p>
-            <a:pPr indent="0" lvl="0" marL="0" rtl="0" algn="l">
+            <a:pPr marL="0" lvl="0" indent="0">
               <a:spcBef>
                 <a:spcPts val="1200"/>
               </a:spcBef>
-              <a:spcAft>
-                <a:spcPts val="0"/>
-              </a:spcAft>
               <a:buSzPts val="358"/>
               <a:buNone/>
+            </a:pPr>
+            <a:endParaRPr lang="en" sz="1277" b="1" dirty="0"/>
+          </a:p>
+          <a:p>
+            <a:pPr marL="342900" lvl="0">
+              <a:buSzPct val="100000"/>
+              <a:buAutoNum type="arabicParenR"/>
             </a:pPr>
             <a:r>
-              <a:rPr b="1" lang="en" sz="1277"/>
-              <a:t>To begin, you need to gain access to mission control.  Locally, you should be able to ssh into Mission Control at 172.174.209.144.  The username we were using before the solar flare hit was Cohort6.  I forget part of the password though.  The part I remember is Cohort6_AI2C_[PART MISSING]</a:t>
+              <a:rPr lang="en" sz="1277" b="1" dirty="0"/>
+              <a:t>Gain remote access of Mission Control (log in to the VM), </a:t>
             </a:r>
-            <a:endParaRPr b="1" sz="1277"/>
           </a:p>
           <a:p>
-            <a:pPr indent="0" lvl="0" marL="0" rtl="0" algn="l">
-              <a:spcBef>
-                <a:spcPts val="1200"/>
-              </a:spcBef>
-              <a:spcAft>
-                <a:spcPts val="0"/>
-              </a:spcAft>
-              <a:buSzPts val="358"/>
-              <a:buNone/>
+            <a:pPr marL="342900" lvl="0">
+              <a:buSzPct val="100000"/>
+              <a:buAutoNum type="arabicParenR"/>
             </a:pPr>
             <a:r>
-              <a:rPr b="1" lang="en" sz="1277"/>
-              <a:t>To find the last part of the password, you must use your Python expertise to find the total number of medals the United States won in the Olympics in your all_olympic_medalists.csv file that you have stored locally.  To be clear,if you find that the United States won 100 medals, the password would be Cohort6_AI2C_100</a:t>
+              <a:rPr lang="en" sz="1277" b="1" dirty="0"/>
+              <a:t>solve telemetry systems issues (Python Problem 1) </a:t>
             </a:r>
-            <a:endParaRPr b="1" sz="1277"/>
           </a:p>
           <a:p>
-            <a:pPr indent="0" lvl="0" marL="0" rtl="0" algn="l">
-              <a:spcBef>
-                <a:spcPts val="1200"/>
-              </a:spcBef>
-              <a:spcAft>
-                <a:spcPts val="0"/>
-              </a:spcAft>
-              <a:buSzPts val="358"/>
-              <a:buNone/>
+            <a:pPr marL="342900" lvl="0">
+              <a:buSzPct val="100000"/>
+              <a:buAutoNum type="arabicParenR"/>
             </a:pPr>
             <a:r>
-              <a:rPr b="1" lang="en" sz="1277"/>
-              <a:t>Good luck.  There are lives at stake!"</a:t>
+              <a:rPr lang="en" sz="1277" b="1" dirty="0"/>
+              <a:t>Recalculate food resources (Python Problem 2), </a:t>
             </a:r>
-            <a:endParaRPr b="1" sz="1277"/>
           </a:p>
           <a:p>
-            <a:pPr indent="0" lvl="0" marL="0" rtl="0" algn="l">
-              <a:spcBef>
-                <a:spcPts val="1200"/>
-              </a:spcBef>
-              <a:spcAft>
-                <a:spcPts val="0"/>
-              </a:spcAft>
-              <a:buSzPts val="358"/>
-              <a:buNone/>
+            <a:pPr marL="342900" lvl="0">
+              <a:buSzPct val="100000"/>
+              <a:buAutoNum type="arabicParenR"/>
             </a:pPr>
             <a:r>
-              <a:rPr b="1" lang="en" sz="1277"/>
-              <a:t>-Commander Goulding</a:t>
+              <a:rPr lang="en" sz="1277" b="1" dirty="0"/>
+              <a:t>Launch the emergency comms rocket (Python Problem 3)</a:t>
             </a:r>
-            <a:endParaRPr b="1" sz="1277"/>
           </a:p>
           <a:p>
-            <a:pPr indent="0" lvl="0" marL="0" rtl="0" algn="l">
+            <a:pPr marL="0" lvl="0" indent="0">
               <a:spcBef>
                 <a:spcPts val="1200"/>
               </a:spcBef>
-              <a:spcAft>
-                <a:spcPts val="1200"/>
-              </a:spcAft>
               <a:buSzPts val="358"/>
               <a:buNone/>
             </a:pPr>
             <a:r>
-              <a:t/>
+              <a:rPr lang="en" sz="1277" b="1" dirty="0"/>
+              <a:t>To begin, you need to gain access to mission control. The SSD that contained the username and password to login to Mission Control was fried by the Solar Flare, but you have confirmed that Mission Control will send an HTTP Response to a request at 20.127.202.175 on Port 8000. Test this connection with a simple HTTP Request without authentication headers..  Once you have those, send a simple HTTP request with</a:t>
             </a:r>
-            <a:endParaRPr sz="685"/>
+            <a:r>
+              <a:rPr lang="en-US" sz="1277" b="1" dirty="0"/>
+              <a:t> t</a:t>
+            </a:r>
+            <a:r>
+              <a:rPr lang="en" sz="1277" b="1" dirty="0"/>
+              <a:t>hese authentication headers to get the login information for Mission Control’s system internals.</a:t>
+            </a:r>
+          </a:p>
+          <a:p>
+            <a:pPr marL="0" lvl="0" indent="0">
+              <a:spcBef>
+                <a:spcPts val="1200"/>
+              </a:spcBef>
+              <a:buSzPts val="358"/>
+              <a:buNone/>
+            </a:pPr>
+            <a:r>
+              <a:rPr lang="en" sz="1277" b="1" dirty="0"/>
+              <a:t>Good luck.  There are lives at stake!“    -Commander </a:t>
+            </a:r>
+            <a:r>
+              <a:rPr lang="en-US" sz="1277" b="1" dirty="0"/>
+              <a:t>Weiss</a:t>
+            </a:r>
+            <a:endParaRPr sz="1277" b="1" dirty="0"/>
+          </a:p>
+          <a:p>
+            <a:pPr marL="0" lvl="0" indent="0" algn="l" rtl="0">
+              <a:spcBef>
+                <a:spcPts val="1200"/>
+              </a:spcBef>
+              <a:spcAft>
+                <a:spcPts val="1200"/>
+              </a:spcAft>
+              <a:buSzPts val="358"/>
+              <a:buNone/>
+            </a:pPr>
+            <a:endParaRPr sz="685" dirty="0"/>
           </a:p>
         </p:txBody>
       </p:sp>
@@ -6805,7 +6960,288 @@
 </file>
 
 <file path=ppt/theme/theme1.xml><?xml version="1.0" encoding="utf-8"?>
-<a:theme xmlns:a="http://schemas.openxmlformats.org/drawingml/2006/main" xmlns:r="http://schemas.openxmlformats.org/officeDocument/2006/relationships">
+<a:theme xmlns:a="http://schemas.openxmlformats.org/drawingml/2006/main" name="Spearmint">
+  <a:themeElements>
+    <a:clrScheme name="Spearmint">
+      <a:dk1>
+        <a:srgbClr val="202729"/>
+      </a:dk1>
+      <a:lt1>
+        <a:srgbClr val="FFFFFF"/>
+      </a:lt1>
+      <a:dk2>
+        <a:srgbClr val="4BA173"/>
+      </a:dk2>
+      <a:lt2>
+        <a:srgbClr val="63D297"/>
+      </a:lt2>
+      <a:accent1>
+        <a:srgbClr val="353744"/>
+      </a:accent1>
+      <a:accent2>
+        <a:srgbClr val="424242"/>
+      </a:accent2>
+      <a:accent3>
+        <a:srgbClr val="616161"/>
+      </a:accent3>
+      <a:accent4>
+        <a:srgbClr val="999999"/>
+      </a:accent4>
+      <a:accent5>
+        <a:srgbClr val="FF5252"/>
+      </a:accent5>
+      <a:accent6>
+        <a:srgbClr val="FFF176"/>
+      </a:accent6>
+      <a:hlink>
+        <a:srgbClr val="FF5252"/>
+      </a:hlink>
+      <a:folHlink>
+        <a:srgbClr val="FF5252"/>
+      </a:folHlink>
+    </a:clrScheme>
+    <a:fontScheme name="Office">
+      <a:majorFont>
+        <a:latin typeface="Arial"/>
+        <a:ea typeface=""/>
+        <a:cs typeface=""/>
+        <a:font script="Jpan" typeface="ＭＳ Ｐゴシック"/>
+        <a:font script="Hang" typeface="맑은 고딕"/>
+        <a:font script="Hans" typeface="宋体"/>
+        <a:font script="Hant" typeface="新細明體"/>
+        <a:font script="Arab" typeface="Times New Roman"/>
+        <a:font script="Hebr" typeface="Times New Roman"/>
+        <a:font script="Thai" typeface="Angsana New"/>
+        <a:font script="Ethi" typeface="Nyala"/>
+        <a:font script="Beng" typeface="Vrinda"/>
+        <a:font script="Gujr" typeface="Shruti"/>
+        <a:font script="Khmr" typeface="MoolBoran"/>
+        <a:font script="Knda" typeface="Tunga"/>
+        <a:font script="Guru" typeface="Raavi"/>
+        <a:font script="Cans" typeface="Euphemia"/>
+        <a:font script="Cher" typeface="Plantagenet Cherokee"/>
+        <a:font script="Yiii" typeface="Microsoft Yi Baiti"/>
+        <a:font script="Tibt" typeface="Microsoft Himalaya"/>
+        <a:font script="Thaa" typeface="MV Boli"/>
+        <a:font script="Deva" typeface="Mangal"/>
+        <a:font script="Telu" typeface="Gautami"/>
+        <a:font script="Taml" typeface="Latha"/>
+        <a:font script="Syrc" typeface="Estrangelo Edessa"/>
+        <a:font script="Orya" typeface="Kalinga"/>
+        <a:font script="Mlym" typeface="Kartika"/>
+        <a:font script="Laoo" typeface="DokChampa"/>
+        <a:font script="Sinh" typeface="Iskoola Pota"/>
+        <a:font script="Mong" typeface="Mongolian Baiti"/>
+        <a:font script="Viet" typeface="Times New Roman"/>
+        <a:font script="Uigh" typeface="Microsoft Uighur"/>
+        <a:font script="Geor" typeface="Sylfaen"/>
+      </a:majorFont>
+      <a:minorFont>
+        <a:latin typeface="Arial"/>
+        <a:ea typeface=""/>
+        <a:cs typeface=""/>
+        <a:font script="Jpan" typeface="ＭＳ Ｐゴシック"/>
+        <a:font script="Hang" typeface="맑은 고딕"/>
+        <a:font script="Hans" typeface="宋体"/>
+        <a:font script="Hant" typeface="新細明體"/>
+        <a:font script="Arab" typeface="Arial"/>
+        <a:font script="Hebr" typeface="Arial"/>
+        <a:font script="Thai" typeface="Cordia New"/>
+        <a:font script="Ethi" typeface="Nyala"/>
+        <a:font script="Beng" typeface="Vrinda"/>
+        <a:font script="Gujr" typeface="Shruti"/>
+        <a:font script="Khmr" typeface="DaunPenh"/>
+        <a:font script="Knda" typeface="Tunga"/>
+        <a:font script="Guru" typeface="Raavi"/>
+        <a:font script="Cans" typeface="Euphemia"/>
+        <a:font script="Cher" typeface="Plantagenet Cherokee"/>
+        <a:font script="Yiii" typeface="Microsoft Yi Baiti"/>
+        <a:font script="Tibt" typeface="Microsoft Himalaya"/>
+        <a:font script="Thaa" typeface="MV Boli"/>
+        <a:font script="Deva" typeface="Mangal"/>
+        <a:font script="Telu" typeface="Gautami"/>
+        <a:font script="Taml" typeface="Latha"/>
+        <a:font script="Syrc" typeface="Estrangelo Edessa"/>
+        <a:font script="Orya" typeface="Kalinga"/>
+        <a:font script="Mlym" typeface="Kartika"/>
+        <a:font script="Laoo" typeface="DokChampa"/>
+        <a:font script="Sinh" typeface="Iskoola Pota"/>
+        <a:font script="Mong" typeface="Mongolian Baiti"/>
+        <a:font script="Viet" typeface="Arial"/>
+        <a:font script="Uigh" typeface="Microsoft Uighur"/>
+        <a:font script="Geor" typeface="Sylfaen"/>
+      </a:minorFont>
+    </a:fontScheme>
+    <a:fmtScheme name="Office">
+      <a:fillStyleLst>
+        <a:solidFill>
+          <a:schemeClr val="phClr"/>
+        </a:solidFill>
+        <a:gradFill rotWithShape="1">
+          <a:gsLst>
+            <a:gs pos="0">
+              <a:schemeClr val="phClr">
+                <a:tint val="50000"/>
+                <a:satMod val="300000"/>
+              </a:schemeClr>
+            </a:gs>
+            <a:gs pos="35000">
+              <a:schemeClr val="phClr">
+                <a:tint val="37000"/>
+                <a:satMod val="300000"/>
+              </a:schemeClr>
+            </a:gs>
+            <a:gs pos="100000">
+              <a:schemeClr val="phClr">
+                <a:tint val="15000"/>
+                <a:satMod val="350000"/>
+              </a:schemeClr>
+            </a:gs>
+          </a:gsLst>
+          <a:lin ang="16200000" scaled="1"/>
+        </a:gradFill>
+        <a:gradFill rotWithShape="1">
+          <a:gsLst>
+            <a:gs pos="0">
+              <a:schemeClr val="phClr">
+                <a:tint val="100000"/>
+                <a:shade val="100000"/>
+                <a:satMod val="130000"/>
+              </a:schemeClr>
+            </a:gs>
+            <a:gs pos="100000">
+              <a:schemeClr val="phClr">
+                <a:tint val="50000"/>
+                <a:shade val="100000"/>
+                <a:satMod val="350000"/>
+              </a:schemeClr>
+            </a:gs>
+          </a:gsLst>
+          <a:lin ang="16200000" scaled="0"/>
+        </a:gradFill>
+      </a:fillStyleLst>
+      <a:lnStyleLst>
+        <a:ln w="9525" cap="flat" cmpd="sng" algn="ctr">
+          <a:solidFill>
+            <a:schemeClr val="phClr">
+              <a:shade val="95000"/>
+              <a:satMod val="105000"/>
+            </a:schemeClr>
+          </a:solidFill>
+          <a:prstDash val="solid"/>
+        </a:ln>
+        <a:ln w="25400" cap="flat" cmpd="sng" algn="ctr">
+          <a:solidFill>
+            <a:schemeClr val="phClr"/>
+          </a:solidFill>
+          <a:prstDash val="solid"/>
+        </a:ln>
+        <a:ln w="38100" cap="flat" cmpd="sng" algn="ctr">
+          <a:solidFill>
+            <a:schemeClr val="phClr"/>
+          </a:solidFill>
+          <a:prstDash val="solid"/>
+        </a:ln>
+      </a:lnStyleLst>
+      <a:effectStyleLst>
+        <a:effectStyle>
+          <a:effectLst>
+            <a:outerShdw blurRad="40000" dist="20000" dir="5400000" rotWithShape="0">
+              <a:srgbClr val="000000">
+                <a:alpha val="38000"/>
+              </a:srgbClr>
+            </a:outerShdw>
+          </a:effectLst>
+        </a:effectStyle>
+        <a:effectStyle>
+          <a:effectLst>
+            <a:outerShdw blurRad="40000" dist="23000" dir="5400000" rotWithShape="0">
+              <a:srgbClr val="000000">
+                <a:alpha val="35000"/>
+              </a:srgbClr>
+            </a:outerShdw>
+          </a:effectLst>
+        </a:effectStyle>
+        <a:effectStyle>
+          <a:effectLst>
+            <a:outerShdw blurRad="40000" dist="23000" dir="5400000" rotWithShape="0">
+              <a:srgbClr val="000000">
+                <a:alpha val="35000"/>
+              </a:srgbClr>
+            </a:outerShdw>
+          </a:effectLst>
+          <a:scene3d>
+            <a:camera prst="orthographicFront">
+              <a:rot lat="0" lon="0" rev="0"/>
+            </a:camera>
+            <a:lightRig rig="threePt" dir="t">
+              <a:rot lat="0" lon="0" rev="1200000"/>
+            </a:lightRig>
+          </a:scene3d>
+          <a:sp3d>
+            <a:bevelT w="63500" h="25400"/>
+          </a:sp3d>
+        </a:effectStyle>
+      </a:effectStyleLst>
+      <a:bgFillStyleLst>
+        <a:solidFill>
+          <a:schemeClr val="phClr"/>
+        </a:solidFill>
+        <a:gradFill rotWithShape="1">
+          <a:gsLst>
+            <a:gs pos="0">
+              <a:schemeClr val="phClr">
+                <a:tint val="40000"/>
+                <a:satMod val="350000"/>
+              </a:schemeClr>
+            </a:gs>
+            <a:gs pos="40000">
+              <a:schemeClr val="phClr">
+                <a:tint val="45000"/>
+                <a:shade val="99000"/>
+                <a:satMod val="350000"/>
+              </a:schemeClr>
+            </a:gs>
+            <a:gs pos="100000">
+              <a:schemeClr val="phClr">
+                <a:shade val="20000"/>
+                <a:satMod val="255000"/>
+              </a:schemeClr>
+            </a:gs>
+          </a:gsLst>
+          <a:path path="circle">
+            <a:fillToRect l="50000" t="-80000" r="50000" b="180000"/>
+          </a:path>
+        </a:gradFill>
+        <a:gradFill rotWithShape="1">
+          <a:gsLst>
+            <a:gs pos="0">
+              <a:schemeClr val="phClr">
+                <a:tint val="80000"/>
+                <a:satMod val="300000"/>
+              </a:schemeClr>
+            </a:gs>
+            <a:gs pos="100000">
+              <a:schemeClr val="phClr">
+                <a:shade val="30000"/>
+                <a:satMod val="200000"/>
+              </a:schemeClr>
+            </a:gs>
+          </a:gsLst>
+          <a:path path="circle">
+            <a:fillToRect l="50000" t="50000" r="50000" b="50000"/>
+          </a:path>
+        </a:gradFill>
+      </a:bgFillStyleLst>
+    </a:fmtScheme>
+  </a:themeElements>
+  <a:objectDefaults/>
+  <a:extraClrSchemeLst/>
+</a:theme>
+</file>
+
+<file path=ppt/theme/theme2.xml><?xml version="1.0" encoding="utf-8"?>
+<a:theme xmlns:a="http://schemas.openxmlformats.org/drawingml/2006/main">
   <a:themeElements>
     <a:clrScheme name="Default">
       <a:dk1>
@@ -7080,284 +7516,7 @@
       </a:bgFillStyleLst>
     </a:fmtScheme>
   </a:themeElements>
-</a:theme>
-</file>
-
-<file path=ppt/theme/theme2.xml><?xml version="1.0" encoding="utf-8"?>
-<a:theme xmlns:a="http://schemas.openxmlformats.org/drawingml/2006/main" xmlns:r="http://schemas.openxmlformats.org/officeDocument/2006/relationships" name="Spearmint">
-  <a:themeElements>
-    <a:clrScheme name="Spearmint">
-      <a:dk1>
-        <a:srgbClr val="202729"/>
-      </a:dk1>
-      <a:lt1>
-        <a:srgbClr val="FFFFFF"/>
-      </a:lt1>
-      <a:dk2>
-        <a:srgbClr val="4BA173"/>
-      </a:dk2>
-      <a:lt2>
-        <a:srgbClr val="63D297"/>
-      </a:lt2>
-      <a:accent1>
-        <a:srgbClr val="353744"/>
-      </a:accent1>
-      <a:accent2>
-        <a:srgbClr val="424242"/>
-      </a:accent2>
-      <a:accent3>
-        <a:srgbClr val="616161"/>
-      </a:accent3>
-      <a:accent4>
-        <a:srgbClr val="999999"/>
-      </a:accent4>
-      <a:accent5>
-        <a:srgbClr val="FF5252"/>
-      </a:accent5>
-      <a:accent6>
-        <a:srgbClr val="FFF176"/>
-      </a:accent6>
-      <a:hlink>
-        <a:srgbClr val="FF5252"/>
-      </a:hlink>
-      <a:folHlink>
-        <a:srgbClr val="FF5252"/>
-      </a:folHlink>
-    </a:clrScheme>
-    <a:fontScheme name="Office">
-      <a:majorFont>
-        <a:latin typeface="Arial"/>
-        <a:ea typeface=""/>
-        <a:cs typeface=""/>
-        <a:font script="Jpan" typeface="ＭＳ Ｐゴシック"/>
-        <a:font script="Hang" typeface="맑은 고딕"/>
-        <a:font script="Hans" typeface="宋体"/>
-        <a:font script="Hant" typeface="新細明體"/>
-        <a:font script="Arab" typeface="Times New Roman"/>
-        <a:font script="Hebr" typeface="Times New Roman"/>
-        <a:font script="Thai" typeface="Angsana New"/>
-        <a:font script="Ethi" typeface="Nyala"/>
-        <a:font script="Beng" typeface="Vrinda"/>
-        <a:font script="Gujr" typeface="Shruti"/>
-        <a:font script="Khmr" typeface="MoolBoran"/>
-        <a:font script="Knda" typeface="Tunga"/>
-        <a:font script="Guru" typeface="Raavi"/>
-        <a:font script="Cans" typeface="Euphemia"/>
-        <a:font script="Cher" typeface="Plantagenet Cherokee"/>
-        <a:font script="Yiii" typeface="Microsoft Yi Baiti"/>
-        <a:font script="Tibt" typeface="Microsoft Himalaya"/>
-        <a:font script="Thaa" typeface="MV Boli"/>
-        <a:font script="Deva" typeface="Mangal"/>
-        <a:font script="Telu" typeface="Gautami"/>
-        <a:font script="Taml" typeface="Latha"/>
-        <a:font script="Syrc" typeface="Estrangelo Edessa"/>
-        <a:font script="Orya" typeface="Kalinga"/>
-        <a:font script="Mlym" typeface="Kartika"/>
-        <a:font script="Laoo" typeface="DokChampa"/>
-        <a:font script="Sinh" typeface="Iskoola Pota"/>
-        <a:font script="Mong" typeface="Mongolian Baiti"/>
-        <a:font script="Viet" typeface="Times New Roman"/>
-        <a:font script="Uigh" typeface="Microsoft Uighur"/>
-        <a:font script="Geor" typeface="Sylfaen"/>
-      </a:majorFont>
-      <a:minorFont>
-        <a:latin typeface="Arial"/>
-        <a:ea typeface=""/>
-        <a:cs typeface=""/>
-        <a:font script="Jpan" typeface="ＭＳ Ｐゴシック"/>
-        <a:font script="Hang" typeface="맑은 고딕"/>
-        <a:font script="Hans" typeface="宋体"/>
-        <a:font script="Hant" typeface="新細明體"/>
-        <a:font script="Arab" typeface="Arial"/>
-        <a:font script="Hebr" typeface="Arial"/>
-        <a:font script="Thai" typeface="Cordia New"/>
-        <a:font script="Ethi" typeface="Nyala"/>
-        <a:font script="Beng" typeface="Vrinda"/>
-        <a:font script="Gujr" typeface="Shruti"/>
-        <a:font script="Khmr" typeface="DaunPenh"/>
-        <a:font script="Knda" typeface="Tunga"/>
-        <a:font script="Guru" typeface="Raavi"/>
-        <a:font script="Cans" typeface="Euphemia"/>
-        <a:font script="Cher" typeface="Plantagenet Cherokee"/>
-        <a:font script="Yiii" typeface="Microsoft Yi Baiti"/>
-        <a:font script="Tibt" typeface="Microsoft Himalaya"/>
-        <a:font script="Thaa" typeface="MV Boli"/>
-        <a:font script="Deva" typeface="Mangal"/>
-        <a:font script="Telu" typeface="Gautami"/>
-        <a:font script="Taml" typeface="Latha"/>
-        <a:font script="Syrc" typeface="Estrangelo Edessa"/>
-        <a:font script="Orya" typeface="Kalinga"/>
-        <a:font script="Mlym" typeface="Kartika"/>
-        <a:font script="Laoo" typeface="DokChampa"/>
-        <a:font script="Sinh" typeface="Iskoola Pota"/>
-        <a:font script="Mong" typeface="Mongolian Baiti"/>
-        <a:font script="Viet" typeface="Arial"/>
-        <a:font script="Uigh" typeface="Microsoft Uighur"/>
-        <a:font script="Geor" typeface="Sylfaen"/>
-      </a:minorFont>
-    </a:fontScheme>
-    <a:fmtScheme name="Office">
-      <a:fillStyleLst>
-        <a:solidFill>
-          <a:schemeClr val="phClr"/>
-        </a:solidFill>
-        <a:gradFill rotWithShape="1">
-          <a:gsLst>
-            <a:gs pos="0">
-              <a:schemeClr val="phClr">
-                <a:tint val="50000"/>
-                <a:satMod val="300000"/>
-              </a:schemeClr>
-            </a:gs>
-            <a:gs pos="35000">
-              <a:schemeClr val="phClr">
-                <a:tint val="37000"/>
-                <a:satMod val="300000"/>
-              </a:schemeClr>
-            </a:gs>
-            <a:gs pos="100000">
-              <a:schemeClr val="phClr">
-                <a:tint val="15000"/>
-                <a:satMod val="350000"/>
-              </a:schemeClr>
-            </a:gs>
-          </a:gsLst>
-          <a:lin ang="16200000" scaled="1"/>
-        </a:gradFill>
-        <a:gradFill rotWithShape="1">
-          <a:gsLst>
-            <a:gs pos="0">
-              <a:schemeClr val="phClr">
-                <a:tint val="100000"/>
-                <a:shade val="100000"/>
-                <a:satMod val="130000"/>
-              </a:schemeClr>
-            </a:gs>
-            <a:gs pos="100000">
-              <a:schemeClr val="phClr">
-                <a:tint val="50000"/>
-                <a:shade val="100000"/>
-                <a:satMod val="350000"/>
-              </a:schemeClr>
-            </a:gs>
-          </a:gsLst>
-          <a:lin ang="16200000" scaled="0"/>
-        </a:gradFill>
-      </a:fillStyleLst>
-      <a:lnStyleLst>
-        <a:ln w="9525" cap="flat" cmpd="sng" algn="ctr">
-          <a:solidFill>
-            <a:schemeClr val="phClr">
-              <a:shade val="95000"/>
-              <a:satMod val="105000"/>
-            </a:schemeClr>
-          </a:solidFill>
-          <a:prstDash val="solid"/>
-        </a:ln>
-        <a:ln w="25400" cap="flat" cmpd="sng" algn="ctr">
-          <a:solidFill>
-            <a:schemeClr val="phClr"/>
-          </a:solidFill>
-          <a:prstDash val="solid"/>
-        </a:ln>
-        <a:ln w="38100" cap="flat" cmpd="sng" algn="ctr">
-          <a:solidFill>
-            <a:schemeClr val="phClr"/>
-          </a:solidFill>
-          <a:prstDash val="solid"/>
-        </a:ln>
-      </a:lnStyleLst>
-      <a:effectStyleLst>
-        <a:effectStyle>
-          <a:effectLst>
-            <a:outerShdw blurRad="40000" dist="20000" dir="5400000" rotWithShape="0">
-              <a:srgbClr val="000000">
-                <a:alpha val="38000"/>
-              </a:srgbClr>
-            </a:outerShdw>
-          </a:effectLst>
-        </a:effectStyle>
-        <a:effectStyle>
-          <a:effectLst>
-            <a:outerShdw blurRad="40000" dist="23000" dir="5400000" rotWithShape="0">
-              <a:srgbClr val="000000">
-                <a:alpha val="35000"/>
-              </a:srgbClr>
-            </a:outerShdw>
-          </a:effectLst>
-        </a:effectStyle>
-        <a:effectStyle>
-          <a:effectLst>
-            <a:outerShdw blurRad="40000" dist="23000" dir="5400000" rotWithShape="0">
-              <a:srgbClr val="000000">
-                <a:alpha val="35000"/>
-              </a:srgbClr>
-            </a:outerShdw>
-          </a:effectLst>
-          <a:scene3d>
-            <a:camera prst="orthographicFront">
-              <a:rot lat="0" lon="0" rev="0"/>
-            </a:camera>
-            <a:lightRig rig="threePt" dir="t">
-              <a:rot lat="0" lon="0" rev="1200000"/>
-            </a:lightRig>
-          </a:scene3d>
-          <a:sp3d>
-            <a:bevelT w="63500" h="25400"/>
-          </a:sp3d>
-        </a:effectStyle>
-      </a:effectStyleLst>
-      <a:bgFillStyleLst>
-        <a:solidFill>
-          <a:schemeClr val="phClr"/>
-        </a:solidFill>
-        <a:gradFill rotWithShape="1">
-          <a:gsLst>
-            <a:gs pos="0">
-              <a:schemeClr val="phClr">
-                <a:tint val="40000"/>
-                <a:satMod val="350000"/>
-              </a:schemeClr>
-            </a:gs>
-            <a:gs pos="40000">
-              <a:schemeClr val="phClr">
-                <a:tint val="45000"/>
-                <a:shade val="99000"/>
-                <a:satMod val="350000"/>
-              </a:schemeClr>
-            </a:gs>
-            <a:gs pos="100000">
-              <a:schemeClr val="phClr">
-                <a:shade val="20000"/>
-                <a:satMod val="255000"/>
-              </a:schemeClr>
-            </a:gs>
-          </a:gsLst>
-          <a:path path="circle">
-            <a:fillToRect l="50000" t="-80000" r="50000" b="180000"/>
-          </a:path>
-        </a:gradFill>
-        <a:gradFill rotWithShape="1">
-          <a:gsLst>
-            <a:gs pos="0">
-              <a:schemeClr val="phClr">
-                <a:tint val="80000"/>
-                <a:satMod val="300000"/>
-              </a:schemeClr>
-            </a:gs>
-            <a:gs pos="100000">
-              <a:schemeClr val="phClr">
-                <a:shade val="30000"/>
-                <a:satMod val="200000"/>
-              </a:schemeClr>
-            </a:gs>
-          </a:gsLst>
-          <a:path path="circle">
-            <a:fillToRect l="50000" t="50000" r="50000" b="50000"/>
-          </a:path>
-        </a:gradFill>
-      </a:bgFillStyleLst>
-    </a:fmtScheme>
-  </a:themeElements>
+  <a:objectDefaults/>
+  <a:extraClrSchemeLst/>
 </a:theme>
 </file>
</xml_diff>